<commit_message>
PPTX: corregir formas inválidas que PowerPoint reparaba; fuentes explícitas para Canva
Co-Authored-By: Claude Sonnet 5.5 <noreply@anthropic.com>
Claude-Session: https://claude.ai/code/session_01SZenMW1fww8JkTjePJkRxL
</commit_message>
<xml_diff>
--- a/presentaciones/comite-salud-gs1/Comite-Salud-GS1.pptx
+++ b/presentaciones/comite-salud-gs1/Comite-Salud-GS1.pptx
@@ -2115,9 +2115,9 @@
                 <a:solidFill>
                   <a:schemeClr val="tx2"/>
                 </a:solidFill>
-                <a:latin typeface="+mj-lt" pitchFamily="34" charset="0"/>
-                <a:ea typeface="+mj-lt" pitchFamily="34" charset="-122"/>
-                <a:cs typeface="+mj-lt" pitchFamily="34" charset="-120"/>
+                <a:latin typeface="Arial" pitchFamily="34" charset="0"/>
+                <a:ea typeface="Arial" pitchFamily="34" charset="-122"/>
+                <a:cs typeface="Arial" pitchFamily="34" charset="-120"/>
               </a:defRPr>
             </a:lvl1pPr>
           </a:lstStyle>
@@ -2349,9 +2349,9 @@
                 <a:solidFill>
                   <a:schemeClr val="bg1"/>
                 </a:solidFill>
-                <a:latin typeface="+mj-lt" pitchFamily="34" charset="0"/>
-                <a:ea typeface="+mj-lt" pitchFamily="34" charset="-122"/>
-                <a:cs typeface="+mj-lt" pitchFamily="34" charset="-120"/>
+                <a:latin typeface="Arial" pitchFamily="34" charset="0"/>
+                <a:ea typeface="Arial" pitchFamily="34" charset="-122"/>
+                <a:cs typeface="Arial" pitchFamily="34" charset="-120"/>
               </a:defRPr>
             </a:lvl1pPr>
           </a:lstStyle>
@@ -2867,9 +2867,9 @@
                 <a:solidFill>
                   <a:schemeClr val="tx2"/>
                 </a:solidFill>
-                <a:latin typeface="+mj-lt" pitchFamily="34" charset="0"/>
-                <a:ea typeface="+mj-lt" pitchFamily="34" charset="-122"/>
-                <a:cs typeface="+mj-lt" pitchFamily="34" charset="-120"/>
+                <a:latin typeface="Arial" pitchFamily="34" charset="0"/>
+                <a:ea typeface="Arial" pitchFamily="34" charset="-122"/>
+                <a:cs typeface="Arial" pitchFamily="34" charset="-120"/>
               </a:rPr>
               <a:t>COMITÉ</a:t>
             </a:r>
@@ -2906,9 +2906,9 @@
                 <a:solidFill>
                   <a:schemeClr val="accent1"/>
                 </a:solidFill>
-                <a:latin typeface="+mj-lt" pitchFamily="34" charset="0"/>
-                <a:ea typeface="+mj-lt" pitchFamily="34" charset="-122"/>
-                <a:cs typeface="+mj-lt" pitchFamily="34" charset="-120"/>
+                <a:latin typeface="Arial" pitchFamily="34" charset="0"/>
+                <a:ea typeface="Arial" pitchFamily="34" charset="-122"/>
+                <a:cs typeface="Arial" pitchFamily="34" charset="-120"/>
               </a:rPr>
               <a:t>Salud GS1</a:t>
             </a:r>
@@ -2989,6 +2989,9 @@
                 <a:solidFill>
                   <a:schemeClr val="accent2"/>
                 </a:solidFill>
+                <a:latin typeface="Calibri" pitchFamily="34" charset="0"/>
+                <a:ea typeface="Calibri" pitchFamily="34" charset="-122"/>
+                <a:cs typeface="Calibri" pitchFamily="34" charset="-120"/>
               </a:rPr>
               <a:t>1. </a:t>
             </a:r>
@@ -3000,6 +3003,9 @@
                 <a:solidFill>
                   <a:schemeClr val="tx2"/>
                 </a:solidFill>
+                <a:latin typeface="Calibri" pitchFamily="34" charset="0"/>
+                <a:ea typeface="Calibri" pitchFamily="34" charset="-122"/>
+                <a:cs typeface="Calibri" pitchFamily="34" charset="-120"/>
               </a:rPr>
               <a:t>Rastreo Inteligente: IA Aplicada a la Trazabilidad Médica.</a:t>
             </a:r>
@@ -3080,6 +3086,9 @@
                 <a:solidFill>
                   <a:schemeClr val="accent2"/>
                 </a:solidFill>
+                <a:latin typeface="Calibri" pitchFamily="34" charset="0"/>
+                <a:ea typeface="Calibri" pitchFamily="34" charset="-122"/>
+                <a:cs typeface="Calibri" pitchFamily="34" charset="-120"/>
               </a:rPr>
               <a:t>2. </a:t>
             </a:r>
@@ -3091,6 +3100,9 @@
                 <a:solidFill>
                   <a:schemeClr val="tx2"/>
                 </a:solidFill>
+                <a:latin typeface="Calibri" pitchFamily="34" charset="0"/>
+                <a:ea typeface="Calibri" pitchFamily="34" charset="-122"/>
+                <a:cs typeface="Calibri" pitchFamily="34" charset="-120"/>
               </a:rPr>
               <a:t>Seguridad del paciente, eficiencia de la cadena de suministro y trazabilidad de medicamentos.</a:t>
             </a:r>
@@ -3171,6 +3183,9 @@
                 <a:solidFill>
                   <a:schemeClr val="accent2"/>
                 </a:solidFill>
+                <a:latin typeface="Calibri" pitchFamily="34" charset="0"/>
+                <a:ea typeface="Calibri" pitchFamily="34" charset="-122"/>
+                <a:cs typeface="Calibri" pitchFamily="34" charset="-120"/>
               </a:rPr>
               <a:t>3. </a:t>
             </a:r>
@@ -3182,6 +3197,9 @@
                 <a:solidFill>
                   <a:schemeClr val="tx2"/>
                 </a:solidFill>
+                <a:latin typeface="Calibri" pitchFamily="34" charset="0"/>
+                <a:ea typeface="Calibri" pitchFamily="34" charset="-122"/>
+                <a:cs typeface="Calibri" pitchFamily="34" charset="-120"/>
               </a:rPr>
               <a:t>Casos de Éxito Internacionales y Contexto Venezolano.</a:t>
             </a:r>
@@ -3262,6 +3280,9 @@
                 <a:solidFill>
                   <a:schemeClr val="accent2"/>
                 </a:solidFill>
+                <a:latin typeface="Calibri" pitchFamily="34" charset="0"/>
+                <a:ea typeface="Calibri" pitchFamily="34" charset="-122"/>
+                <a:cs typeface="Calibri" pitchFamily="34" charset="-120"/>
               </a:rPr>
               <a:t>4. </a:t>
             </a:r>
@@ -3273,6 +3294,9 @@
                 <a:solidFill>
                   <a:schemeClr val="tx2"/>
                 </a:solidFill>
+                <a:latin typeface="Calibri" pitchFamily="34" charset="0"/>
+                <a:ea typeface="Calibri" pitchFamily="34" charset="-122"/>
+                <a:cs typeface="Calibri" pitchFamily="34" charset="-120"/>
               </a:rPr>
               <a:t>GS1 News &amp; Ronda Abierta.</a:t>
             </a:r>
@@ -3367,9 +3391,9 @@
                 <a:solidFill>
                   <a:schemeClr val="bg1"/>
                 </a:solidFill>
-                <a:latin typeface="+mj-lt" pitchFamily="34" charset="0"/>
-                <a:ea typeface="+mj-lt" pitchFamily="34" charset="-122"/>
-                <a:cs typeface="+mj-lt" pitchFamily="34" charset="-120"/>
+                <a:latin typeface="Arial" pitchFamily="34" charset="0"/>
+                <a:ea typeface="Arial" pitchFamily="34" charset="-122"/>
+                <a:cs typeface="Arial" pitchFamily="34" charset="-120"/>
               </a:rPr>
               <a:t>5 Noviembre, 2026</a:t>
             </a:r>
@@ -3430,6 +3454,9 @@
                 <a:solidFill>
                   <a:schemeClr val="bg1"/>
                 </a:solidFill>
+                <a:latin typeface="Calibri" pitchFamily="34" charset="0"/>
+                <a:ea typeface="Calibri" pitchFamily="34" charset="-122"/>
+                <a:cs typeface="Calibri" pitchFamily="34" charset="-120"/>
               </a:rPr>
               <a:t>8:30 am – 10:00 am</a:t>
             </a:r>
@@ -3515,6 +3542,9 @@
                 <a:solidFill>
                   <a:schemeClr val="bg1"/>
                 </a:solidFill>
+                <a:latin typeface="Calibri" pitchFamily="34" charset="0"/>
+                <a:ea typeface="Calibri" pitchFamily="34" charset="-122"/>
+                <a:cs typeface="Calibri" pitchFamily="34" charset="-120"/>
               </a:rPr>
               <a:t>Oficina GS1 Venezuela. </a:t>
             </a:r>
@@ -3526,6 +3556,9 @@
                 <a:solidFill>
                   <a:schemeClr val="bg1"/>
                 </a:solidFill>
+                <a:latin typeface="Calibri" pitchFamily="34" charset="0"/>
+                <a:ea typeface="Calibri" pitchFamily="34" charset="-122"/>
+                <a:cs typeface="Calibri" pitchFamily="34" charset="-120"/>
               </a:rPr>
               <a:t>Los Ruices, Calle Los Laboratorios, Edf. Quorum, Piso 1, Oficina K (Caracas).</a:t>
             </a:r>
@@ -3642,6 +3675,9 @@
                 <a:solidFill>
                   <a:schemeClr val="accent1"/>
                 </a:solidFill>
+                <a:latin typeface="Calibri" pitchFamily="34" charset="0"/>
+                <a:ea typeface="Calibri" pitchFamily="34" charset="-122"/>
+                <a:cs typeface="Calibri" pitchFamily="34" charset="-120"/>
               </a:rPr>
               <a:t>+</a:t>
             </a:r>
@@ -3746,6 +3782,9 @@
                 <a:solidFill>
                   <a:schemeClr val="bg1"/>
                 </a:solidFill>
+                <a:latin typeface="Calibri" pitchFamily="34" charset="0"/>
+                <a:ea typeface="Calibri" pitchFamily="34" charset="-122"/>
+                <a:cs typeface="Calibri" pitchFamily="34" charset="-120"/>
               </a:rPr>
               <a:t>+58 414 2771877</a:t>
             </a:r>
@@ -3806,6 +3845,9 @@
                 <a:solidFill>
                   <a:schemeClr val="bg1"/>
                 </a:solidFill>
+                <a:latin typeface="Calibri" pitchFamily="34" charset="0"/>
+                <a:ea typeface="Calibri" pitchFamily="34" charset="-122"/>
+                <a:cs typeface="Calibri" pitchFamily="34" charset="-120"/>
               </a:rPr>
               <a:t>www.gs1ve.org</a:t>
             </a:r>
@@ -3867,6 +3909,9 @@
                 <a:solidFill>
                   <a:schemeClr val="accent2"/>
                 </a:solidFill>
+                <a:latin typeface="Calibri" pitchFamily="34" charset="0"/>
+                <a:ea typeface="Calibri" pitchFamily="34" charset="-122"/>
+                <a:cs typeface="Calibri" pitchFamily="34" charset="-120"/>
               </a:rPr>
               <a:t>AGENDA · PUNTO 3 · GS1 NEWS</a:t>
             </a:r>
@@ -3905,9 +3950,9 @@
                 <a:solidFill>
                   <a:schemeClr val="tx2"/>
                 </a:solidFill>
-                <a:latin typeface="+mj-lt" pitchFamily="34" charset="0"/>
-                <a:ea typeface="+mj-lt" pitchFamily="34" charset="-122"/>
-                <a:cs typeface="+mj-lt" pitchFamily="34" charset="-120"/>
+                <a:latin typeface="Arial" pitchFamily="34" charset="0"/>
+                <a:ea typeface="Arial" pitchFamily="34" charset="-122"/>
+                <a:cs typeface="Arial" pitchFamily="34" charset="-120"/>
               </a:rPr>
               <a:t>Novedades globales y </a:t>
             </a:r>
@@ -3919,9 +3964,9 @@
                 <a:solidFill>
                   <a:schemeClr val="accent1"/>
                 </a:solidFill>
-                <a:latin typeface="+mj-lt" pitchFamily="34" charset="0"/>
-                <a:ea typeface="+mj-lt" pitchFamily="34" charset="-122"/>
-                <a:cs typeface="+mj-lt" pitchFamily="34" charset="-120"/>
+                <a:latin typeface="Arial" pitchFamily="34" charset="0"/>
+                <a:ea typeface="Arial" pitchFamily="34" charset="-122"/>
+                <a:cs typeface="Arial" pitchFamily="34" charset="-120"/>
               </a:rPr>
               <a:t>hoja de ruta 2026–2027</a:t>
             </a:r>
@@ -4060,9 +4105,9 @@
                 <a:solidFill>
                   <a:schemeClr val="tx2"/>
                 </a:solidFill>
-                <a:latin typeface="+mj-lt" pitchFamily="34" charset="0"/>
-                <a:ea typeface="+mj-lt" pitchFamily="34" charset="-122"/>
-                <a:cs typeface="+mj-lt" pitchFamily="34" charset="-120"/>
+                <a:latin typeface="Arial" pitchFamily="34" charset="0"/>
+                <a:ea typeface="Arial" pitchFamily="34" charset="-122"/>
+                <a:cs typeface="Arial" pitchFamily="34" charset="-120"/>
               </a:rPr>
               <a:t>Rumbo a GS1 Sunrise 2027</a:t>
             </a:r>
@@ -4099,9 +4144,9 @@
                 <a:solidFill>
                   <a:schemeClr val="accent1"/>
                 </a:solidFill>
-                <a:latin typeface="+mj-lt" pitchFamily="34" charset="0"/>
-                <a:ea typeface="+mj-lt" pitchFamily="34" charset="-122"/>
-                <a:cs typeface="+mj-lt" pitchFamily="34" charset="-120"/>
+                <a:latin typeface="Arial" pitchFamily="34" charset="0"/>
+                <a:ea typeface="Arial" pitchFamily="34" charset="-122"/>
+                <a:cs typeface="Arial" pitchFamily="34" charset="-120"/>
               </a:rPr>
               <a:t>2027</a:t>
             </a:r>
@@ -4138,6 +4183,9 @@
                 <a:solidFill>
                   <a:srgbClr val="475569"/>
                 </a:solidFill>
+                <a:latin typeface="Calibri" pitchFamily="34" charset="0"/>
+                <a:ea typeface="Calibri" pitchFamily="34" charset="-122"/>
+                <a:cs typeface="Calibri" pitchFamily="34" charset="-120"/>
               </a:rPr>
               <a:t>año meta de GS1 Sunrise (pilotos en 48 países / 88% del PIB mundial)</a:t>
             </a:r>
@@ -4174,6 +4222,9 @@
                 <a:solidFill>
                   <a:srgbClr val="475569"/>
                 </a:solidFill>
+                <a:latin typeface="Calibri" pitchFamily="34" charset="0"/>
+                <a:ea typeface="Calibri" pitchFamily="34" charset="-122"/>
+                <a:cs typeface="Calibri" pitchFamily="34" charset="-120"/>
               </a:rPr>
               <a:t>Puntos de venta y farmacias avanzan hacia la lectura nativa de códigos 2D.</a:t>
             </a:r>
@@ -4288,9 +4339,9 @@
                 <a:solidFill>
                   <a:schemeClr val="tx2"/>
                 </a:solidFill>
-                <a:latin typeface="+mj-lt" pitchFamily="34" charset="0"/>
-                <a:ea typeface="+mj-lt" pitchFamily="34" charset="-122"/>
-                <a:cs typeface="+mj-lt" pitchFamily="34" charset="-120"/>
+                <a:latin typeface="Arial" pitchFamily="34" charset="0"/>
+                <a:ea typeface="Arial" pitchFamily="34" charset="-122"/>
+                <a:cs typeface="Arial" pitchFamily="34" charset="-120"/>
               </a:rPr>
               <a:t>Plataforma GS1 Digital Link Latam</a:t>
             </a:r>
@@ -4327,6 +4378,9 @@
                 <a:solidFill>
                   <a:schemeClr val="tx1"/>
                 </a:solidFill>
+                <a:latin typeface="Calibri" pitchFamily="34" charset="0"/>
+                <a:ea typeface="Calibri" pitchFamily="34" charset="-122"/>
+                <a:cs typeface="Calibri" pitchFamily="34" charset="-120"/>
               </a:rPr>
               <a:t>Disponible para afiliados de GS1 Venezuela en </a:t>
             </a:r>
@@ -4338,6 +4392,9 @@
                 <a:solidFill>
                   <a:schemeClr val="accent6"/>
                 </a:solidFill>
+                <a:latin typeface="Calibri" pitchFamily="34" charset="0"/>
+                <a:ea typeface="Calibri" pitchFamily="34" charset="-122"/>
+                <a:cs typeface="Calibri" pitchFamily="34" charset="-120"/>
               </a:rPr>
               <a:t>app.gs1digitallink.lat</a:t>
             </a:r>
@@ -4349,6 +4406,9 @@
                 <a:solidFill>
                   <a:schemeClr val="tx1"/>
                 </a:solidFill>
+                <a:latin typeface="Calibri" pitchFamily="34" charset="0"/>
+                <a:ea typeface="Calibri" pitchFamily="34" charset="-122"/>
+                <a:cs typeface="Calibri" pitchFamily="34" charset="-120"/>
               </a:rPr>
               <a:t>. Exportación de arte tanto para QR Digital Link como GS1 DataMatrix:</a:t>
             </a:r>
@@ -4707,9 +4767,9 @@
                 <a:solidFill>
                   <a:schemeClr val="tx2"/>
                 </a:solidFill>
-                <a:latin typeface="+mj-lt" pitchFamily="34" charset="0"/>
-                <a:ea typeface="+mj-lt" pitchFamily="34" charset="-122"/>
-                <a:cs typeface="+mj-lt" pitchFamily="34" charset="-120"/>
+                <a:latin typeface="Arial" pitchFamily="34" charset="0"/>
+                <a:ea typeface="Arial" pitchFamily="34" charset="-122"/>
+                <a:cs typeface="Arial" pitchFamily="34" charset="-120"/>
               </a:rPr>
               <a:t>EPCIS 2.0 e interoperabilidad con IA</a:t>
             </a:r>
@@ -4746,6 +4806,9 @@
                 <a:solidFill>
                   <a:srgbClr val="475569"/>
                 </a:solidFill>
+                <a:latin typeface="Calibri" pitchFamily="34" charset="0"/>
+                <a:ea typeface="Calibri" pitchFamily="34" charset="-122"/>
+                <a:cs typeface="Calibri" pitchFamily="34" charset="-120"/>
               </a:rPr>
               <a:t>Nuevo estándar global para compartir eventos de visibilidad en cadenas de suministro de salud con máxima ciberseguridad.</a:t>
             </a:r>
@@ -4860,9 +4923,9 @@
                 <a:solidFill>
                   <a:schemeClr val="tx2"/>
                 </a:solidFill>
-                <a:latin typeface="+mj-lt" pitchFamily="34" charset="0"/>
-                <a:ea typeface="+mj-lt" pitchFamily="34" charset="-122"/>
-                <a:cs typeface="+mj-lt" pitchFamily="34" charset="-120"/>
+                <a:latin typeface="Arial" pitchFamily="34" charset="0"/>
+                <a:ea typeface="Arial" pitchFamily="34" charset="-122"/>
+                <a:cs typeface="Arial" pitchFamily="34" charset="-120"/>
               </a:rPr>
               <a:t>Formación y acompañamiento técnico</a:t>
             </a:r>
@@ -4899,6 +4962,9 @@
                 <a:solidFill>
                   <a:srgbClr val="475569"/>
                 </a:solidFill>
+                <a:latin typeface="Calibri" pitchFamily="34" charset="0"/>
+                <a:ea typeface="Calibri" pitchFamily="34" charset="-122"/>
+                <a:cs typeface="Calibri" pitchFamily="34" charset="-120"/>
               </a:rPr>
               <a:t>Consultoría del Departamento de Estándares de GS1 Venezuela para adecuar líneas de empaque, asignación de GLN/GTIN y catalogación.</a:t>
             </a:r>
@@ -5005,6 +5071,9 @@
                 <a:solidFill>
                   <a:schemeClr val="accent2"/>
                 </a:solidFill>
+                <a:latin typeface="Calibri" pitchFamily="34" charset="0"/>
+                <a:ea typeface="Calibri" pitchFamily="34" charset="-122"/>
+                <a:cs typeface="Calibri" pitchFamily="34" charset="-120"/>
               </a:rPr>
               <a:t>AGENDA · PUNTO 4 · MESA DE TRABAJO DEL COMITÉ</a:t>
             </a:r>
@@ -5043,9 +5112,9 @@
                 <a:solidFill>
                   <a:schemeClr val="tx2"/>
                 </a:solidFill>
-                <a:latin typeface="+mj-lt" pitchFamily="34" charset="0"/>
-                <a:ea typeface="+mj-lt" pitchFamily="34" charset="-122"/>
-                <a:cs typeface="+mj-lt" pitchFamily="34" charset="-120"/>
+                <a:latin typeface="Arial" pitchFamily="34" charset="0"/>
+                <a:ea typeface="Arial" pitchFamily="34" charset="-122"/>
+                <a:cs typeface="Arial" pitchFamily="34" charset="-120"/>
               </a:rPr>
               <a:t>Ronda </a:t>
             </a:r>
@@ -5057,9 +5126,9 @@
                 <a:solidFill>
                   <a:schemeClr val="accent1"/>
                 </a:solidFill>
-                <a:latin typeface="+mj-lt" pitchFamily="34" charset="0"/>
-                <a:ea typeface="+mj-lt" pitchFamily="34" charset="-122"/>
-                <a:cs typeface="+mj-lt" pitchFamily="34" charset="-120"/>
+                <a:latin typeface="Arial" pitchFamily="34" charset="0"/>
+                <a:ea typeface="Arial" pitchFamily="34" charset="-122"/>
+                <a:cs typeface="Arial" pitchFamily="34" charset="-120"/>
               </a:rPr>
               <a:t>Abierta</a:t>
             </a:r>
@@ -5154,6 +5223,9 @@
                 <a:solidFill>
                   <a:schemeClr val="bg1"/>
                 </a:solidFill>
+                <a:latin typeface="Calibri" pitchFamily="34" charset="0"/>
+                <a:ea typeface="Calibri" pitchFamily="34" charset="-122"/>
+                <a:cs typeface="Calibri" pitchFamily="34" charset="-120"/>
               </a:rPr>
               <a:t>Insertar foto: mesa de trabajo del comité</a:t>
             </a:r>
@@ -5174,7 +5246,7 @@
           </a:xfrm>
           <a:prstGeom prst="roundRect">
             <a:avLst>
-              <a:gd name="adj" fmla="val 141176"/>
+              <a:gd name="adj" fmla="val 50000"/>
             </a:avLst>
           </a:prstGeom>
           <a:solidFill>
@@ -5212,6 +5284,9 @@
                 <a:solidFill>
                   <a:schemeClr val="bg1"/>
                 </a:solidFill>
+                <a:latin typeface="Calibri" pitchFamily="34" charset="0"/>
+                <a:ea typeface="Calibri" pitchFamily="34" charset="-122"/>
+                <a:cs typeface="Calibri" pitchFamily="34" charset="-120"/>
               </a:rPr>
               <a:t>Comité Salud GS1 · 5 Nov 2026</a:t>
             </a:r>
@@ -5302,9 +5377,9 @@
                 <a:solidFill>
                   <a:schemeClr val="bg1"/>
                 </a:solidFill>
-                <a:latin typeface="+mj-lt" pitchFamily="34" charset="0"/>
-                <a:ea typeface="+mj-lt" pitchFamily="34" charset="-122"/>
-                <a:cs typeface="+mj-lt" pitchFamily="34" charset="-120"/>
+                <a:latin typeface="Arial" pitchFamily="34" charset="0"/>
+                <a:ea typeface="Arial" pitchFamily="34" charset="-122"/>
+                <a:cs typeface="Arial" pitchFamily="34" charset="-120"/>
               </a:rPr>
               <a:t>1</a:t>
             </a:r>
@@ -5341,9 +5416,9 @@
                 <a:solidFill>
                   <a:schemeClr val="tx2"/>
                 </a:solidFill>
-                <a:latin typeface="+mj-lt" pitchFamily="34" charset="0"/>
-                <a:ea typeface="+mj-lt" pitchFamily="34" charset="-122"/>
-                <a:cs typeface="+mj-lt" pitchFamily="34" charset="-120"/>
+                <a:latin typeface="Arial" pitchFamily="34" charset="0"/>
+                <a:ea typeface="Arial" pitchFamily="34" charset="-122"/>
+                <a:cs typeface="Arial" pitchFamily="34" charset="-120"/>
               </a:rPr>
               <a:t>Retos en empaque primario y secundario</a:t>
             </a:r>
@@ -5380,6 +5455,9 @@
                 <a:solidFill>
                   <a:srgbClr val="475569"/>
                 </a:solidFill>
+                <a:latin typeface="Calibri" pitchFamily="34" charset="0"/>
+                <a:ea typeface="Calibri" pitchFamily="34" charset="-122"/>
+                <a:cs typeface="Calibri" pitchFamily="34" charset="-120"/>
               </a:rPr>
               <a:t>Líneas de impresión para códigos 2D variables (lote / vencimiento).</a:t>
             </a:r>
@@ -5470,9 +5548,9 @@
                 <a:solidFill>
                   <a:schemeClr val="bg1"/>
                 </a:solidFill>
-                <a:latin typeface="+mj-lt" pitchFamily="34" charset="0"/>
-                <a:ea typeface="+mj-lt" pitchFamily="34" charset="-122"/>
-                <a:cs typeface="+mj-lt" pitchFamily="34" charset="-120"/>
+                <a:latin typeface="Arial" pitchFamily="34" charset="0"/>
+                <a:ea typeface="Arial" pitchFamily="34" charset="-122"/>
+                <a:cs typeface="Arial" pitchFamily="34" charset="-120"/>
               </a:rPr>
               <a:t>2</a:t>
             </a:r>
@@ -5509,9 +5587,9 @@
                 <a:solidFill>
                   <a:schemeClr val="tx2"/>
                 </a:solidFill>
-                <a:latin typeface="+mj-lt" pitchFamily="34" charset="0"/>
-                <a:ea typeface="+mj-lt" pitchFamily="34" charset="-122"/>
-                <a:cs typeface="+mj-lt" pitchFamily="34" charset="-120"/>
+                <a:latin typeface="Arial" pitchFamily="34" charset="0"/>
+                <a:ea typeface="Arial" pitchFamily="34" charset="-122"/>
+                <a:cs typeface="Arial" pitchFamily="34" charset="-120"/>
               </a:rPr>
               <a:t>Integración con farmacias y clínicas</a:t>
             </a:r>
@@ -5548,6 +5626,9 @@
                 <a:solidFill>
                   <a:srgbClr val="475569"/>
                 </a:solidFill>
+                <a:latin typeface="Calibri" pitchFamily="34" charset="0"/>
+                <a:ea typeface="Calibri" pitchFamily="34" charset="-122"/>
+                <a:cs typeface="Calibri" pitchFamily="34" charset="-120"/>
               </a:rPr>
               <a:t>Homologación de lectores ópticos 2D y sistemas ERP / HIS en Venezuela.</a:t>
             </a:r>
@@ -5638,9 +5719,9 @@
                 <a:solidFill>
                   <a:schemeClr val="bg1"/>
                 </a:solidFill>
-                <a:latin typeface="+mj-lt" pitchFamily="34" charset="0"/>
-                <a:ea typeface="+mj-lt" pitchFamily="34" charset="-122"/>
-                <a:cs typeface="+mj-lt" pitchFamily="34" charset="-120"/>
+                <a:latin typeface="Arial" pitchFamily="34" charset="0"/>
+                <a:ea typeface="Arial" pitchFamily="34" charset="-122"/>
+                <a:cs typeface="Arial" pitchFamily="34" charset="-120"/>
               </a:rPr>
               <a:t>3</a:t>
             </a:r>
@@ -5677,9 +5758,9 @@
                 <a:solidFill>
                   <a:schemeClr val="tx2"/>
                 </a:solidFill>
-                <a:latin typeface="+mj-lt" pitchFamily="34" charset="0"/>
-                <a:ea typeface="+mj-lt" pitchFamily="34" charset="-122"/>
-                <a:cs typeface="+mj-lt" pitchFamily="34" charset="-120"/>
+                <a:latin typeface="Arial" pitchFamily="34" charset="0"/>
+                <a:ea typeface="Arial" pitchFamily="34" charset="-122"/>
+                <a:cs typeface="Arial" pitchFamily="34" charset="-120"/>
               </a:rPr>
               <a:t>Educación al médico y al paciente</a:t>
             </a:r>
@@ -5716,6 +5797,9 @@
                 <a:solidFill>
                   <a:srgbClr val="475569"/>
                 </a:solidFill>
+                <a:latin typeface="Calibri" pitchFamily="34" charset="0"/>
+                <a:ea typeface="Calibri" pitchFamily="34" charset="-122"/>
+                <a:cs typeface="Calibri" pitchFamily="34" charset="-120"/>
               </a:rPr>
               <a:t>Estrategias conjuntas para impulsar el escaneo de autenticidad y prospecto digital.</a:t>
             </a:r>
@@ -5806,9 +5890,9 @@
                 <a:solidFill>
                   <a:schemeClr val="bg1"/>
                 </a:solidFill>
-                <a:latin typeface="+mj-lt" pitchFamily="34" charset="0"/>
-                <a:ea typeface="+mj-lt" pitchFamily="34" charset="-122"/>
-                <a:cs typeface="+mj-lt" pitchFamily="34" charset="-120"/>
+                <a:latin typeface="Arial" pitchFamily="34" charset="0"/>
+                <a:ea typeface="Arial" pitchFamily="34" charset="-122"/>
+                <a:cs typeface="Arial" pitchFamily="34" charset="-120"/>
               </a:rPr>
               <a:t>4</a:t>
             </a:r>
@@ -5845,9 +5929,9 @@
                 <a:solidFill>
                   <a:schemeClr val="tx2"/>
                 </a:solidFill>
-                <a:latin typeface="+mj-lt" pitchFamily="34" charset="0"/>
-                <a:ea typeface="+mj-lt" pitchFamily="34" charset="-122"/>
-                <a:cs typeface="+mj-lt" pitchFamily="34" charset="-120"/>
+                <a:latin typeface="Arial" pitchFamily="34" charset="0"/>
+                <a:ea typeface="Arial" pitchFamily="34" charset="-122"/>
+                <a:cs typeface="Arial" pitchFamily="34" charset="-120"/>
               </a:rPr>
               <a:t>Próximos pilotos 2026–2027</a:t>
             </a:r>
@@ -5884,6 +5968,9 @@
                 <a:solidFill>
                   <a:srgbClr val="475569"/>
                 </a:solidFill>
+                <a:latin typeface="Calibri" pitchFamily="34" charset="0"/>
+                <a:ea typeface="Calibri" pitchFamily="34" charset="-122"/>
+                <a:cs typeface="Calibri" pitchFamily="34" charset="-120"/>
               </a:rPr>
               <a:t>Definición de las mesas técnicas de trabajo del Comité Salud.</a:t>
             </a:r>
@@ -6038,9 +6125,9 @@
                 <a:solidFill>
                   <a:schemeClr val="tx2"/>
                 </a:solidFill>
-                <a:latin typeface="+mj-lt" pitchFamily="34" charset="0"/>
-                <a:ea typeface="+mj-lt" pitchFamily="34" charset="-122"/>
-                <a:cs typeface="+mj-lt" pitchFamily="34" charset="-120"/>
+                <a:latin typeface="Arial" pitchFamily="34" charset="0"/>
+                <a:ea typeface="Arial" pitchFamily="34" charset="-122"/>
+                <a:cs typeface="Arial" pitchFamily="34" charset="-120"/>
               </a:rPr>
               <a:t>Únete al </a:t>
             </a:r>
@@ -6052,9 +6139,9 @@
                 <a:solidFill>
                   <a:schemeClr val="accent1"/>
                 </a:solidFill>
-                <a:latin typeface="+mj-lt" pitchFamily="34" charset="0"/>
-                <a:ea typeface="+mj-lt" pitchFamily="34" charset="-122"/>
-                <a:cs typeface="+mj-lt" pitchFamily="34" charset="-120"/>
+                <a:latin typeface="Arial" pitchFamily="34" charset="0"/>
+                <a:ea typeface="Arial" pitchFamily="34" charset="-122"/>
+                <a:cs typeface="Arial" pitchFamily="34" charset="-120"/>
               </a:rPr>
               <a:t>Comité Salud GS1</a:t>
             </a:r>
@@ -6091,6 +6178,9 @@
                 <a:solidFill>
                   <a:srgbClr val="475569"/>
                 </a:solidFill>
+                <a:latin typeface="Calibri" pitchFamily="34" charset="0"/>
+                <a:ea typeface="Calibri" pitchFamily="34" charset="-122"/>
+                <a:cs typeface="Calibri" pitchFamily="34" charset="-120"/>
               </a:rPr>
               <a:t>Solicita tu acceso a la plataforma Digital Link.</a:t>
             </a:r>
@@ -6369,6 +6459,9 @@
                 <a:solidFill>
                   <a:schemeClr val="accent2"/>
                 </a:solidFill>
+                <a:latin typeface="Calibri" pitchFamily="34" charset="0"/>
+                <a:ea typeface="Calibri" pitchFamily="34" charset="-122"/>
+                <a:cs typeface="Calibri" pitchFamily="34" charset="-120"/>
               </a:rPr>
               <a:t>ESCANEA · SOLICITA ACCESO</a:t>
             </a:r>
@@ -6463,6 +6556,9 @@
                 <a:solidFill>
                   <a:schemeClr val="tx1"/>
                 </a:solidFill>
+                <a:latin typeface="Calibri" pitchFamily="34" charset="0"/>
+                <a:ea typeface="Calibri" pitchFamily="34" charset="-122"/>
+                <a:cs typeface="Calibri" pitchFamily="34" charset="-120"/>
               </a:rPr>
               <a:t>Oficina GS1 Venezuela. </a:t>
             </a:r>
@@ -6474,6 +6570,9 @@
                 <a:solidFill>
                   <a:schemeClr val="tx1"/>
                 </a:solidFill>
+                <a:latin typeface="Calibri" pitchFamily="34" charset="0"/>
+                <a:ea typeface="Calibri" pitchFamily="34" charset="-122"/>
+                <a:cs typeface="Calibri" pitchFamily="34" charset="-120"/>
               </a:rPr>
               <a:t>Los Ruices, Calle Los Laboratorios, Edf. Quorum, Piso 1, Oficina K, Caracas, Venezuela.</a:t>
             </a:r>
@@ -6494,7 +6593,7 @@
           </a:xfrm>
           <a:prstGeom prst="roundRect">
             <a:avLst>
-              <a:gd name="adj" fmla="val 65455"/>
+              <a:gd name="adj" fmla="val 50000"/>
             </a:avLst>
           </a:prstGeom>
           <a:solidFill>
@@ -6705,7 +6804,7 @@
           </a:xfrm>
           <a:prstGeom prst="roundRect">
             <a:avLst>
-              <a:gd name="adj" fmla="val 65455"/>
+              <a:gd name="adj" fmla="val 50000"/>
             </a:avLst>
           </a:prstGeom>
           <a:solidFill>
@@ -6779,6 +6878,9 @@
                 <a:solidFill>
                   <a:schemeClr val="tx1"/>
                 </a:solidFill>
+                <a:latin typeface="Calibri" pitchFamily="34" charset="0"/>
+                <a:ea typeface="Calibri" pitchFamily="34" charset="-122"/>
+                <a:cs typeface="Calibri" pitchFamily="34" charset="-120"/>
               </a:rPr>
               <a:t>www.gs1ve.org  ·  Instagram @GS1Venezuela  ·  RIF J-00336360-0</a:t>
             </a:r>
@@ -6815,9 +6917,9 @@
                 <a:solidFill>
                   <a:schemeClr val="tx2"/>
                 </a:solidFill>
-                <a:latin typeface="+mj-lt" pitchFamily="34" charset="0"/>
-                <a:ea typeface="+mj-lt" pitchFamily="34" charset="-122"/>
-                <a:cs typeface="+mj-lt" pitchFamily="34" charset="-120"/>
+                <a:latin typeface="Arial" pitchFamily="34" charset="0"/>
+                <a:ea typeface="Arial" pitchFamily="34" charset="-122"/>
+                <a:cs typeface="Arial" pitchFamily="34" charset="-120"/>
               </a:rPr>
               <a:t>Datos estándar, </a:t>
             </a:r>
@@ -6829,9 +6931,9 @@
                 <a:solidFill>
                   <a:schemeClr val="accent2"/>
                 </a:solidFill>
-                <a:latin typeface="+mj-lt" pitchFamily="34" charset="0"/>
-                <a:ea typeface="+mj-lt" pitchFamily="34" charset="-122"/>
-                <a:cs typeface="+mj-lt" pitchFamily="34" charset="-120"/>
+                <a:latin typeface="Arial" pitchFamily="34" charset="0"/>
+                <a:ea typeface="Arial" pitchFamily="34" charset="-122"/>
+                <a:cs typeface="Arial" pitchFamily="34" charset="-120"/>
               </a:rPr>
               <a:t>decisiones seguras.</a:t>
             </a:r>
@@ -6893,6 +6995,9 @@
                 <a:solidFill>
                   <a:schemeClr val="accent2"/>
                 </a:solidFill>
+                <a:latin typeface="Calibri" pitchFamily="34" charset="0"/>
+                <a:ea typeface="Calibri" pitchFamily="34" charset="-122"/>
+                <a:cs typeface="Calibri" pitchFamily="34" charset="-120"/>
               </a:rPr>
               <a:t>COMITÉ SALUD GS1 · 5 NOVIEMBRE 2026</a:t>
             </a:r>
@@ -6931,9 +7036,9 @@
                 <a:solidFill>
                   <a:schemeClr val="tx2"/>
                 </a:solidFill>
-                <a:latin typeface="+mj-lt" pitchFamily="34" charset="0"/>
-                <a:ea typeface="+mj-lt" pitchFamily="34" charset="-122"/>
-                <a:cs typeface="+mj-lt" pitchFamily="34" charset="-120"/>
+                <a:latin typeface="Arial" pitchFamily="34" charset="0"/>
+                <a:ea typeface="Arial" pitchFamily="34" charset="-122"/>
+                <a:cs typeface="Arial" pitchFamily="34" charset="-120"/>
               </a:rPr>
               <a:t>Agenda </a:t>
             </a:r>
@@ -6945,9 +7050,9 @@
                 <a:solidFill>
                   <a:schemeClr val="accent1"/>
                 </a:solidFill>
-                <a:latin typeface="+mj-lt" pitchFamily="34" charset="0"/>
-                <a:ea typeface="+mj-lt" pitchFamily="34" charset="-122"/>
-                <a:cs typeface="+mj-lt" pitchFamily="34" charset="-120"/>
+                <a:latin typeface="Arial" pitchFamily="34" charset="0"/>
+                <a:ea typeface="Arial" pitchFamily="34" charset="-122"/>
+                <a:cs typeface="Arial" pitchFamily="34" charset="-120"/>
               </a:rPr>
               <a:t>de hoy</a:t>
             </a:r>
@@ -7000,9 +7105,9 @@
             <a:off x="590550" y="1285875"/>
             <a:ext cx="2400300" cy="76200"/>
           </a:xfrm>
-          <a:prstGeom prst="round2SameRect">
+          <a:prstGeom prst="roundRect">
             <a:avLst>
-              <a:gd name="adj" fmla="val 600000"/>
+              <a:gd name="adj" fmla="val 50000"/>
             </a:avLst>
           </a:prstGeom>
           <a:solidFill>
@@ -7013,7 +7118,27 @@
       </p:sp>
       <p:sp>
         <p:nvSpPr>
-          <p:cNvPr id="6" name="Insignia 1"/>
+          <p:cNvPr id="6" name="Barra de color (base)"/>
+          <p:cNvSpPr/>
+          <p:nvPr/>
+        </p:nvSpPr>
+        <p:spPr>
+          <a:xfrm>
+            <a:off x="590550" y="1323975"/>
+            <a:ext cx="2400300" cy="38100"/>
+          </a:xfrm>
+          <a:prstGeom prst="rect">
+            <a:avLst/>
+          </a:prstGeom>
+          <a:solidFill>
+            <a:schemeClr val="tx2"/>
+          </a:solidFill>
+          <a:ln/>
+        </p:spPr>
+      </p:sp>
+      <p:sp>
+        <p:nvSpPr>
+          <p:cNvPr id="7" name="Insignia 1"/>
           <p:cNvSpPr/>
           <p:nvPr/>
         </p:nvSpPr>
@@ -7033,7 +7158,7 @@
       </p:sp>
       <p:sp>
         <p:nvSpPr>
-          <p:cNvPr id="7" name="Text 5"/>
+          <p:cNvPr id="8" name="Text 6"/>
           <p:cNvSpPr txBox="1"/>
           <p:nvPr/>
         </p:nvSpPr>
@@ -7060,9 +7185,9 @@
                 <a:solidFill>
                   <a:schemeClr val="bg1"/>
                 </a:solidFill>
-                <a:latin typeface="+mj-lt" pitchFamily="34" charset="0"/>
-                <a:ea typeface="+mj-lt" pitchFamily="34" charset="-122"/>
-                <a:cs typeface="+mj-lt" pitchFamily="34" charset="-120"/>
+                <a:latin typeface="Arial" pitchFamily="34" charset="0"/>
+                <a:ea typeface="Arial" pitchFamily="34" charset="-122"/>
+                <a:cs typeface="Arial" pitchFamily="34" charset="-120"/>
               </a:rPr>
               <a:t>1</a:t>
             </a:r>
@@ -7072,7 +7197,7 @@
       </p:sp>
       <p:sp>
         <p:nvSpPr>
-          <p:cNvPr id="8" name="Icono BrainCircuit"/>
+          <p:cNvPr id="9" name="Icono BrainCircuit"/>
           <p:cNvSpPr/>
           <p:nvPr/>
         </p:nvSpPr>
@@ -7092,7 +7217,7 @@
       </p:sp>
       <p:pic>
         <p:nvPicPr>
-          <p:cNvPr id="9" name="Image 0" descr="Icono BrainCircuit">    </p:cNvPr>
+          <p:cNvPr id="10" name="Image 0" descr="Icono BrainCircuit">    </p:cNvPr>
           <p:cNvPicPr>
             <a:picLocks noChangeAspect="1"/>
           </p:cNvPicPr>
@@ -7116,7 +7241,7 @@
       </p:pic>
       <p:sp>
         <p:nvSpPr>
-          <p:cNvPr id="10" name="Text 7"/>
+          <p:cNvPr id="11" name="Text 8"/>
           <p:cNvSpPr txBox="1"/>
           <p:nvPr/>
         </p:nvSpPr>
@@ -7143,9 +7268,9 @@
                 <a:solidFill>
                   <a:schemeClr val="tx2"/>
                 </a:solidFill>
-                <a:latin typeface="+mj-lt" pitchFamily="34" charset="0"/>
-                <a:ea typeface="+mj-lt" pitchFamily="34" charset="-122"/>
-                <a:cs typeface="+mj-lt" pitchFamily="34" charset="-120"/>
+                <a:latin typeface="Arial" pitchFamily="34" charset="0"/>
+                <a:ea typeface="Arial" pitchFamily="34" charset="-122"/>
+                <a:cs typeface="Arial" pitchFamily="34" charset="-120"/>
               </a:rPr>
               <a:t>Rastreo Inteligente</a:t>
             </a:r>
@@ -7155,7 +7280,7 @@
       </p:sp>
       <p:sp>
         <p:nvSpPr>
-          <p:cNvPr id="11" name="Text 8"/>
+          <p:cNvPr id="12" name="Text 9"/>
           <p:cNvSpPr txBox="1"/>
           <p:nvPr/>
         </p:nvSpPr>
@@ -7182,6 +7307,9 @@
                 <a:solidFill>
                   <a:srgbClr val="64748B"/>
                 </a:solidFill>
+                <a:latin typeface="Calibri" pitchFamily="34" charset="0"/>
+                <a:ea typeface="Calibri" pitchFamily="34" charset="-122"/>
+                <a:cs typeface="Calibri" pitchFamily="34" charset="-120"/>
               </a:rPr>
               <a:t>IA aplicada a la trazabilidad médica</a:t>
             </a:r>
@@ -7191,7 +7319,7 @@
       </p:sp>
       <p:sp>
         <p:nvSpPr>
-          <p:cNvPr id="12" name="Viñeta"/>
+          <p:cNvPr id="13" name="Viñeta"/>
           <p:cNvSpPr/>
           <p:nvPr/>
         </p:nvSpPr>
@@ -7211,7 +7339,7 @@
       </p:sp>
       <p:sp>
         <p:nvSpPr>
-          <p:cNvPr id="13" name="Text 10"/>
+          <p:cNvPr id="14" name="Text 11"/>
           <p:cNvSpPr txBox="1"/>
           <p:nvPr/>
         </p:nvSpPr>
@@ -7238,6 +7366,9 @@
                 <a:solidFill>
                   <a:srgbClr val="334155"/>
                 </a:solidFill>
+                <a:latin typeface="Calibri" pitchFamily="34" charset="0"/>
+                <a:ea typeface="Calibri" pitchFamily="34" charset="-122"/>
+                <a:cs typeface="Calibri" pitchFamily="34" charset="-120"/>
               </a:rPr>
               <a:t>Datos estándar + IA</a:t>
             </a:r>
@@ -7247,7 +7378,7 @@
       </p:sp>
       <p:sp>
         <p:nvSpPr>
-          <p:cNvPr id="14" name="Viñeta"/>
+          <p:cNvPr id="15" name="Viñeta"/>
           <p:cNvSpPr/>
           <p:nvPr/>
         </p:nvSpPr>
@@ -7267,7 +7398,7 @@
       </p:sp>
       <p:sp>
         <p:nvSpPr>
-          <p:cNvPr id="15" name="Text 12"/>
+          <p:cNvPr id="16" name="Text 13"/>
           <p:cNvSpPr txBox="1"/>
           <p:nvPr/>
         </p:nvSpPr>
@@ -7294,6 +7425,9 @@
                 <a:solidFill>
                   <a:srgbClr val="334155"/>
                 </a:solidFill>
+                <a:latin typeface="Calibri" pitchFamily="34" charset="0"/>
+                <a:ea typeface="Calibri" pitchFamily="34" charset="-122"/>
+                <a:cs typeface="Calibri" pitchFamily="34" charset="-120"/>
               </a:rPr>
               <a:t>Predicción, visión artificial y anomalías</a:t>
             </a:r>
@@ -7303,7 +7437,7 @@
       </p:sp>
       <p:sp>
         <p:nvSpPr>
-          <p:cNvPr id="16" name="Tarjeta"/>
+          <p:cNvPr id="17" name="Tarjeta"/>
           <p:cNvSpPr/>
           <p:nvPr/>
         </p:nvSpPr>
@@ -7337,7 +7471,7 @@
       </p:sp>
       <p:sp>
         <p:nvSpPr>
-          <p:cNvPr id="17" name="Barra de color"/>
+          <p:cNvPr id="18" name="Barra de color"/>
           <p:cNvSpPr/>
           <p:nvPr/>
         </p:nvSpPr>
@@ -7346,9 +7480,9 @@
             <a:off x="3460718" y="1285875"/>
             <a:ext cx="2400300" cy="76200"/>
           </a:xfrm>
-          <a:prstGeom prst="round2SameRect">
+          <a:prstGeom prst="roundRect">
             <a:avLst>
-              <a:gd name="adj" fmla="val 600000"/>
+              <a:gd name="adj" fmla="val 50000"/>
             </a:avLst>
           </a:prstGeom>
           <a:solidFill>
@@ -7359,7 +7493,27 @@
       </p:sp>
       <p:sp>
         <p:nvSpPr>
-          <p:cNvPr id="18" name="Insignia 2"/>
+          <p:cNvPr id="19" name="Barra de color (base)"/>
+          <p:cNvSpPr/>
+          <p:nvPr/>
+        </p:nvSpPr>
+        <p:spPr>
+          <a:xfrm>
+            <a:off x="3460718" y="1323975"/>
+            <a:ext cx="2400300" cy="38100"/>
+          </a:xfrm>
+          <a:prstGeom prst="rect">
+            <a:avLst/>
+          </a:prstGeom>
+          <a:solidFill>
+            <a:schemeClr val="accent1"/>
+          </a:solidFill>
+          <a:ln/>
+        </p:spPr>
+      </p:sp>
+      <p:sp>
+        <p:nvSpPr>
+          <p:cNvPr id="20" name="Insignia 2"/>
           <p:cNvSpPr/>
           <p:nvPr/>
         </p:nvSpPr>
@@ -7379,7 +7533,7 @@
       </p:sp>
       <p:sp>
         <p:nvSpPr>
-          <p:cNvPr id="19" name="Text 16"/>
+          <p:cNvPr id="21" name="Text 18"/>
           <p:cNvSpPr txBox="1"/>
           <p:nvPr/>
         </p:nvSpPr>
@@ -7406,9 +7560,9 @@
                 <a:solidFill>
                   <a:schemeClr val="bg1"/>
                 </a:solidFill>
-                <a:latin typeface="+mj-lt" pitchFamily="34" charset="0"/>
-                <a:ea typeface="+mj-lt" pitchFamily="34" charset="-122"/>
-                <a:cs typeface="+mj-lt" pitchFamily="34" charset="-120"/>
+                <a:latin typeface="Arial" pitchFamily="34" charset="0"/>
+                <a:ea typeface="Arial" pitchFamily="34" charset="-122"/>
+                <a:cs typeface="Arial" pitchFamily="34" charset="-120"/>
               </a:rPr>
               <a:t>2</a:t>
             </a:r>
@@ -7418,7 +7572,7 @@
       </p:sp>
       <p:sp>
         <p:nvSpPr>
-          <p:cNvPr id="20" name="Icono ShieldPlus"/>
+          <p:cNvPr id="22" name="Icono ShieldPlus"/>
           <p:cNvSpPr/>
           <p:nvPr/>
         </p:nvSpPr>
@@ -7438,7 +7592,7 @@
       </p:sp>
       <p:pic>
         <p:nvPicPr>
-          <p:cNvPr id="21" name="Image 1" descr="Icono ShieldPlus">    </p:cNvPr>
+          <p:cNvPr id="23" name="Image 1" descr="Icono ShieldPlus">    </p:cNvPr>
           <p:cNvPicPr>
             <a:picLocks noChangeAspect="1"/>
           </p:cNvPicPr>
@@ -7462,7 +7616,7 @@
       </p:pic>
       <p:sp>
         <p:nvSpPr>
-          <p:cNvPr id="22" name="Text 18"/>
+          <p:cNvPr id="24" name="Text 20"/>
           <p:cNvSpPr txBox="1"/>
           <p:nvPr/>
         </p:nvSpPr>
@@ -7489,9 +7643,9 @@
                 <a:solidFill>
                   <a:schemeClr val="tx2"/>
                 </a:solidFill>
-                <a:latin typeface="+mj-lt" pitchFamily="34" charset="0"/>
-                <a:ea typeface="+mj-lt" pitchFamily="34" charset="-122"/>
-                <a:cs typeface="+mj-lt" pitchFamily="34" charset="-120"/>
+                <a:latin typeface="Arial" pitchFamily="34" charset="0"/>
+                <a:ea typeface="Arial" pitchFamily="34" charset="-122"/>
+                <a:cs typeface="Arial" pitchFamily="34" charset="-120"/>
               </a:rPr>
               <a:t>Seguridad, cadena y trazabilidad</a:t>
             </a:r>
@@ -7501,7 +7655,7 @@
       </p:sp>
       <p:sp>
         <p:nvSpPr>
-          <p:cNvPr id="23" name="Text 19"/>
+          <p:cNvPr id="25" name="Text 21"/>
           <p:cNvSpPr txBox="1"/>
           <p:nvPr/>
         </p:nvSpPr>
@@ -7528,6 +7682,9 @@
                 <a:solidFill>
                   <a:srgbClr val="64748B"/>
                 </a:solidFill>
+                <a:latin typeface="Calibri" pitchFamily="34" charset="0"/>
+                <a:ea typeface="Calibri" pitchFamily="34" charset="-122"/>
+                <a:cs typeface="Calibri" pitchFamily="34" charset="-120"/>
               </a:rPr>
               <a:t>Pacientes, suministro y medicamentos</a:t>
             </a:r>
@@ -7537,7 +7694,7 @@
       </p:sp>
       <p:sp>
         <p:nvSpPr>
-          <p:cNvPr id="24" name="Viñeta"/>
+          <p:cNvPr id="26" name="Viñeta"/>
           <p:cNvSpPr/>
           <p:nvPr/>
         </p:nvSpPr>
@@ -7557,7 +7714,7 @@
       </p:sp>
       <p:sp>
         <p:nvSpPr>
-          <p:cNvPr id="25" name="Text 21"/>
+          <p:cNvPr id="27" name="Text 23"/>
           <p:cNvSpPr txBox="1"/>
           <p:nvPr/>
         </p:nvSpPr>
@@ -7584,6 +7741,9 @@
                 <a:solidFill>
                   <a:srgbClr val="334155"/>
                 </a:solidFill>
+                <a:latin typeface="Calibri" pitchFamily="34" charset="0"/>
+                <a:ea typeface="Calibri" pitchFamily="34" charset="-122"/>
+                <a:cs typeface="Calibri" pitchFamily="34" charset="-120"/>
               </a:rPr>
               <a:t>Los 5 Correctos (BCMA)</a:t>
             </a:r>
@@ -7593,7 +7753,7 @@
       </p:sp>
       <p:sp>
         <p:nvSpPr>
-          <p:cNvPr id="26" name="Viñeta"/>
+          <p:cNvPr id="28" name="Viñeta"/>
           <p:cNvSpPr/>
           <p:nvPr/>
         </p:nvSpPr>
@@ -7613,7 +7773,7 @@
       </p:sp>
       <p:sp>
         <p:nvSpPr>
-          <p:cNvPr id="27" name="Text 23"/>
+          <p:cNvPr id="29" name="Text 25"/>
           <p:cNvSpPr txBox="1"/>
           <p:nvPr/>
         </p:nvSpPr>
@@ -7640,6 +7800,9 @@
                 <a:solidFill>
                   <a:srgbClr val="334155"/>
                 </a:solidFill>
+                <a:latin typeface="Calibri" pitchFamily="34" charset="0"/>
+                <a:ea typeface="Calibri" pitchFamily="34" charset="-122"/>
+                <a:cs typeface="Calibri" pitchFamily="34" charset="-120"/>
               </a:rPr>
               <a:t>Eficiencia de la cadena</a:t>
             </a:r>
@@ -7649,7 +7812,7 @@
       </p:sp>
       <p:sp>
         <p:nvSpPr>
-          <p:cNvPr id="28" name="Viñeta"/>
+          <p:cNvPr id="30" name="Viñeta"/>
           <p:cNvSpPr/>
           <p:nvPr/>
         </p:nvSpPr>
@@ -7669,7 +7832,7 @@
       </p:sp>
       <p:sp>
         <p:nvSpPr>
-          <p:cNvPr id="29" name="Text 25"/>
+          <p:cNvPr id="31" name="Text 27"/>
           <p:cNvSpPr txBox="1"/>
           <p:nvPr/>
         </p:nvSpPr>
@@ -7696,6 +7859,9 @@
                 <a:solidFill>
                   <a:srgbClr val="334155"/>
                 </a:solidFill>
+                <a:latin typeface="Calibri" pitchFamily="34" charset="0"/>
+                <a:ea typeface="Calibri" pitchFamily="34" charset="-122"/>
+                <a:cs typeface="Calibri" pitchFamily="34" charset="-120"/>
               </a:rPr>
               <a:t>De EAN-13 a 2D: DataMatrix y QR GS1</a:t>
             </a:r>
@@ -7705,7 +7871,7 @@
       </p:sp>
       <p:sp>
         <p:nvSpPr>
-          <p:cNvPr id="30" name="Viñeta"/>
+          <p:cNvPr id="32" name="Viñeta"/>
           <p:cNvSpPr/>
           <p:nvPr/>
         </p:nvSpPr>
@@ -7725,7 +7891,7 @@
       </p:sp>
       <p:sp>
         <p:nvSpPr>
-          <p:cNvPr id="31" name="Text 27"/>
+          <p:cNvPr id="33" name="Text 29"/>
           <p:cNvSpPr txBox="1"/>
           <p:nvPr/>
         </p:nvSpPr>
@@ -7752,6 +7918,9 @@
                 <a:solidFill>
                   <a:srgbClr val="334155"/>
                 </a:solidFill>
+                <a:latin typeface="Calibri" pitchFamily="34" charset="0"/>
+                <a:ea typeface="Calibri" pitchFamily="34" charset="-122"/>
+                <a:cs typeface="Calibri" pitchFamily="34" charset="-120"/>
               </a:rPr>
               <a:t>Casos de éxito</a:t>
             </a:r>
@@ -7761,7 +7930,7 @@
       </p:sp>
       <p:sp>
         <p:nvSpPr>
-          <p:cNvPr id="32" name="Tarjeta"/>
+          <p:cNvPr id="34" name="Tarjeta"/>
           <p:cNvSpPr/>
           <p:nvPr/>
         </p:nvSpPr>
@@ -7795,7 +7964,7 @@
       </p:sp>
       <p:sp>
         <p:nvSpPr>
-          <p:cNvPr id="33" name="Barra de color"/>
+          <p:cNvPr id="35" name="Barra de color"/>
           <p:cNvSpPr/>
           <p:nvPr/>
         </p:nvSpPr>
@@ -7804,9 +7973,9 @@
             <a:off x="6330886" y="1285875"/>
             <a:ext cx="2400300" cy="76200"/>
           </a:xfrm>
-          <a:prstGeom prst="round2SameRect">
+          <a:prstGeom prst="roundRect">
             <a:avLst>
-              <a:gd name="adj" fmla="val 600000"/>
+              <a:gd name="adj" fmla="val 50000"/>
             </a:avLst>
           </a:prstGeom>
           <a:solidFill>
@@ -7817,7 +7986,27 @@
       </p:sp>
       <p:sp>
         <p:nvSpPr>
-          <p:cNvPr id="34" name="Insignia 3"/>
+          <p:cNvPr id="36" name="Barra de color (base)"/>
+          <p:cNvSpPr/>
+          <p:nvPr/>
+        </p:nvSpPr>
+        <p:spPr>
+          <a:xfrm>
+            <a:off x="6330886" y="1323975"/>
+            <a:ext cx="2400300" cy="38100"/>
+          </a:xfrm>
+          <a:prstGeom prst="rect">
+            <a:avLst/>
+          </a:prstGeom>
+          <a:solidFill>
+            <a:schemeClr val="accent3"/>
+          </a:solidFill>
+          <a:ln/>
+        </p:spPr>
+      </p:sp>
+      <p:sp>
+        <p:nvSpPr>
+          <p:cNvPr id="37" name="Insignia 3"/>
           <p:cNvSpPr/>
           <p:nvPr/>
         </p:nvSpPr>
@@ -7837,7 +8026,7 @@
       </p:sp>
       <p:sp>
         <p:nvSpPr>
-          <p:cNvPr id="35" name="Text 31"/>
+          <p:cNvPr id="38" name="Text 34"/>
           <p:cNvSpPr txBox="1"/>
           <p:nvPr/>
         </p:nvSpPr>
@@ -7864,9 +8053,9 @@
                 <a:solidFill>
                   <a:schemeClr val="bg1"/>
                 </a:solidFill>
-                <a:latin typeface="+mj-lt" pitchFamily="34" charset="0"/>
-                <a:ea typeface="+mj-lt" pitchFamily="34" charset="-122"/>
-                <a:cs typeface="+mj-lt" pitchFamily="34" charset="-120"/>
+                <a:latin typeface="Arial" pitchFamily="34" charset="0"/>
+                <a:ea typeface="Arial" pitchFamily="34" charset="-122"/>
+                <a:cs typeface="Arial" pitchFamily="34" charset="-120"/>
               </a:rPr>
               <a:t>3</a:t>
             </a:r>
@@ -7876,7 +8065,7 @@
       </p:sp>
       <p:sp>
         <p:nvSpPr>
-          <p:cNvPr id="36" name="Icono Newspaper"/>
+          <p:cNvPr id="39" name="Icono Newspaper"/>
           <p:cNvSpPr/>
           <p:nvPr/>
         </p:nvSpPr>
@@ -7896,7 +8085,7 @@
       </p:sp>
       <p:pic>
         <p:nvPicPr>
-          <p:cNvPr id="37" name="Image 2" descr="Icono Newspaper">    </p:cNvPr>
+          <p:cNvPr id="40" name="Image 2" descr="Icono Newspaper">    </p:cNvPr>
           <p:cNvPicPr>
             <a:picLocks noChangeAspect="1"/>
           </p:cNvPicPr>
@@ -7920,7 +8109,7 @@
       </p:pic>
       <p:sp>
         <p:nvSpPr>
-          <p:cNvPr id="38" name="Text 33"/>
+          <p:cNvPr id="41" name="Text 36"/>
           <p:cNvSpPr txBox="1"/>
           <p:nvPr/>
         </p:nvSpPr>
@@ -7947,9 +8136,9 @@
                 <a:solidFill>
                   <a:schemeClr val="tx2"/>
                 </a:solidFill>
-                <a:latin typeface="+mj-lt" pitchFamily="34" charset="0"/>
-                <a:ea typeface="+mj-lt" pitchFamily="34" charset="-122"/>
-                <a:cs typeface="+mj-lt" pitchFamily="34" charset="-120"/>
+                <a:latin typeface="Arial" pitchFamily="34" charset="0"/>
+                <a:ea typeface="Arial" pitchFamily="34" charset="-122"/>
+                <a:cs typeface="Arial" pitchFamily="34" charset="-120"/>
               </a:rPr>
               <a:t>GS1 News</a:t>
             </a:r>
@@ -7959,7 +8148,7 @@
       </p:sp>
       <p:sp>
         <p:nvSpPr>
-          <p:cNvPr id="39" name="Text 34"/>
+          <p:cNvPr id="42" name="Text 37"/>
           <p:cNvSpPr txBox="1"/>
           <p:nvPr/>
         </p:nvSpPr>
@@ -7986,6 +8175,9 @@
                 <a:solidFill>
                   <a:srgbClr val="64748B"/>
                 </a:solidFill>
+                <a:latin typeface="Calibri" pitchFamily="34" charset="0"/>
+                <a:ea typeface="Calibri" pitchFamily="34" charset="-122"/>
+                <a:cs typeface="Calibri" pitchFamily="34" charset="-120"/>
               </a:rPr>
               <a:t>Novedades y hoja de ruta</a:t>
             </a:r>
@@ -7995,7 +8187,7 @@
       </p:sp>
       <p:sp>
         <p:nvSpPr>
-          <p:cNvPr id="40" name="Viñeta"/>
+          <p:cNvPr id="43" name="Viñeta"/>
           <p:cNvSpPr/>
           <p:nvPr/>
         </p:nvSpPr>
@@ -8015,7 +8207,7 @@
       </p:sp>
       <p:sp>
         <p:nvSpPr>
-          <p:cNvPr id="41" name="Text 36"/>
+          <p:cNvPr id="44" name="Text 39"/>
           <p:cNvSpPr txBox="1"/>
           <p:nvPr/>
         </p:nvSpPr>
@@ -8042,6 +8234,9 @@
                 <a:solidFill>
                   <a:srgbClr val="334155"/>
                 </a:solidFill>
+                <a:latin typeface="Calibri" pitchFamily="34" charset="0"/>
+                <a:ea typeface="Calibri" pitchFamily="34" charset="-122"/>
+                <a:cs typeface="Calibri" pitchFamily="34" charset="-120"/>
               </a:rPr>
               <a:t>Sunrise 2027</a:t>
             </a:r>
@@ -8051,7 +8246,7 @@
       </p:sp>
       <p:sp>
         <p:nvSpPr>
-          <p:cNvPr id="42" name="Viñeta"/>
+          <p:cNvPr id="45" name="Viñeta"/>
           <p:cNvSpPr/>
           <p:nvPr/>
         </p:nvSpPr>
@@ -8071,7 +8266,7 @@
       </p:sp>
       <p:sp>
         <p:nvSpPr>
-          <p:cNvPr id="43" name="Text 38"/>
+          <p:cNvPr id="46" name="Text 41"/>
           <p:cNvSpPr txBox="1"/>
           <p:nvPr/>
         </p:nvSpPr>
@@ -8098,6 +8293,9 @@
                 <a:solidFill>
                   <a:srgbClr val="334155"/>
                 </a:solidFill>
+                <a:latin typeface="Calibri" pitchFamily="34" charset="0"/>
+                <a:ea typeface="Calibri" pitchFamily="34" charset="-122"/>
+                <a:cs typeface="Calibri" pitchFamily="34" charset="-120"/>
               </a:rPr>
               <a:t>GS1 Digital Link Latam</a:t>
             </a:r>
@@ -8107,7 +8305,7 @@
       </p:sp>
       <p:sp>
         <p:nvSpPr>
-          <p:cNvPr id="44" name="Viñeta"/>
+          <p:cNvPr id="47" name="Viñeta"/>
           <p:cNvSpPr/>
           <p:nvPr/>
         </p:nvSpPr>
@@ -8127,7 +8325,7 @@
       </p:sp>
       <p:sp>
         <p:nvSpPr>
-          <p:cNvPr id="45" name="Text 40"/>
+          <p:cNvPr id="48" name="Text 43"/>
           <p:cNvSpPr txBox="1"/>
           <p:nvPr/>
         </p:nvSpPr>
@@ -8154,6 +8352,9 @@
                 <a:solidFill>
                   <a:srgbClr val="334155"/>
                 </a:solidFill>
+                <a:latin typeface="Calibri" pitchFamily="34" charset="0"/>
+                <a:ea typeface="Calibri" pitchFamily="34" charset="-122"/>
+                <a:cs typeface="Calibri" pitchFamily="34" charset="-120"/>
               </a:rPr>
               <a:t>EPCIS 2.0</a:t>
             </a:r>
@@ -8163,7 +8364,7 @@
       </p:sp>
       <p:sp>
         <p:nvSpPr>
-          <p:cNvPr id="46" name="Tarjeta"/>
+          <p:cNvPr id="49" name="Tarjeta"/>
           <p:cNvSpPr/>
           <p:nvPr/>
         </p:nvSpPr>
@@ -8197,7 +8398,7 @@
       </p:sp>
       <p:sp>
         <p:nvSpPr>
-          <p:cNvPr id="47" name="Barra de color"/>
+          <p:cNvPr id="50" name="Barra de color"/>
           <p:cNvSpPr/>
           <p:nvPr/>
         </p:nvSpPr>
@@ -8206,9 +8407,9 @@
             <a:off x="9201055" y="1285875"/>
             <a:ext cx="2400300" cy="76200"/>
           </a:xfrm>
-          <a:prstGeom prst="round2SameRect">
+          <a:prstGeom prst="roundRect">
             <a:avLst>
-              <a:gd name="adj" fmla="val 600000"/>
+              <a:gd name="adj" fmla="val 50000"/>
             </a:avLst>
           </a:prstGeom>
           <a:solidFill>
@@ -8219,7 +8420,27 @@
       </p:sp>
       <p:sp>
         <p:nvSpPr>
-          <p:cNvPr id="48" name="Insignia 4"/>
+          <p:cNvPr id="51" name="Barra de color (base)"/>
+          <p:cNvSpPr/>
+          <p:nvPr/>
+        </p:nvSpPr>
+        <p:spPr>
+          <a:xfrm>
+            <a:off x="9201055" y="1323975"/>
+            <a:ext cx="2400300" cy="38100"/>
+          </a:xfrm>
+          <a:prstGeom prst="rect">
+            <a:avLst/>
+          </a:prstGeom>
+          <a:solidFill>
+            <a:schemeClr val="accent2"/>
+          </a:solidFill>
+          <a:ln/>
+        </p:spPr>
+      </p:sp>
+      <p:sp>
+        <p:nvSpPr>
+          <p:cNvPr id="52" name="Insignia 4"/>
           <p:cNvSpPr/>
           <p:nvPr/>
         </p:nvSpPr>
@@ -8239,7 +8460,7 @@
       </p:sp>
       <p:sp>
         <p:nvSpPr>
-          <p:cNvPr id="49" name="Text 44"/>
+          <p:cNvPr id="53" name="Text 48"/>
           <p:cNvSpPr txBox="1"/>
           <p:nvPr/>
         </p:nvSpPr>
@@ -8266,9 +8487,9 @@
                 <a:solidFill>
                   <a:schemeClr val="bg1"/>
                 </a:solidFill>
-                <a:latin typeface="+mj-lt" pitchFamily="34" charset="0"/>
-                <a:ea typeface="+mj-lt" pitchFamily="34" charset="-122"/>
-                <a:cs typeface="+mj-lt" pitchFamily="34" charset="-120"/>
+                <a:latin typeface="Arial" pitchFamily="34" charset="0"/>
+                <a:ea typeface="Arial" pitchFamily="34" charset="-122"/>
+                <a:cs typeface="Arial" pitchFamily="34" charset="-120"/>
               </a:rPr>
               <a:t>4</a:t>
             </a:r>
@@ -8278,7 +8499,7 @@
       </p:sp>
       <p:sp>
         <p:nvSpPr>
-          <p:cNvPr id="50" name="Icono MessagesSquare"/>
+          <p:cNvPr id="54" name="Icono MessagesSquare"/>
           <p:cNvSpPr/>
           <p:nvPr/>
         </p:nvSpPr>
@@ -8298,7 +8519,7 @@
       </p:sp>
       <p:pic>
         <p:nvPicPr>
-          <p:cNvPr id="51" name="Image 3" descr="Icono MessagesSquare">    </p:cNvPr>
+          <p:cNvPr id="55" name="Image 3" descr="Icono MessagesSquare">    </p:cNvPr>
           <p:cNvPicPr>
             <a:picLocks noChangeAspect="1"/>
           </p:cNvPicPr>
@@ -8322,7 +8543,7 @@
       </p:pic>
       <p:sp>
         <p:nvSpPr>
-          <p:cNvPr id="52" name="Text 46"/>
+          <p:cNvPr id="56" name="Text 50"/>
           <p:cNvSpPr txBox="1"/>
           <p:nvPr/>
         </p:nvSpPr>
@@ -8349,9 +8570,9 @@
                 <a:solidFill>
                   <a:schemeClr val="tx2"/>
                 </a:solidFill>
-                <a:latin typeface="+mj-lt" pitchFamily="34" charset="0"/>
-                <a:ea typeface="+mj-lt" pitchFamily="34" charset="-122"/>
-                <a:cs typeface="+mj-lt" pitchFamily="34" charset="-120"/>
+                <a:latin typeface="Arial" pitchFamily="34" charset="0"/>
+                <a:ea typeface="Arial" pitchFamily="34" charset="-122"/>
+                <a:cs typeface="Arial" pitchFamily="34" charset="-120"/>
               </a:rPr>
               <a:t>Ronda Abierta</a:t>
             </a:r>
@@ -8361,7 +8582,7 @@
       </p:sp>
       <p:sp>
         <p:nvSpPr>
-          <p:cNvPr id="53" name="Text 47"/>
+          <p:cNvPr id="57" name="Text 51"/>
           <p:cNvSpPr txBox="1"/>
           <p:nvPr/>
         </p:nvSpPr>
@@ -8388,6 +8609,9 @@
                 <a:solidFill>
                   <a:srgbClr val="64748B"/>
                 </a:solidFill>
+                <a:latin typeface="Calibri" pitchFamily="34" charset="0"/>
+                <a:ea typeface="Calibri" pitchFamily="34" charset="-122"/>
+                <a:cs typeface="Calibri" pitchFamily="34" charset="-120"/>
               </a:rPr>
               <a:t>Mesa de trabajo del Comité</a:t>
             </a:r>
@@ -8397,7 +8621,7 @@
       </p:sp>
       <p:sp>
         <p:nvSpPr>
-          <p:cNvPr id="54" name="Viñeta"/>
+          <p:cNvPr id="58" name="Viñeta"/>
           <p:cNvSpPr/>
           <p:nvPr/>
         </p:nvSpPr>
@@ -8417,7 +8641,7 @@
       </p:sp>
       <p:sp>
         <p:nvSpPr>
-          <p:cNvPr id="55" name="Text 49"/>
+          <p:cNvPr id="59" name="Text 53"/>
           <p:cNvSpPr txBox="1"/>
           <p:nvPr/>
         </p:nvSpPr>
@@ -8444,6 +8668,9 @@
                 <a:solidFill>
                   <a:srgbClr val="334155"/>
                 </a:solidFill>
+                <a:latin typeface="Calibri" pitchFamily="34" charset="0"/>
+                <a:ea typeface="Calibri" pitchFamily="34" charset="-122"/>
+                <a:cs typeface="Calibri" pitchFamily="34" charset="-120"/>
               </a:rPr>
               <a:t>Retos de implementación</a:t>
             </a:r>
@@ -8453,7 +8680,7 @@
       </p:sp>
       <p:sp>
         <p:nvSpPr>
-          <p:cNvPr id="56" name="Viñeta"/>
+          <p:cNvPr id="60" name="Viñeta"/>
           <p:cNvSpPr/>
           <p:nvPr/>
         </p:nvSpPr>
@@ -8473,7 +8700,7 @@
       </p:sp>
       <p:sp>
         <p:nvSpPr>
-          <p:cNvPr id="57" name="Text 51"/>
+          <p:cNvPr id="61" name="Text 55"/>
           <p:cNvSpPr txBox="1"/>
           <p:nvPr/>
         </p:nvSpPr>
@@ -8500,6 +8727,9 @@
                 <a:solidFill>
                   <a:srgbClr val="334155"/>
                 </a:solidFill>
+                <a:latin typeface="Calibri" pitchFamily="34" charset="0"/>
+                <a:ea typeface="Calibri" pitchFamily="34" charset="-122"/>
+                <a:cs typeface="Calibri" pitchFamily="34" charset="-120"/>
               </a:rPr>
               <a:t>Integración y educación</a:t>
             </a:r>
@@ -8509,7 +8739,7 @@
       </p:sp>
       <p:sp>
         <p:nvSpPr>
-          <p:cNvPr id="58" name="Viñeta"/>
+          <p:cNvPr id="62" name="Viñeta"/>
           <p:cNvSpPr/>
           <p:nvPr/>
         </p:nvSpPr>
@@ -8529,7 +8759,7 @@
       </p:sp>
       <p:sp>
         <p:nvSpPr>
-          <p:cNvPr id="59" name="Text 53"/>
+          <p:cNvPr id="63" name="Text 57"/>
           <p:cNvSpPr txBox="1"/>
           <p:nvPr/>
         </p:nvSpPr>
@@ -8556,6 +8786,9 @@
                 <a:solidFill>
                   <a:srgbClr val="334155"/>
                 </a:solidFill>
+                <a:latin typeface="Calibri" pitchFamily="34" charset="0"/>
+                <a:ea typeface="Calibri" pitchFamily="34" charset="-122"/>
+                <a:cs typeface="Calibri" pitchFamily="34" charset="-120"/>
               </a:rPr>
               <a:t>Próximos pilotos</a:t>
             </a:r>
@@ -8565,7 +8798,7 @@
       </p:sp>
       <p:sp>
         <p:nvSpPr>
-          <p:cNvPr id="60" name="Barra informativa"/>
+          <p:cNvPr id="64" name="Barra informativa"/>
           <p:cNvSpPr/>
           <p:nvPr/>
         </p:nvSpPr>
@@ -8587,7 +8820,7 @@
       </p:sp>
       <p:pic>
         <p:nvPicPr>
-          <p:cNvPr id="61" name="Image 4" descr="Icono CalendarDays">    </p:cNvPr>
+          <p:cNvPr id="65" name="Image 4" descr="Icono CalendarDays">    </p:cNvPr>
           <p:cNvPicPr>
             <a:picLocks noChangeAspect="1"/>
           </p:cNvPicPr>
@@ -8611,7 +8844,7 @@
       </p:pic>
       <p:sp>
         <p:nvSpPr>
-          <p:cNvPr id="62" name="Text 55"/>
+          <p:cNvPr id="66" name="Text 59"/>
           <p:cNvSpPr txBox="1"/>
           <p:nvPr/>
         </p:nvSpPr>
@@ -8638,9 +8871,9 @@
                 <a:solidFill>
                   <a:schemeClr val="bg1"/>
                 </a:solidFill>
-                <a:latin typeface="+mj-lt" pitchFamily="34" charset="0"/>
-                <a:ea typeface="+mj-lt" pitchFamily="34" charset="-122"/>
-                <a:cs typeface="+mj-lt" pitchFamily="34" charset="-120"/>
+                <a:latin typeface="Arial" pitchFamily="34" charset="0"/>
+                <a:ea typeface="Arial" pitchFamily="34" charset="-122"/>
+                <a:cs typeface="Arial" pitchFamily="34" charset="-120"/>
               </a:rPr>
               <a:t>5 Noviembre, 2026 · 8:30 am – 10:00 am</a:t>
             </a:r>
@@ -8650,7 +8883,7 @@
       </p:sp>
       <p:sp>
         <p:nvSpPr>
-          <p:cNvPr id="63" name="Shape 56"/>
+          <p:cNvPr id="67" name="Shape 60"/>
           <p:cNvSpPr/>
           <p:nvPr/>
         </p:nvSpPr>
@@ -8675,7 +8908,7 @@
       </p:sp>
       <p:pic>
         <p:nvPicPr>
-          <p:cNvPr id="64" name="Image 5" descr="Icono MapPin">    </p:cNvPr>
+          <p:cNvPr id="68" name="Image 5" descr="Icono MapPin">    </p:cNvPr>
           <p:cNvPicPr>
             <a:picLocks noChangeAspect="1"/>
           </p:cNvPicPr>
@@ -8699,7 +8932,7 @@
       </p:pic>
       <p:sp>
         <p:nvSpPr>
-          <p:cNvPr id="65" name="Text 57"/>
+          <p:cNvPr id="69" name="Text 61"/>
           <p:cNvSpPr txBox="1"/>
           <p:nvPr/>
         </p:nvSpPr>
@@ -8726,6 +8959,9 @@
                 <a:solidFill>
                   <a:schemeClr val="bg1"/>
                 </a:solidFill>
+                <a:latin typeface="Calibri" pitchFamily="34" charset="0"/>
+                <a:ea typeface="Calibri" pitchFamily="34" charset="-122"/>
+                <a:cs typeface="Calibri" pitchFamily="34" charset="-120"/>
               </a:rPr>
               <a:t>Oficina GS1 Venezuela · Los Ruices, Calle Los Laboratorios, Edf. Quorum, Piso 1, Oficina K (Caracas)</a:t>
             </a:r>
@@ -8832,6 +9068,9 @@
                 <a:solidFill>
                   <a:schemeClr val="accent2"/>
                 </a:solidFill>
+                <a:latin typeface="Calibri" pitchFamily="34" charset="0"/>
+                <a:ea typeface="Calibri" pitchFamily="34" charset="-122"/>
+                <a:cs typeface="Calibri" pitchFamily="34" charset="-120"/>
               </a:rPr>
               <a:t>CONTEXTO VENEZOLANO · EL NUEVO PACIENTE</a:t>
             </a:r>
@@ -8870,9 +9109,9 @@
                 <a:solidFill>
                   <a:schemeClr val="tx2"/>
                 </a:solidFill>
-                <a:latin typeface="+mj-lt" pitchFamily="34" charset="0"/>
-                <a:ea typeface="+mj-lt" pitchFamily="34" charset="-122"/>
-                <a:cs typeface="+mj-lt" pitchFamily="34" charset="-120"/>
+                <a:latin typeface="Arial" pitchFamily="34" charset="0"/>
+                <a:ea typeface="Arial" pitchFamily="34" charset="-122"/>
+                <a:cs typeface="Arial" pitchFamily="34" charset="-120"/>
               </a:rPr>
               <a:t>Información, confianza y </a:t>
             </a:r>
@@ -8884,9 +9123,9 @@
                 <a:solidFill>
                   <a:schemeClr val="accent1"/>
                 </a:solidFill>
-                <a:latin typeface="+mj-lt" pitchFamily="34" charset="0"/>
-                <a:ea typeface="+mj-lt" pitchFamily="34" charset="-122"/>
-                <a:cs typeface="+mj-lt" pitchFamily="34" charset="-120"/>
+                <a:latin typeface="Arial" pitchFamily="34" charset="0"/>
+                <a:ea typeface="Arial" pitchFamily="34" charset="-122"/>
+                <a:cs typeface="Arial" pitchFamily="34" charset="-120"/>
               </a:rPr>
               <a:t>verificación en cada empaque</a:t>
             </a:r>
@@ -8973,9 +9212,9 @@
                 <a:solidFill>
                   <a:schemeClr val="accent2"/>
                 </a:solidFill>
-                <a:latin typeface="+mj-lt" pitchFamily="34" charset="0"/>
-                <a:ea typeface="+mj-lt" pitchFamily="34" charset="-122"/>
-                <a:cs typeface="+mj-lt" pitchFamily="34" charset="-120"/>
+                <a:latin typeface="Arial" pitchFamily="34" charset="0"/>
+                <a:ea typeface="Arial" pitchFamily="34" charset="-122"/>
+                <a:cs typeface="Arial" pitchFamily="34" charset="-120"/>
               </a:rPr>
               <a:t>41%</a:t>
             </a:r>
@@ -9012,6 +9251,9 @@
                 <a:solidFill>
                   <a:srgbClr val="475569"/>
                 </a:solidFill>
+                <a:latin typeface="Calibri" pitchFamily="34" charset="0"/>
+                <a:ea typeface="Calibri" pitchFamily="34" charset="-122"/>
+                <a:cs typeface="Calibri" pitchFamily="34" charset="-120"/>
               </a:rPr>
               <a:t>No escanea códigos estáticos que no aportan información útil.</a:t>
             </a:r>
@@ -9098,9 +9340,9 @@
                 <a:solidFill>
                   <a:schemeClr val="accent1"/>
                 </a:solidFill>
-                <a:latin typeface="+mj-lt" pitchFamily="34" charset="0"/>
-                <a:ea typeface="+mj-lt" pitchFamily="34" charset="-122"/>
-                <a:cs typeface="+mj-lt" pitchFamily="34" charset="-120"/>
+                <a:latin typeface="Arial" pitchFamily="34" charset="0"/>
+                <a:ea typeface="Arial" pitchFamily="34" charset="-122"/>
+                <a:cs typeface="Arial" pitchFamily="34" charset="-120"/>
               </a:rPr>
               <a:t>80%</a:t>
             </a:r>
@@ -9137,6 +9379,9 @@
                 <a:solidFill>
                   <a:srgbClr val="475569"/>
                 </a:solidFill>
+                <a:latin typeface="Calibri" pitchFamily="34" charset="0"/>
+                <a:ea typeface="Calibri" pitchFamily="34" charset="-122"/>
+                <a:cs typeface="Calibri" pitchFamily="34" charset="-120"/>
               </a:rPr>
               <a:t>Está dispuesto a escanear para conocer origen, registro sanitario y autenticidad.</a:t>
             </a:r>
@@ -9251,9 +9496,9 @@
                 <a:solidFill>
                   <a:schemeClr val="tx2"/>
                 </a:solidFill>
-                <a:latin typeface="+mj-lt" pitchFamily="34" charset="0"/>
-                <a:ea typeface="+mj-lt" pitchFamily="34" charset="-122"/>
-                <a:cs typeface="+mj-lt" pitchFamily="34" charset="-120"/>
+                <a:latin typeface="Arial" pitchFamily="34" charset="0"/>
+                <a:ea typeface="Arial" pitchFamily="34" charset="-122"/>
+                <a:cs typeface="Arial" pitchFamily="34" charset="-120"/>
               </a:rPr>
               <a:t>Información</a:t>
             </a:r>
@@ -9290,6 +9535,9 @@
                 <a:solidFill>
                   <a:srgbClr val="475569"/>
                 </a:solidFill>
+                <a:latin typeface="Calibri" pitchFamily="34" charset="0"/>
+                <a:ea typeface="Calibri" pitchFamily="34" charset="-122"/>
+                <a:cs typeface="Calibri" pitchFamily="34" charset="-120"/>
               </a:rPr>
               <a:t>Acceso al prospecto digital actualizado (e-PIL), posología y alertas sanitarias desde el móvil.</a:t>
             </a:r>
@@ -9404,9 +9652,9 @@
                 <a:solidFill>
                   <a:schemeClr val="tx2"/>
                 </a:solidFill>
-                <a:latin typeface="+mj-lt" pitchFamily="34" charset="0"/>
-                <a:ea typeface="+mj-lt" pitchFamily="34" charset="-122"/>
-                <a:cs typeface="+mj-lt" pitchFamily="34" charset="-120"/>
+                <a:latin typeface="Arial" pitchFamily="34" charset="0"/>
+                <a:ea typeface="Arial" pitchFamily="34" charset="-122"/>
+                <a:cs typeface="Arial" pitchFamily="34" charset="-120"/>
               </a:rPr>
               <a:t>Confianza</a:t>
             </a:r>
@@ -9443,6 +9691,9 @@
                 <a:solidFill>
                   <a:srgbClr val="475569"/>
                 </a:solidFill>
+                <a:latin typeface="Calibri" pitchFamily="34" charset="0"/>
+                <a:ea typeface="Calibri" pitchFamily="34" charset="-122"/>
+                <a:cs typeface="Calibri" pitchFamily="34" charset="-120"/>
               </a:rPr>
               <a:t>Protección frente a medicamentos ilícitos, contrabando o sin registro sanitario (SACS / INHRR) en el mercado nacional.</a:t>
             </a:r>
@@ -9557,9 +9808,9 @@
                 <a:solidFill>
                   <a:schemeClr val="tx2"/>
                 </a:solidFill>
-                <a:latin typeface="+mj-lt" pitchFamily="34" charset="0"/>
-                <a:ea typeface="+mj-lt" pitchFamily="34" charset="-122"/>
-                <a:cs typeface="+mj-lt" pitchFamily="34" charset="-120"/>
+                <a:latin typeface="Arial" pitchFamily="34" charset="0"/>
+                <a:ea typeface="Arial" pitchFamily="34" charset="-122"/>
+                <a:cs typeface="Arial" pitchFamily="34" charset="-120"/>
               </a:rPr>
               <a:t>Experiencia</a:t>
             </a:r>
@@ -9596,6 +9847,9 @@
                 <a:solidFill>
                   <a:srgbClr val="475569"/>
                 </a:solidFill>
+                <a:latin typeface="Calibri" pitchFamily="34" charset="0"/>
+                <a:ea typeface="Calibri" pitchFamily="34" charset="-122"/>
+                <a:cs typeface="Calibri" pitchFamily="34" charset="-120"/>
               </a:rPr>
               <a:t>Transparencia total entre laboratorio, droguería, farmacia, médico y paciente.</a:t>
             </a:r>
@@ -9690,6 +9944,9 @@
                 <a:solidFill>
                   <a:schemeClr val="bg1"/>
                 </a:solidFill>
+                <a:latin typeface="Calibri" pitchFamily="34" charset="0"/>
+                <a:ea typeface="Calibri" pitchFamily="34" charset="-122"/>
+                <a:cs typeface="Calibri" pitchFamily="34" charset="-120"/>
               </a:rPr>
               <a:t>Insertar foto: farmacéutica / paciente escaneando</a:t>
             </a:r>
@@ -9840,6 +10097,9 @@
                 <a:solidFill>
                   <a:schemeClr val="accent2"/>
                 </a:solidFill>
+                <a:latin typeface="Calibri" pitchFamily="34" charset="0"/>
+                <a:ea typeface="Calibri" pitchFamily="34" charset="-122"/>
+                <a:cs typeface="Calibri" pitchFamily="34" charset="-120"/>
               </a:rPr>
               <a:t>AGENDA · PUNTO 1</a:t>
             </a:r>
@@ -9878,9 +10138,9 @@
                 <a:solidFill>
                   <a:schemeClr val="tx2"/>
                 </a:solidFill>
-                <a:latin typeface="+mj-lt" pitchFamily="34" charset="0"/>
-                <a:ea typeface="+mj-lt" pitchFamily="34" charset="-122"/>
-                <a:cs typeface="+mj-lt" pitchFamily="34" charset="-120"/>
+                <a:latin typeface="Arial" pitchFamily="34" charset="0"/>
+                <a:ea typeface="Arial" pitchFamily="34" charset="-122"/>
+                <a:cs typeface="Arial" pitchFamily="34" charset="-120"/>
               </a:rPr>
               <a:t>Rastreo Inteligente: </a:t>
             </a:r>
@@ -9892,9 +10152,9 @@
                 <a:solidFill>
                   <a:schemeClr val="accent1"/>
                 </a:solidFill>
-                <a:latin typeface="+mj-lt" pitchFamily="34" charset="0"/>
-                <a:ea typeface="+mj-lt" pitchFamily="34" charset="-122"/>
-                <a:cs typeface="+mj-lt" pitchFamily="34" charset="-120"/>
+                <a:latin typeface="Arial" pitchFamily="34" charset="0"/>
+                <a:ea typeface="Arial" pitchFamily="34" charset="-122"/>
+                <a:cs typeface="Arial" pitchFamily="34" charset="-120"/>
               </a:rPr>
               <a:t>la IA parte del dato estándar</a:t>
             </a:r>
@@ -9931,6 +10191,9 @@
                 <a:solidFill>
                   <a:srgbClr val="475569"/>
                 </a:solidFill>
+                <a:latin typeface="Calibri" pitchFamily="34" charset="0"/>
+                <a:ea typeface="Calibri" pitchFamily="34" charset="-122"/>
+                <a:cs typeface="Calibri" pitchFamily="34" charset="-120"/>
               </a:rPr>
               <a:t>Los algoritmos de IA son tan buenos como la calidad de los datos estándar que los alimentan.</a:t>
             </a:r>
@@ -9983,7 +10246,7 @@
             <a:off x="457200" y="1524000"/>
             <a:ext cx="3276600" cy="723900"/>
           </a:xfrm>
-          <a:prstGeom prst="round2SameRect">
+          <a:prstGeom prst="roundRect">
             <a:avLst>
               <a:gd name="adj" fmla="val 22737"/>
             </a:avLst>
@@ -9994,9 +10257,29 @@
           <a:ln/>
         </p:spPr>
       </p:sp>
+      <p:sp>
+        <p:nvSpPr>
+          <p:cNvPr id="7" name="Cabecero (base)"/>
+          <p:cNvSpPr/>
+          <p:nvPr/>
+        </p:nvSpPr>
+        <p:spPr>
+          <a:xfrm>
+            <a:off x="457200" y="1885950"/>
+            <a:ext cx="3276600" cy="361950"/>
+          </a:xfrm>
+          <a:prstGeom prst="rect">
+            <a:avLst/>
+          </a:prstGeom>
+          <a:solidFill>
+            <a:schemeClr val="tx2"/>
+          </a:solidFill>
+          <a:ln/>
+        </p:spPr>
+      </p:sp>
       <p:pic>
         <p:nvPicPr>
-          <p:cNvPr id="7" name="Image 0" descr="Icono Database">    </p:cNvPr>
+          <p:cNvPr id="8" name="Image 0" descr="Icono Database">    </p:cNvPr>
           <p:cNvPicPr>
             <a:picLocks noChangeAspect="1"/>
           </p:cNvPicPr>
@@ -10020,7 +10303,7 @@
       </p:pic>
       <p:sp>
         <p:nvSpPr>
-          <p:cNvPr id="8" name="Text 5"/>
+          <p:cNvPr id="9" name="Text 6"/>
           <p:cNvSpPr txBox="1"/>
           <p:nvPr/>
         </p:nvSpPr>
@@ -10047,9 +10330,9 @@
                 <a:solidFill>
                   <a:schemeClr val="bg1"/>
                 </a:solidFill>
-                <a:latin typeface="+mj-lt" pitchFamily="34" charset="0"/>
-                <a:ea typeface="+mj-lt" pitchFamily="34" charset="-122"/>
-                <a:cs typeface="+mj-lt" pitchFamily="34" charset="-120"/>
+                <a:latin typeface="Arial" pitchFamily="34" charset="0"/>
+                <a:ea typeface="Arial" pitchFamily="34" charset="-122"/>
+                <a:cs typeface="Arial" pitchFamily="34" charset="-120"/>
               </a:rPr>
               <a:t>1 · Datos estándar GS1</a:t>
             </a:r>
@@ -10059,7 +10342,7 @@
       </p:sp>
       <p:sp>
         <p:nvSpPr>
-          <p:cNvPr id="9" name="Text 6"/>
+          <p:cNvPr id="10" name="Text 7"/>
           <p:cNvSpPr txBox="1"/>
           <p:nvPr/>
         </p:nvSpPr>
@@ -10086,6 +10369,9 @@
                 <a:solidFill>
                   <a:schemeClr val="bg1"/>
                 </a:solidFill>
+                <a:latin typeface="Calibri" pitchFamily="34" charset="0"/>
+                <a:ea typeface="Calibri" pitchFamily="34" charset="-122"/>
+                <a:cs typeface="Calibri" pitchFamily="34" charset="-120"/>
               </a:rPr>
               <a:t>Identificadores únicos y universales</a:t>
             </a:r>
@@ -10095,7 +10381,7 @@
       </p:sp>
       <p:sp>
         <p:nvSpPr>
-          <p:cNvPr id="10" name="Dato GTIN"/>
+          <p:cNvPr id="11" name="Dato GTIN"/>
           <p:cNvSpPr/>
           <p:nvPr/>
         </p:nvSpPr>
@@ -10117,7 +10403,7 @@
       </p:sp>
       <p:sp>
         <p:nvSpPr>
-          <p:cNvPr id="11" name="Text 8"/>
+          <p:cNvPr id="12" name="Text 9"/>
           <p:cNvSpPr txBox="1"/>
           <p:nvPr/>
         </p:nvSpPr>
@@ -10156,7 +10442,7 @@
       </p:sp>
       <p:sp>
         <p:nvSpPr>
-          <p:cNvPr id="12" name="Text 9"/>
+          <p:cNvPr id="13" name="Text 10"/>
           <p:cNvSpPr txBox="1"/>
           <p:nvPr/>
         </p:nvSpPr>
@@ -10183,6 +10469,9 @@
                 <a:solidFill>
                   <a:srgbClr val="334155"/>
                 </a:solidFill>
+                <a:latin typeface="Calibri" pitchFamily="34" charset="0"/>
+                <a:ea typeface="Calibri" pitchFamily="34" charset="-122"/>
+                <a:cs typeface="Calibri" pitchFamily="34" charset="-120"/>
               </a:rPr>
               <a:t>qué producto</a:t>
             </a:r>
@@ -10192,7 +10481,7 @@
       </p:sp>
       <p:sp>
         <p:nvSpPr>
-          <p:cNvPr id="13" name="Dato GLN"/>
+          <p:cNvPr id="14" name="Dato GLN"/>
           <p:cNvSpPr/>
           <p:nvPr/>
         </p:nvSpPr>
@@ -10214,7 +10503,7 @@
       </p:sp>
       <p:sp>
         <p:nvSpPr>
-          <p:cNvPr id="14" name="Text 11"/>
+          <p:cNvPr id="15" name="Text 12"/>
           <p:cNvSpPr txBox="1"/>
           <p:nvPr/>
         </p:nvSpPr>
@@ -10253,7 +10542,7 @@
       </p:sp>
       <p:sp>
         <p:nvSpPr>
-          <p:cNvPr id="15" name="Text 12"/>
+          <p:cNvPr id="16" name="Text 13"/>
           <p:cNvSpPr txBox="1"/>
           <p:nvPr/>
         </p:nvSpPr>
@@ -10280,6 +10569,9 @@
                 <a:solidFill>
                   <a:srgbClr val="334155"/>
                 </a:solidFill>
+                <a:latin typeface="Calibri" pitchFamily="34" charset="0"/>
+                <a:ea typeface="Calibri" pitchFamily="34" charset="-122"/>
+                <a:cs typeface="Calibri" pitchFamily="34" charset="-120"/>
               </a:rPr>
               <a:t>dónde / ubicación</a:t>
             </a:r>
@@ -10289,7 +10581,7 @@
       </p:sp>
       <p:sp>
         <p:nvSpPr>
-          <p:cNvPr id="16" name="Dato Lote/Serie"/>
+          <p:cNvPr id="17" name="Dato Lote/Serie"/>
           <p:cNvSpPr/>
           <p:nvPr/>
         </p:nvSpPr>
@@ -10311,7 +10603,7 @@
       </p:sp>
       <p:sp>
         <p:nvSpPr>
-          <p:cNvPr id="17" name="Text 14"/>
+          <p:cNvPr id="18" name="Text 15"/>
           <p:cNvSpPr txBox="1"/>
           <p:nvPr/>
         </p:nvSpPr>
@@ -10350,7 +10642,7 @@
       </p:sp>
       <p:sp>
         <p:nvSpPr>
-          <p:cNvPr id="18" name="Text 15"/>
+          <p:cNvPr id="19" name="Text 16"/>
           <p:cNvSpPr txBox="1"/>
           <p:nvPr/>
         </p:nvSpPr>
@@ -10377,6 +10669,9 @@
                 <a:solidFill>
                   <a:srgbClr val="334155"/>
                 </a:solidFill>
+                <a:latin typeface="Calibri" pitchFamily="34" charset="0"/>
+                <a:ea typeface="Calibri" pitchFamily="34" charset="-122"/>
+                <a:cs typeface="Calibri" pitchFamily="34" charset="-120"/>
               </a:rPr>
               <a:t>qué unidad</a:t>
             </a:r>
@@ -10386,7 +10681,7 @@
       </p:sp>
       <p:sp>
         <p:nvSpPr>
-          <p:cNvPr id="19" name="Dato SSCC"/>
+          <p:cNvPr id="20" name="Dato SSCC"/>
           <p:cNvSpPr/>
           <p:nvPr/>
         </p:nvSpPr>
@@ -10408,7 +10703,7 @@
       </p:sp>
       <p:sp>
         <p:nvSpPr>
-          <p:cNvPr id="20" name="Text 17"/>
+          <p:cNvPr id="21" name="Text 18"/>
           <p:cNvSpPr txBox="1"/>
           <p:nvPr/>
         </p:nvSpPr>
@@ -10447,7 +10742,7 @@
       </p:sp>
       <p:sp>
         <p:nvSpPr>
-          <p:cNvPr id="21" name="Text 18"/>
+          <p:cNvPr id="22" name="Text 19"/>
           <p:cNvSpPr txBox="1"/>
           <p:nvPr/>
         </p:nvSpPr>
@@ -10474,6 +10769,9 @@
                 <a:solidFill>
                   <a:srgbClr val="334155"/>
                 </a:solidFill>
+                <a:latin typeface="Calibri" pitchFamily="34" charset="0"/>
+                <a:ea typeface="Calibri" pitchFamily="34" charset="-122"/>
+                <a:cs typeface="Calibri" pitchFamily="34" charset="-120"/>
               </a:rPr>
               <a:t>qué envío</a:t>
             </a:r>
@@ -10483,7 +10781,7 @@
       </p:sp>
       <p:sp>
         <p:nvSpPr>
-          <p:cNvPr id="22" name="Flecha"/>
+          <p:cNvPr id="23" name="Flecha"/>
           <p:cNvSpPr/>
           <p:nvPr/>
         </p:nvSpPr>
@@ -10503,7 +10801,7 @@
       </p:sp>
       <p:sp>
         <p:nvSpPr>
-          <p:cNvPr id="23" name="Tarjeta"/>
+          <p:cNvPr id="24" name="Tarjeta"/>
           <p:cNvSpPr/>
           <p:nvPr/>
         </p:nvSpPr>
@@ -10537,7 +10835,7 @@
       </p:sp>
       <p:sp>
         <p:nvSpPr>
-          <p:cNvPr id="24" name="Cabecero"/>
+          <p:cNvPr id="25" name="Cabecero"/>
           <p:cNvSpPr/>
           <p:nvPr/>
         </p:nvSpPr>
@@ -10546,7 +10844,7 @@
             <a:off x="4457700" y="1524000"/>
             <a:ext cx="3276600" cy="723900"/>
           </a:xfrm>
-          <a:prstGeom prst="round2SameRect">
+          <a:prstGeom prst="roundRect">
             <a:avLst>
               <a:gd name="adj" fmla="val 22737"/>
             </a:avLst>
@@ -10557,9 +10855,29 @@
           <a:ln/>
         </p:spPr>
       </p:sp>
+      <p:sp>
+        <p:nvSpPr>
+          <p:cNvPr id="26" name="Cabecero (base)"/>
+          <p:cNvSpPr/>
+          <p:nvPr/>
+        </p:nvSpPr>
+        <p:spPr>
+          <a:xfrm>
+            <a:off x="4457700" y="1885950"/>
+            <a:ext cx="3276600" cy="361950"/>
+          </a:xfrm>
+          <a:prstGeom prst="rect">
+            <a:avLst/>
+          </a:prstGeom>
+          <a:solidFill>
+            <a:schemeClr val="accent1"/>
+          </a:solidFill>
+          <a:ln/>
+        </p:spPr>
+      </p:sp>
       <p:pic>
         <p:nvPicPr>
-          <p:cNvPr id="25" name="Image 1" descr="Icono Radar">    </p:cNvPr>
+          <p:cNvPr id="27" name="Image 1" descr="Icono Radar">    </p:cNvPr>
           <p:cNvPicPr>
             <a:picLocks noChangeAspect="1"/>
           </p:cNvPicPr>
@@ -10583,7 +10901,7 @@
       </p:pic>
       <p:sp>
         <p:nvSpPr>
-          <p:cNvPr id="26" name="Text 22"/>
+          <p:cNvPr id="28" name="Text 24"/>
           <p:cNvSpPr txBox="1"/>
           <p:nvPr/>
         </p:nvSpPr>
@@ -10610,9 +10928,9 @@
                 <a:solidFill>
                   <a:schemeClr val="bg1"/>
                 </a:solidFill>
-                <a:latin typeface="+mj-lt" pitchFamily="34" charset="0"/>
-                <a:ea typeface="+mj-lt" pitchFamily="34" charset="-122"/>
-                <a:cs typeface="+mj-lt" pitchFamily="34" charset="-120"/>
+                <a:latin typeface="Arial" pitchFamily="34" charset="0"/>
+                <a:ea typeface="Arial" pitchFamily="34" charset="-122"/>
+                <a:cs typeface="Arial" pitchFamily="34" charset="-120"/>
               </a:rPr>
               <a:t>2 · Eventos EPCIS 2.0</a:t>
             </a:r>
@@ -10622,7 +10940,7 @@
       </p:sp>
       <p:sp>
         <p:nvSpPr>
-          <p:cNvPr id="27" name="Text 23"/>
+          <p:cNvPr id="29" name="Text 25"/>
           <p:cNvSpPr txBox="1"/>
           <p:nvPr/>
         </p:nvSpPr>
@@ -10649,6 +10967,9 @@
                 <a:solidFill>
                   <a:schemeClr val="bg1"/>
                 </a:solidFill>
+                <a:latin typeface="Calibri" pitchFamily="34" charset="0"/>
+                <a:ea typeface="Calibri" pitchFamily="34" charset="-122"/>
+                <a:cs typeface="Calibri" pitchFamily="34" charset="-120"/>
               </a:rPr>
               <a:t>Cada movimiento queda registrado</a:t>
             </a:r>
@@ -10658,7 +10979,7 @@
       </p:sp>
       <p:sp>
         <p:nvSpPr>
-          <p:cNvPr id="28" name="Dato QUÉ"/>
+          <p:cNvPr id="30" name="Dato QUÉ"/>
           <p:cNvSpPr/>
           <p:nvPr/>
         </p:nvSpPr>
@@ -10680,7 +11001,7 @@
       </p:sp>
       <p:sp>
         <p:nvSpPr>
-          <p:cNvPr id="29" name="Text 25"/>
+          <p:cNvPr id="31" name="Text 27"/>
           <p:cNvSpPr txBox="1"/>
           <p:nvPr/>
         </p:nvSpPr>
@@ -10719,7 +11040,7 @@
       </p:sp>
       <p:sp>
         <p:nvSpPr>
-          <p:cNvPr id="30" name="Text 26"/>
+          <p:cNvPr id="32" name="Text 28"/>
           <p:cNvSpPr txBox="1"/>
           <p:nvPr/>
         </p:nvSpPr>
@@ -10746,6 +11067,9 @@
                 <a:solidFill>
                   <a:srgbClr val="334155"/>
                 </a:solidFill>
+                <a:latin typeface="Calibri" pitchFamily="34" charset="0"/>
+                <a:ea typeface="Calibri" pitchFamily="34" charset="-122"/>
+                <a:cs typeface="Calibri" pitchFamily="34" charset="-120"/>
               </a:rPr>
               <a:t>producto y cantidad</a:t>
             </a:r>
@@ -10755,7 +11079,7 @@
       </p:sp>
       <p:sp>
         <p:nvSpPr>
-          <p:cNvPr id="31" name="Dato DÓNDE"/>
+          <p:cNvPr id="33" name="Dato DÓNDE"/>
           <p:cNvSpPr/>
           <p:nvPr/>
         </p:nvSpPr>
@@ -10777,7 +11101,7 @@
       </p:sp>
       <p:sp>
         <p:nvSpPr>
-          <p:cNvPr id="32" name="Text 28"/>
+          <p:cNvPr id="34" name="Text 30"/>
           <p:cNvSpPr txBox="1"/>
           <p:nvPr/>
         </p:nvSpPr>
@@ -10816,7 +11140,7 @@
       </p:sp>
       <p:sp>
         <p:nvSpPr>
-          <p:cNvPr id="33" name="Text 29"/>
+          <p:cNvPr id="35" name="Text 31"/>
           <p:cNvSpPr txBox="1"/>
           <p:nvPr/>
         </p:nvSpPr>
@@ -10843,6 +11167,9 @@
                 <a:solidFill>
                   <a:srgbClr val="334155"/>
                 </a:solidFill>
+                <a:latin typeface="Calibri" pitchFamily="34" charset="0"/>
+                <a:ea typeface="Calibri" pitchFamily="34" charset="-122"/>
+                <a:cs typeface="Calibri" pitchFamily="34" charset="-120"/>
               </a:rPr>
               <a:t>ubicación GLN</a:t>
             </a:r>
@@ -10852,7 +11179,7 @@
       </p:sp>
       <p:sp>
         <p:nvSpPr>
-          <p:cNvPr id="34" name="Dato CUÁNDO"/>
+          <p:cNvPr id="36" name="Dato CUÁNDO"/>
           <p:cNvSpPr/>
           <p:nvPr/>
         </p:nvSpPr>
@@ -10874,7 +11201,7 @@
       </p:sp>
       <p:sp>
         <p:nvSpPr>
-          <p:cNvPr id="35" name="Text 31"/>
+          <p:cNvPr id="37" name="Text 33"/>
           <p:cNvSpPr txBox="1"/>
           <p:nvPr/>
         </p:nvSpPr>
@@ -10913,7 +11240,7 @@
       </p:sp>
       <p:sp>
         <p:nvSpPr>
-          <p:cNvPr id="36" name="Text 32"/>
+          <p:cNvPr id="38" name="Text 34"/>
           <p:cNvSpPr txBox="1"/>
           <p:nvPr/>
         </p:nvSpPr>
@@ -10940,6 +11267,9 @@
                 <a:solidFill>
                   <a:srgbClr val="334155"/>
                 </a:solidFill>
+                <a:latin typeface="Calibri" pitchFamily="34" charset="0"/>
+                <a:ea typeface="Calibri" pitchFamily="34" charset="-122"/>
+                <a:cs typeface="Calibri" pitchFamily="34" charset="-120"/>
               </a:rPr>
               <a:t>fecha y hora</a:t>
             </a:r>
@@ -10949,7 +11279,7 @@
       </p:sp>
       <p:sp>
         <p:nvSpPr>
-          <p:cNvPr id="37" name="Dato POR QUÉ"/>
+          <p:cNvPr id="39" name="Dato POR QUÉ"/>
           <p:cNvSpPr/>
           <p:nvPr/>
         </p:nvSpPr>
@@ -10971,7 +11301,7 @@
       </p:sp>
       <p:sp>
         <p:nvSpPr>
-          <p:cNvPr id="38" name="Text 34"/>
+          <p:cNvPr id="40" name="Text 36"/>
           <p:cNvSpPr txBox="1"/>
           <p:nvPr/>
         </p:nvSpPr>
@@ -11010,7 +11340,7 @@
       </p:sp>
       <p:sp>
         <p:nvSpPr>
-          <p:cNvPr id="39" name="Text 35"/>
+          <p:cNvPr id="41" name="Text 37"/>
           <p:cNvSpPr txBox="1"/>
           <p:nvPr/>
         </p:nvSpPr>
@@ -11037,6 +11367,9 @@
                 <a:solidFill>
                   <a:srgbClr val="334155"/>
                 </a:solidFill>
+                <a:latin typeface="Calibri" pitchFamily="34" charset="0"/>
+                <a:ea typeface="Calibri" pitchFamily="34" charset="-122"/>
+                <a:cs typeface="Calibri" pitchFamily="34" charset="-120"/>
               </a:rPr>
               <a:t>recepción, despacho, dispensación</a:t>
             </a:r>
@@ -11046,7 +11379,7 @@
       </p:sp>
       <p:sp>
         <p:nvSpPr>
-          <p:cNvPr id="40" name="Flecha"/>
+          <p:cNvPr id="42" name="Flecha"/>
           <p:cNvSpPr/>
           <p:nvPr/>
         </p:nvSpPr>
@@ -11066,7 +11399,7 @@
       </p:sp>
       <p:sp>
         <p:nvSpPr>
-          <p:cNvPr id="41" name="Tarjeta"/>
+          <p:cNvPr id="43" name="Tarjeta"/>
           <p:cNvSpPr/>
           <p:nvPr/>
         </p:nvSpPr>
@@ -11100,7 +11433,7 @@
       </p:sp>
       <p:sp>
         <p:nvSpPr>
-          <p:cNvPr id="42" name="Cabecero"/>
+          <p:cNvPr id="44" name="Cabecero"/>
           <p:cNvSpPr/>
           <p:nvPr/>
         </p:nvSpPr>
@@ -11109,7 +11442,7 @@
             <a:off x="8458200" y="1524000"/>
             <a:ext cx="3276600" cy="723900"/>
           </a:xfrm>
-          <a:prstGeom prst="round2SameRect">
+          <a:prstGeom prst="roundRect">
             <a:avLst>
               <a:gd name="adj" fmla="val 22737"/>
             </a:avLst>
@@ -11120,9 +11453,29 @@
           <a:ln/>
         </p:spPr>
       </p:sp>
+      <p:sp>
+        <p:nvSpPr>
+          <p:cNvPr id="45" name="Cabecero (base)"/>
+          <p:cNvSpPr/>
+          <p:nvPr/>
+        </p:nvSpPr>
+        <p:spPr>
+          <a:xfrm>
+            <a:off x="8458200" y="1885950"/>
+            <a:ext cx="3276600" cy="361950"/>
+          </a:xfrm>
+          <a:prstGeom prst="rect">
+            <a:avLst/>
+          </a:prstGeom>
+          <a:solidFill>
+            <a:schemeClr val="accent3"/>
+          </a:solidFill>
+          <a:ln/>
+        </p:spPr>
+      </p:sp>
       <p:pic>
         <p:nvPicPr>
-          <p:cNvPr id="43" name="Image 2" descr="Icono Cpu">    </p:cNvPr>
+          <p:cNvPr id="46" name="Image 2" descr="Icono Cpu">    </p:cNvPr>
           <p:cNvPicPr>
             <a:picLocks noChangeAspect="1"/>
           </p:cNvPicPr>
@@ -11146,7 +11499,7 @@
       </p:pic>
       <p:sp>
         <p:nvSpPr>
-          <p:cNvPr id="44" name="Text 39"/>
+          <p:cNvPr id="47" name="Text 42"/>
           <p:cNvSpPr txBox="1"/>
           <p:nvPr/>
         </p:nvSpPr>
@@ -11173,9 +11526,9 @@
                 <a:solidFill>
                   <a:schemeClr val="bg1"/>
                 </a:solidFill>
-                <a:latin typeface="+mj-lt" pitchFamily="34" charset="0"/>
-                <a:ea typeface="+mj-lt" pitchFamily="34" charset="-122"/>
-                <a:cs typeface="+mj-lt" pitchFamily="34" charset="-120"/>
+                <a:latin typeface="Arial" pitchFamily="34" charset="0"/>
+                <a:ea typeface="Arial" pitchFamily="34" charset="-122"/>
+                <a:cs typeface="Arial" pitchFamily="34" charset="-120"/>
               </a:rPr>
               <a:t>3 · Inteligencia Artificial</a:t>
             </a:r>
@@ -11185,7 +11538,7 @@
       </p:sp>
       <p:sp>
         <p:nvSpPr>
-          <p:cNvPr id="45" name="Text 40"/>
+          <p:cNvPr id="48" name="Text 43"/>
           <p:cNvSpPr txBox="1"/>
           <p:nvPr/>
         </p:nvSpPr>
@@ -11212,6 +11565,9 @@
                 <a:solidFill>
                   <a:schemeClr val="bg1"/>
                 </a:solidFill>
+                <a:latin typeface="Calibri" pitchFamily="34" charset="0"/>
+                <a:ea typeface="Calibri" pitchFamily="34" charset="-122"/>
+                <a:cs typeface="Calibri" pitchFamily="34" charset="-120"/>
               </a:rPr>
               <a:t>Modelos sobre datos confiables</a:t>
             </a:r>
@@ -11221,7 +11577,7 @@
       </p:sp>
       <p:sp>
         <p:nvSpPr>
-          <p:cNvPr id="46" name="Dato Predicción"/>
+          <p:cNvPr id="49" name="Dato Predicción"/>
           <p:cNvSpPr/>
           <p:nvPr/>
         </p:nvSpPr>
@@ -11243,7 +11599,7 @@
       </p:sp>
       <p:sp>
         <p:nvSpPr>
-          <p:cNvPr id="47" name="Text 42"/>
+          <p:cNvPr id="50" name="Text 45"/>
           <p:cNvSpPr txBox="1"/>
           <p:nvPr/>
         </p:nvSpPr>
@@ -11282,7 +11638,7 @@
       </p:sp>
       <p:sp>
         <p:nvSpPr>
-          <p:cNvPr id="48" name="Text 43"/>
+          <p:cNvPr id="51" name="Text 46"/>
           <p:cNvSpPr txBox="1"/>
           <p:nvPr/>
         </p:nvSpPr>
@@ -11309,6 +11665,9 @@
                 <a:solidFill>
                   <a:srgbClr val="334155"/>
                 </a:solidFill>
+                <a:latin typeface="Calibri" pitchFamily="34" charset="0"/>
+                <a:ea typeface="Calibri" pitchFamily="34" charset="-122"/>
+                <a:cs typeface="Calibri" pitchFamily="34" charset="-120"/>
               </a:rPr>
               <a:t>demanda y escasez</a:t>
             </a:r>
@@ -11318,7 +11677,7 @@
       </p:sp>
       <p:sp>
         <p:nvSpPr>
-          <p:cNvPr id="49" name="Dato Visión"/>
+          <p:cNvPr id="52" name="Dato Visión"/>
           <p:cNvSpPr/>
           <p:nvPr/>
         </p:nvSpPr>
@@ -11340,7 +11699,7 @@
       </p:sp>
       <p:sp>
         <p:nvSpPr>
-          <p:cNvPr id="50" name="Text 45"/>
+          <p:cNvPr id="53" name="Text 48"/>
           <p:cNvSpPr txBox="1"/>
           <p:nvPr/>
         </p:nvSpPr>
@@ -11379,7 +11738,7 @@
       </p:sp>
       <p:sp>
         <p:nvSpPr>
-          <p:cNvPr id="51" name="Text 46"/>
+          <p:cNvPr id="54" name="Text 49"/>
           <p:cNvSpPr txBox="1"/>
           <p:nvPr/>
         </p:nvSpPr>
@@ -11406,6 +11765,9 @@
                 <a:solidFill>
                   <a:srgbClr val="334155"/>
                 </a:solidFill>
+                <a:latin typeface="Calibri" pitchFamily="34" charset="0"/>
+                <a:ea typeface="Calibri" pitchFamily="34" charset="-122"/>
+                <a:cs typeface="Calibri" pitchFamily="34" charset="-120"/>
               </a:rPr>
               <a:t>verificación de códigos 2D</a:t>
             </a:r>
@@ -11415,7 +11777,7 @@
       </p:sp>
       <p:sp>
         <p:nvSpPr>
-          <p:cNvPr id="52" name="Dato Anomalías"/>
+          <p:cNvPr id="55" name="Dato Anomalías"/>
           <p:cNvSpPr/>
           <p:nvPr/>
         </p:nvSpPr>
@@ -11437,7 +11799,7 @@
       </p:sp>
       <p:sp>
         <p:nvSpPr>
-          <p:cNvPr id="53" name="Text 48"/>
+          <p:cNvPr id="56" name="Text 51"/>
           <p:cNvSpPr txBox="1"/>
           <p:nvPr/>
         </p:nvSpPr>
@@ -11476,7 +11838,7 @@
       </p:sp>
       <p:sp>
         <p:nvSpPr>
-          <p:cNvPr id="54" name="Text 49"/>
+          <p:cNvPr id="57" name="Text 52"/>
           <p:cNvSpPr txBox="1"/>
           <p:nvPr/>
         </p:nvSpPr>
@@ -11503,6 +11865,9 @@
                 <a:solidFill>
                   <a:srgbClr val="334155"/>
                 </a:solidFill>
+                <a:latin typeface="Calibri" pitchFamily="34" charset="0"/>
+                <a:ea typeface="Calibri" pitchFamily="34" charset="-122"/>
+                <a:cs typeface="Calibri" pitchFamily="34" charset="-120"/>
               </a:rPr>
               <a:t>desvíos y cadena de frío</a:t>
             </a:r>
@@ -11512,7 +11877,7 @@
       </p:sp>
       <p:sp>
         <p:nvSpPr>
-          <p:cNvPr id="55" name="Alerta"/>
+          <p:cNvPr id="58" name="Alerta"/>
           <p:cNvSpPr/>
           <p:nvPr/>
         </p:nvSpPr>
@@ -11539,7 +11904,7 @@
       </p:sp>
       <p:pic>
         <p:nvPicPr>
-          <p:cNvPr id="56" name="Image 3" descr="Icono TriangleAlert">    </p:cNvPr>
+          <p:cNvPr id="59" name="Image 3" descr="Icono TriangleAlert">    </p:cNvPr>
           <p:cNvPicPr>
             <a:picLocks noChangeAspect="1"/>
           </p:cNvPicPr>
@@ -11563,7 +11928,7 @@
       </p:pic>
       <p:sp>
         <p:nvSpPr>
-          <p:cNvPr id="57" name="Text 51"/>
+          <p:cNvPr id="60" name="Text 54"/>
           <p:cNvSpPr txBox="1"/>
           <p:nvPr/>
         </p:nvSpPr>
@@ -11590,6 +11955,9 @@
                 <a:solidFill>
                   <a:schemeClr val="accent2"/>
                 </a:solidFill>
+                <a:latin typeface="Calibri" pitchFamily="34" charset="0"/>
+                <a:ea typeface="Calibri" pitchFamily="34" charset="-122"/>
+                <a:cs typeface="Calibri" pitchFamily="34" charset="-120"/>
               </a:rPr>
               <a:t>Sin estándar, no hay IA confiable: </a:t>
             </a:r>
@@ -11601,6 +11969,9 @@
                 <a:solidFill>
                   <a:schemeClr val="tx1"/>
                 </a:solidFill>
+                <a:latin typeface="Calibri" pitchFamily="34" charset="0"/>
+                <a:ea typeface="Calibri" pitchFamily="34" charset="-122"/>
+                <a:cs typeface="Calibri" pitchFamily="34" charset="-120"/>
               </a:rPr>
               <a:t>códigos genéricos, datos incompletos o duplicados producen predicciones y alertas poco fiables.</a:t>
             </a:r>
@@ -11707,6 +12078,9 @@
                 <a:solidFill>
                   <a:schemeClr val="accent2"/>
                 </a:solidFill>
+                <a:latin typeface="Calibri" pitchFamily="34" charset="0"/>
+                <a:ea typeface="Calibri" pitchFamily="34" charset="-122"/>
+                <a:cs typeface="Calibri" pitchFamily="34" charset="-120"/>
               </a:rPr>
               <a:t>AGENDA · PUNTO 1</a:t>
             </a:r>
@@ -11745,9 +12119,9 @@
                 <a:solidFill>
                   <a:schemeClr val="tx2"/>
                 </a:solidFill>
-                <a:latin typeface="+mj-lt" pitchFamily="34" charset="0"/>
-                <a:ea typeface="+mj-lt" pitchFamily="34" charset="-122"/>
-                <a:cs typeface="+mj-lt" pitchFamily="34" charset="-120"/>
+                <a:latin typeface="Arial" pitchFamily="34" charset="0"/>
+                <a:ea typeface="Arial" pitchFamily="34" charset="-122"/>
+                <a:cs typeface="Arial" pitchFamily="34" charset="-120"/>
               </a:rPr>
               <a:t>Tres usos de la </a:t>
             </a:r>
@@ -11759,9 +12133,9 @@
                 <a:solidFill>
                   <a:schemeClr val="accent1"/>
                 </a:solidFill>
-                <a:latin typeface="+mj-lt" pitchFamily="34" charset="0"/>
-                <a:ea typeface="+mj-lt" pitchFamily="34" charset="-122"/>
-                <a:cs typeface="+mj-lt" pitchFamily="34" charset="-120"/>
+                <a:latin typeface="Arial" pitchFamily="34" charset="0"/>
+                <a:ea typeface="Arial" pitchFamily="34" charset="-122"/>
+                <a:cs typeface="Arial" pitchFamily="34" charset="-120"/>
               </a:rPr>
               <a:t>IA + GS1 en salud</a:t>
             </a:r>
@@ -11876,9 +12250,9 @@
                 <a:solidFill>
                   <a:schemeClr val="tx2"/>
                 </a:solidFill>
-                <a:latin typeface="+mj-lt" pitchFamily="34" charset="0"/>
-                <a:ea typeface="+mj-lt" pitchFamily="34" charset="-122"/>
-                <a:cs typeface="+mj-lt" pitchFamily="34" charset="-120"/>
+                <a:latin typeface="Arial" pitchFamily="34" charset="0"/>
+                <a:ea typeface="Arial" pitchFamily="34" charset="-122"/>
+                <a:cs typeface="Arial" pitchFamily="34" charset="-120"/>
               </a:rPr>
               <a:t>Modelos predictivos de demanda</a:t>
             </a:r>
@@ -11915,6 +12289,9 @@
                 <a:solidFill>
                   <a:srgbClr val="475569"/>
                 </a:solidFill>
+                <a:latin typeface="Calibri" pitchFamily="34" charset="0"/>
+                <a:ea typeface="Calibri" pitchFamily="34" charset="-122"/>
+                <a:cs typeface="Calibri" pitchFamily="34" charset="-120"/>
               </a:rPr>
               <a:t>Anticipan la escasez de insumos críticos y reactivos en clínicas y hospitales venezolanos.</a:t>
             </a:r>
@@ -12029,9 +12406,9 @@
                 <a:solidFill>
                   <a:schemeClr val="tx2"/>
                 </a:solidFill>
-                <a:latin typeface="+mj-lt" pitchFamily="34" charset="0"/>
-                <a:ea typeface="+mj-lt" pitchFamily="34" charset="-122"/>
-                <a:cs typeface="+mj-lt" pitchFamily="34" charset="-120"/>
+                <a:latin typeface="Arial" pitchFamily="34" charset="0"/>
+                <a:ea typeface="Arial" pitchFamily="34" charset="-122"/>
+                <a:cs typeface="Arial" pitchFamily="34" charset="-120"/>
               </a:rPr>
               <a:t>Visión artificial en líneas de empaque</a:t>
             </a:r>
@@ -12068,6 +12445,9 @@
                 <a:solidFill>
                   <a:srgbClr val="475569"/>
                 </a:solidFill>
+                <a:latin typeface="Calibri" pitchFamily="34" charset="0"/>
+                <a:ea typeface="Calibri" pitchFamily="34" charset="-122"/>
+                <a:cs typeface="Calibri" pitchFamily="34" charset="-120"/>
               </a:rPr>
               <a:t>Verificación a alta velocidad de GS1 DataMatrix y QR GS1 Digital Link en plantas farmacéuticas.</a:t>
             </a:r>
@@ -12182,9 +12562,9 @@
                 <a:solidFill>
                   <a:schemeClr val="tx2"/>
                 </a:solidFill>
-                <a:latin typeface="+mj-lt" pitchFamily="34" charset="0"/>
-                <a:ea typeface="+mj-lt" pitchFamily="34" charset="-122"/>
-                <a:cs typeface="+mj-lt" pitchFamily="34" charset="-120"/>
+                <a:latin typeface="Arial" pitchFamily="34" charset="0"/>
+                <a:ea typeface="Arial" pitchFamily="34" charset="-122"/>
+                <a:cs typeface="Arial" pitchFamily="34" charset="-120"/>
               </a:rPr>
               <a:t>Detección de anomalías con Machine Learning</a:t>
             </a:r>
@@ -12221,6 +12601,9 @@
                 <a:solidFill>
                   <a:srgbClr val="475569"/>
                 </a:solidFill>
+                <a:latin typeface="Calibri" pitchFamily="34" charset="0"/>
+                <a:ea typeface="Calibri" pitchFamily="34" charset="-122"/>
+                <a:cs typeface="Calibri" pitchFamily="34" charset="-120"/>
               </a:rPr>
               <a:t>Alerta temprana de desvíos a canales irregulares y rupturas de cadena de frío (insulinas, vacunas, biológicos).</a:t>
             </a:r>
@@ -12315,6 +12698,9 @@
                 <a:solidFill>
                   <a:schemeClr val="bg1"/>
                 </a:solidFill>
+                <a:latin typeface="Calibri" pitchFamily="34" charset="0"/>
+                <a:ea typeface="Calibri" pitchFamily="34" charset="-122"/>
+                <a:cs typeface="Calibri" pitchFamily="34" charset="-120"/>
               </a:rPr>
               <a:t>Insertar foto: cadena de suministro farmacéutica</a:t>
             </a:r>
@@ -12335,7 +12721,7 @@
           </a:xfrm>
           <a:prstGeom prst="roundRect">
             <a:avLst>
-              <a:gd name="adj" fmla="val 171429"/>
+              <a:gd name="adj" fmla="val 50000"/>
             </a:avLst>
           </a:prstGeom>
           <a:solidFill>
@@ -12396,7 +12782,7 @@
           </a:xfrm>
           <a:prstGeom prst="roundRect">
             <a:avLst>
-              <a:gd name="adj" fmla="val 171429"/>
+              <a:gd name="adj" fmla="val 50000"/>
             </a:avLst>
           </a:prstGeom>
           <a:solidFill>
@@ -12457,7 +12843,7 @@
           </a:xfrm>
           <a:prstGeom prst="roundRect">
             <a:avLst>
-              <a:gd name="adj" fmla="val 171429"/>
+              <a:gd name="adj" fmla="val 50000"/>
             </a:avLst>
           </a:prstGeom>
           <a:solidFill>
@@ -12608,6 +12994,9 @@
                 <a:solidFill>
                   <a:schemeClr val="accent2"/>
                 </a:solidFill>
+                <a:latin typeface="Calibri" pitchFamily="34" charset="0"/>
+                <a:ea typeface="Calibri" pitchFamily="34" charset="-122"/>
+                <a:cs typeface="Calibri" pitchFamily="34" charset="-120"/>
               </a:rPr>
               <a:t>IMPACTO DIRECTO EN VENEZUELA</a:t>
             </a:r>
@@ -12668,6 +13057,9 @@
                 <a:solidFill>
                   <a:schemeClr val="tx1"/>
                 </a:solidFill>
+                <a:latin typeface="Calibri" pitchFamily="34" charset="0"/>
+                <a:ea typeface="Calibri" pitchFamily="34" charset="-122"/>
+                <a:cs typeface="Calibri" pitchFamily="34" charset="-120"/>
               </a:rPr>
               <a:t>Optimización de rutas logísticas entre laboratorios nacionales, droguerías y farmacias en todo el país.</a:t>
             </a:r>
@@ -12728,6 +13120,9 @@
                 <a:solidFill>
                   <a:schemeClr val="tx1"/>
                 </a:solidFill>
+                <a:latin typeface="Calibri" pitchFamily="34" charset="0"/>
+                <a:ea typeface="Calibri" pitchFamily="34" charset="-122"/>
+                <a:cs typeface="Calibri" pitchFamily="34" charset="-120"/>
               </a:rPr>
               <a:t>Gestión de vencimientos </a:t>
             </a:r>
@@ -12739,6 +13134,9 @@
                 <a:solidFill>
                   <a:schemeClr val="accent2"/>
                 </a:solidFill>
+                <a:latin typeface="Calibri" pitchFamily="34" charset="0"/>
+                <a:ea typeface="Calibri" pitchFamily="34" charset="-122"/>
+                <a:cs typeface="Calibri" pitchFamily="34" charset="-120"/>
               </a:rPr>
               <a:t>FEFO</a:t>
             </a:r>
@@ -12750,6 +13148,9 @@
                 <a:solidFill>
                   <a:schemeClr val="tx1"/>
                 </a:solidFill>
+                <a:latin typeface="Calibri" pitchFamily="34" charset="0"/>
+                <a:ea typeface="Calibri" pitchFamily="34" charset="-122"/>
+                <a:cs typeface="Calibri" pitchFamily="34" charset="-120"/>
               </a:rPr>
               <a:t> (First Expired, First Out): menos mermas financieras por caducidad.</a:t>
             </a:r>
@@ -12856,6 +13257,9 @@
                 <a:solidFill>
                   <a:schemeClr val="accent2"/>
                 </a:solidFill>
+                <a:latin typeface="Calibri" pitchFamily="34" charset="0"/>
+                <a:ea typeface="Calibri" pitchFamily="34" charset="-122"/>
+                <a:cs typeface="Calibri" pitchFamily="34" charset="-120"/>
               </a:rPr>
               <a:t>AGENDA · PUNTO 2</a:t>
             </a:r>
@@ -12894,9 +13298,9 @@
                 <a:solidFill>
                   <a:schemeClr val="tx2"/>
                 </a:solidFill>
-                <a:latin typeface="+mj-lt" pitchFamily="34" charset="0"/>
-                <a:ea typeface="+mj-lt" pitchFamily="34" charset="-122"/>
-                <a:cs typeface="+mj-lt" pitchFamily="34" charset="-120"/>
+                <a:latin typeface="Arial" pitchFamily="34" charset="0"/>
+                <a:ea typeface="Arial" pitchFamily="34" charset="-122"/>
+                <a:cs typeface="Arial" pitchFamily="34" charset="-120"/>
               </a:rPr>
               <a:t>Seguridad del paciente: los </a:t>
             </a:r>
@@ -12908,9 +13312,9 @@
                 <a:solidFill>
                   <a:schemeClr val="accent1"/>
                 </a:solidFill>
-                <a:latin typeface="+mj-lt" pitchFamily="34" charset="0"/>
-                <a:ea typeface="+mj-lt" pitchFamily="34" charset="-122"/>
-                <a:cs typeface="+mj-lt" pitchFamily="34" charset="-120"/>
+                <a:latin typeface="Arial" pitchFamily="34" charset="0"/>
+                <a:ea typeface="Arial" pitchFamily="34" charset="-122"/>
+                <a:cs typeface="Arial" pitchFamily="34" charset="-120"/>
               </a:rPr>
               <a:t>5 Correctos</a:t>
             </a:r>
@@ -12922,9 +13326,9 @@
                 <a:solidFill>
                   <a:schemeClr val="tx2"/>
                 </a:solidFill>
-                <a:latin typeface="+mj-lt" pitchFamily="34" charset="0"/>
-                <a:ea typeface="+mj-lt" pitchFamily="34" charset="-122"/>
-                <a:cs typeface="+mj-lt" pitchFamily="34" charset="-120"/>
+                <a:latin typeface="Arial" pitchFamily="34" charset="0"/>
+                <a:ea typeface="Arial" pitchFamily="34" charset="-122"/>
+                <a:cs typeface="Arial" pitchFamily="34" charset="-120"/>
               </a:rPr>
               <a:t> (BCMA)</a:t>
             </a:r>
@@ -12961,6 +13365,9 @@
                 <a:solidFill>
                   <a:srgbClr val="64748B"/>
                 </a:solidFill>
+                <a:latin typeface="Calibri" pitchFamily="34" charset="0"/>
+                <a:ea typeface="Calibri" pitchFamily="34" charset="-122"/>
+                <a:cs typeface="Calibri" pitchFamily="34" charset="-120"/>
               </a:rPr>
               <a:t>Escaneo a pie de cama — Bedside Barcode Medication Administration</a:t>
             </a:r>
@@ -13143,9 +13550,9 @@
                 <a:solidFill>
                   <a:schemeClr val="bg1"/>
                 </a:solidFill>
-                <a:latin typeface="+mj-lt" pitchFamily="34" charset="0"/>
-                <a:ea typeface="+mj-lt" pitchFamily="34" charset="-122"/>
-                <a:cs typeface="+mj-lt" pitchFamily="34" charset="-120"/>
+                <a:latin typeface="Arial" pitchFamily="34" charset="0"/>
+                <a:ea typeface="Arial" pitchFamily="34" charset="-122"/>
+                <a:cs typeface="Arial" pitchFamily="34" charset="-120"/>
               </a:rPr>
               <a:t>1</a:t>
             </a:r>
@@ -13182,9 +13589,9 @@
                 <a:solidFill>
                   <a:schemeClr val="tx2"/>
                 </a:solidFill>
-                <a:latin typeface="+mj-lt" pitchFamily="34" charset="0"/>
-                <a:ea typeface="+mj-lt" pitchFamily="34" charset="-122"/>
-                <a:cs typeface="+mj-lt" pitchFamily="34" charset="-120"/>
+                <a:latin typeface="Arial" pitchFamily="34" charset="0"/>
+                <a:ea typeface="Arial" pitchFamily="34" charset="-122"/>
+                <a:cs typeface="Arial" pitchFamily="34" charset="-120"/>
               </a:rPr>
               <a:t>Paciente correcto</a:t>
             </a:r>
@@ -13221,6 +13628,9 @@
                 <a:solidFill>
                   <a:srgbClr val="475569"/>
                 </a:solidFill>
+                <a:latin typeface="Calibri" pitchFamily="34" charset="0"/>
+                <a:ea typeface="Calibri" pitchFamily="34" charset="-122"/>
+                <a:cs typeface="Calibri" pitchFamily="34" charset="-120"/>
               </a:rPr>
               <a:t>Escaneo del código GS1 del brazalete de identificación hospitalaria.</a:t>
             </a:r>
@@ -13241,7 +13651,7 @@
           </a:xfrm>
           <a:prstGeom prst="roundRect">
             <a:avLst>
-              <a:gd name="adj" fmla="val 171429"/>
+              <a:gd name="adj" fmla="val 50000"/>
             </a:avLst>
           </a:prstGeom>
           <a:solidFill>
@@ -13372,9 +13782,9 @@
                 <a:solidFill>
                   <a:schemeClr val="bg1"/>
                 </a:solidFill>
-                <a:latin typeface="+mj-lt" pitchFamily="34" charset="0"/>
-                <a:ea typeface="+mj-lt" pitchFamily="34" charset="-122"/>
-                <a:cs typeface="+mj-lt" pitchFamily="34" charset="-120"/>
+                <a:latin typeface="Arial" pitchFamily="34" charset="0"/>
+                <a:ea typeface="Arial" pitchFamily="34" charset="-122"/>
+                <a:cs typeface="Arial" pitchFamily="34" charset="-120"/>
               </a:rPr>
               <a:t>2</a:t>
             </a:r>
@@ -13411,9 +13821,9 @@
                 <a:solidFill>
                   <a:schemeClr val="tx2"/>
                 </a:solidFill>
-                <a:latin typeface="+mj-lt" pitchFamily="34" charset="0"/>
-                <a:ea typeface="+mj-lt" pitchFamily="34" charset="-122"/>
-                <a:cs typeface="+mj-lt" pitchFamily="34" charset="-120"/>
+                <a:latin typeface="Arial" pitchFamily="34" charset="0"/>
+                <a:ea typeface="Arial" pitchFamily="34" charset="-122"/>
+                <a:cs typeface="Arial" pitchFamily="34" charset="-120"/>
               </a:rPr>
               <a:t>Medicamento correcto</a:t>
             </a:r>
@@ -13450,6 +13860,9 @@
                 <a:solidFill>
                   <a:srgbClr val="475569"/>
                 </a:solidFill>
+                <a:latin typeface="Calibri" pitchFamily="34" charset="0"/>
+                <a:ea typeface="Calibri" pitchFamily="34" charset="-122"/>
+                <a:cs typeface="Calibri" pitchFamily="34" charset="-120"/>
               </a:rPr>
               <a:t>Validación instantánea del GTIN contra la prescripción médica electrónica.</a:t>
             </a:r>
@@ -13470,7 +13883,7 @@
           </a:xfrm>
           <a:prstGeom prst="roundRect">
             <a:avLst>
-              <a:gd name="adj" fmla="val 171429"/>
+              <a:gd name="adj" fmla="val 50000"/>
             </a:avLst>
           </a:prstGeom>
           <a:solidFill>
@@ -13601,9 +14014,9 @@
                 <a:solidFill>
                   <a:schemeClr val="bg1"/>
                 </a:solidFill>
-                <a:latin typeface="+mj-lt" pitchFamily="34" charset="0"/>
-                <a:ea typeface="+mj-lt" pitchFamily="34" charset="-122"/>
-                <a:cs typeface="+mj-lt" pitchFamily="34" charset="-120"/>
+                <a:latin typeface="Arial" pitchFamily="34" charset="0"/>
+                <a:ea typeface="Arial" pitchFamily="34" charset="-122"/>
+                <a:cs typeface="Arial" pitchFamily="34" charset="-120"/>
               </a:rPr>
               <a:t>3</a:t>
             </a:r>
@@ -13640,9 +14053,9 @@
                 <a:solidFill>
                   <a:schemeClr val="tx2"/>
                 </a:solidFill>
-                <a:latin typeface="+mj-lt" pitchFamily="34" charset="0"/>
-                <a:ea typeface="+mj-lt" pitchFamily="34" charset="-122"/>
-                <a:cs typeface="+mj-lt" pitchFamily="34" charset="-120"/>
+                <a:latin typeface="Arial" pitchFamily="34" charset="0"/>
+                <a:ea typeface="Arial" pitchFamily="34" charset="-122"/>
+                <a:cs typeface="Arial" pitchFamily="34" charset="-120"/>
               </a:rPr>
               <a:t>Dosis correcta</a:t>
             </a:r>
@@ -13679,6 +14092,9 @@
                 <a:solidFill>
                   <a:srgbClr val="475569"/>
                 </a:solidFill>
+                <a:latin typeface="Calibri" pitchFamily="34" charset="0"/>
+                <a:ea typeface="Calibri" pitchFamily="34" charset="-122"/>
+                <a:cs typeface="Calibri" pitchFamily="34" charset="-120"/>
               </a:rPr>
               <a:t>Confirma la concentración (500 mg vs 1000 mg) y evita errores LASA (Look-Alike, Sound-Alike).</a:t>
             </a:r>
@@ -13699,7 +14115,7 @@
           </a:xfrm>
           <a:prstGeom prst="roundRect">
             <a:avLst>
-              <a:gd name="adj" fmla="val 171429"/>
+              <a:gd name="adj" fmla="val 50000"/>
             </a:avLst>
           </a:prstGeom>
           <a:solidFill>
@@ -13830,9 +14246,9 @@
                 <a:solidFill>
                   <a:schemeClr val="bg1"/>
                 </a:solidFill>
-                <a:latin typeface="+mj-lt" pitchFamily="34" charset="0"/>
-                <a:ea typeface="+mj-lt" pitchFamily="34" charset="-122"/>
-                <a:cs typeface="+mj-lt" pitchFamily="34" charset="-120"/>
+                <a:latin typeface="Arial" pitchFamily="34" charset="0"/>
+                <a:ea typeface="Arial" pitchFamily="34" charset="-122"/>
+                <a:cs typeface="Arial" pitchFamily="34" charset="-120"/>
               </a:rPr>
               <a:t>4</a:t>
             </a:r>
@@ -13869,9 +14285,9 @@
                 <a:solidFill>
                   <a:schemeClr val="tx2"/>
                 </a:solidFill>
-                <a:latin typeface="+mj-lt" pitchFamily="34" charset="0"/>
-                <a:ea typeface="+mj-lt" pitchFamily="34" charset="-122"/>
-                <a:cs typeface="+mj-lt" pitchFamily="34" charset="-120"/>
+                <a:latin typeface="Arial" pitchFamily="34" charset="0"/>
+                <a:ea typeface="Arial" pitchFamily="34" charset="-122"/>
+                <a:cs typeface="Arial" pitchFamily="34" charset="-120"/>
               </a:rPr>
               <a:t>Vía y hora correctas</a:t>
             </a:r>
@@ -13908,6 +14324,9 @@
                 <a:solidFill>
                   <a:srgbClr val="475569"/>
                 </a:solidFill>
+                <a:latin typeface="Calibri" pitchFamily="34" charset="0"/>
+                <a:ea typeface="Calibri" pitchFamily="34" charset="-122"/>
+                <a:cs typeface="Calibri" pitchFamily="34" charset="-120"/>
               </a:rPr>
               <a:t>Registro automático en la Historia Clínica Electrónica.</a:t>
             </a:r>
@@ -13928,7 +14347,7 @@
           </a:xfrm>
           <a:prstGeom prst="roundRect">
             <a:avLst>
-              <a:gd name="adj" fmla="val 171429"/>
+              <a:gd name="adj" fmla="val 50000"/>
             </a:avLst>
           </a:prstGeom>
           <a:solidFill>
@@ -14059,9 +14478,9 @@
                 <a:solidFill>
                   <a:schemeClr val="bg1"/>
                 </a:solidFill>
-                <a:latin typeface="+mj-lt" pitchFamily="34" charset="0"/>
-                <a:ea typeface="+mj-lt" pitchFamily="34" charset="-122"/>
-                <a:cs typeface="+mj-lt" pitchFamily="34" charset="-120"/>
+                <a:latin typeface="Arial" pitchFamily="34" charset="0"/>
+                <a:ea typeface="Arial" pitchFamily="34" charset="-122"/>
+                <a:cs typeface="Arial" pitchFamily="34" charset="-120"/>
               </a:rPr>
               <a:t>5</a:t>
             </a:r>
@@ -14098,9 +14517,9 @@
                 <a:solidFill>
                   <a:schemeClr val="tx2"/>
                 </a:solidFill>
-                <a:latin typeface="+mj-lt" pitchFamily="34" charset="0"/>
-                <a:ea typeface="+mj-lt" pitchFamily="34" charset="-122"/>
-                <a:cs typeface="+mj-lt" pitchFamily="34" charset="-120"/>
+                <a:latin typeface="Arial" pitchFamily="34" charset="0"/>
+                <a:ea typeface="Arial" pitchFamily="34" charset="-122"/>
+                <a:cs typeface="Arial" pitchFamily="34" charset="-120"/>
               </a:rPr>
               <a:t>Vigencia garantizada</a:t>
             </a:r>
@@ -14137,6 +14556,9 @@
                 <a:solidFill>
                   <a:srgbClr val="475569"/>
                 </a:solidFill>
+                <a:latin typeface="Calibri" pitchFamily="34" charset="0"/>
+                <a:ea typeface="Calibri" pitchFamily="34" charset="-122"/>
+                <a:cs typeface="Calibri" pitchFamily="34" charset="-120"/>
               </a:rPr>
               <a:t>El sistema bloquea la dosis si (17) indica vencido o si el lote (10) tiene alerta de retiro.</a:t>
             </a:r>
@@ -14157,7 +14579,7 @@
           </a:xfrm>
           <a:prstGeom prst="roundRect">
             <a:avLst>
-              <a:gd name="adj" fmla="val 171429"/>
+              <a:gd name="adj" fmla="val 50000"/>
             </a:avLst>
           </a:prstGeom>
           <a:solidFill>
@@ -14304,6 +14726,9 @@
                 <a:solidFill>
                   <a:schemeClr val="accent2"/>
                 </a:solidFill>
+                <a:latin typeface="Calibri" pitchFamily="34" charset="0"/>
+                <a:ea typeface="Calibri" pitchFamily="34" charset="-122"/>
+                <a:cs typeface="Calibri" pitchFamily="34" charset="-120"/>
               </a:rPr>
               <a:t>AGENDA · PUNTO 2</a:t>
             </a:r>
@@ -14342,9 +14767,9 @@
                 <a:solidFill>
                   <a:schemeClr val="tx2"/>
                 </a:solidFill>
-                <a:latin typeface="+mj-lt" pitchFamily="34" charset="0"/>
-                <a:ea typeface="+mj-lt" pitchFamily="34" charset="-122"/>
-                <a:cs typeface="+mj-lt" pitchFamily="34" charset="-120"/>
+                <a:latin typeface="Arial" pitchFamily="34" charset="0"/>
+                <a:ea typeface="Arial" pitchFamily="34" charset="-122"/>
+                <a:cs typeface="Arial" pitchFamily="34" charset="-120"/>
               </a:rPr>
               <a:t>Eficiencia de la </a:t>
             </a:r>
@@ -14356,9 +14781,9 @@
                 <a:solidFill>
                   <a:schemeClr val="accent1"/>
                 </a:solidFill>
-                <a:latin typeface="+mj-lt" pitchFamily="34" charset="0"/>
-                <a:ea typeface="+mj-lt" pitchFamily="34" charset="-122"/>
-                <a:cs typeface="+mj-lt" pitchFamily="34" charset="-120"/>
+                <a:latin typeface="Arial" pitchFamily="34" charset="0"/>
+                <a:ea typeface="Arial" pitchFamily="34" charset="-122"/>
+                <a:cs typeface="Arial" pitchFamily="34" charset="-120"/>
               </a:rPr>
               <a:t>cadena de suministro</a:t>
             </a:r>
@@ -14395,6 +14820,9 @@
                 <a:solidFill>
                   <a:srgbClr val="64748B"/>
                 </a:solidFill>
+                <a:latin typeface="Calibri" pitchFamily="34" charset="0"/>
+                <a:ea typeface="Calibri" pitchFamily="34" charset="-122"/>
+                <a:cs typeface="Calibri" pitchFamily="34" charset="-120"/>
               </a:rPr>
               <a:t>Un mismo lenguaje GS1 desde el laboratorio hasta el paciente en Venezuela</a:t>
             </a:r>
@@ -14487,9 +14915,9 @@
                 <a:solidFill>
                   <a:schemeClr val="tx2"/>
                 </a:solidFill>
-                <a:latin typeface="+mj-lt" pitchFamily="34" charset="0"/>
-                <a:ea typeface="+mj-lt" pitchFamily="34" charset="-122"/>
-                <a:cs typeface="+mj-lt" pitchFamily="34" charset="-120"/>
+                <a:latin typeface="Arial" pitchFamily="34" charset="0"/>
+                <a:ea typeface="Arial" pitchFamily="34" charset="-122"/>
+                <a:cs typeface="Arial" pitchFamily="34" charset="-120"/>
               </a:rPr>
               <a:t>Laboratorio</a:t>
             </a:r>
@@ -14510,7 +14938,7 @@
           </a:xfrm>
           <a:prstGeom prst="roundRect">
             <a:avLst>
-              <a:gd name="adj" fmla="val 160000"/>
+              <a:gd name="adj" fmla="val 50000"/>
             </a:avLst>
           </a:prstGeom>
           <a:solidFill>
@@ -14663,9 +15091,9 @@
                 <a:solidFill>
                   <a:schemeClr val="tx2"/>
                 </a:solidFill>
-                <a:latin typeface="+mj-lt" pitchFamily="34" charset="0"/>
-                <a:ea typeface="+mj-lt" pitchFamily="34" charset="-122"/>
-                <a:cs typeface="+mj-lt" pitchFamily="34" charset="-120"/>
+                <a:latin typeface="Arial" pitchFamily="34" charset="0"/>
+                <a:ea typeface="Arial" pitchFamily="34" charset="-122"/>
+                <a:cs typeface="Arial" pitchFamily="34" charset="-120"/>
               </a:rPr>
               <a:t>Droguería / Distribuidor</a:t>
             </a:r>
@@ -14686,7 +15114,7 @@
           </a:xfrm>
           <a:prstGeom prst="roundRect">
             <a:avLst>
-              <a:gd name="adj" fmla="val 160000"/>
+              <a:gd name="adj" fmla="val 50000"/>
             </a:avLst>
           </a:prstGeom>
           <a:solidFill>
@@ -14839,9 +15267,9 @@
                 <a:solidFill>
                   <a:schemeClr val="tx2"/>
                 </a:solidFill>
-                <a:latin typeface="+mj-lt" pitchFamily="34" charset="0"/>
-                <a:ea typeface="+mj-lt" pitchFamily="34" charset="-122"/>
-                <a:cs typeface="+mj-lt" pitchFamily="34" charset="-120"/>
+                <a:latin typeface="Arial" pitchFamily="34" charset="0"/>
+                <a:ea typeface="Arial" pitchFamily="34" charset="-122"/>
+                <a:cs typeface="Arial" pitchFamily="34" charset="-120"/>
               </a:rPr>
               <a:t>Farmacia / Clínica</a:t>
             </a:r>
@@ -14862,7 +15290,7 @@
           </a:xfrm>
           <a:prstGeom prst="roundRect">
             <a:avLst>
-              <a:gd name="adj" fmla="val 160000"/>
+              <a:gd name="adj" fmla="val 50000"/>
             </a:avLst>
           </a:prstGeom>
           <a:solidFill>
@@ -15015,9 +15443,9 @@
                 <a:solidFill>
                   <a:schemeClr val="tx2"/>
                 </a:solidFill>
-                <a:latin typeface="+mj-lt" pitchFamily="34" charset="0"/>
-                <a:ea typeface="+mj-lt" pitchFamily="34" charset="-122"/>
-                <a:cs typeface="+mj-lt" pitchFamily="34" charset="-120"/>
+                <a:latin typeface="Arial" pitchFamily="34" charset="0"/>
+                <a:ea typeface="Arial" pitchFamily="34" charset="-122"/>
+                <a:cs typeface="Arial" pitchFamily="34" charset="-120"/>
               </a:rPr>
               <a:t>Paciente</a:t>
             </a:r>
@@ -15038,7 +15466,7 @@
           </a:xfrm>
           <a:prstGeom prst="roundRect">
             <a:avLst>
-              <a:gd name="adj" fmla="val 160000"/>
+              <a:gd name="adj" fmla="val 50000"/>
             </a:avLst>
           </a:prstGeom>
           <a:solidFill>
@@ -15131,9 +15559,9 @@
             <a:off x="590550" y="3333750"/>
             <a:ext cx="2400300" cy="76200"/>
           </a:xfrm>
-          <a:prstGeom prst="round2SameRect">
+          <a:prstGeom prst="roundRect">
             <a:avLst>
-              <a:gd name="adj" fmla="val 600000"/>
+              <a:gd name="adj" fmla="val 50000"/>
             </a:avLst>
           </a:prstGeom>
           <a:solidFill>
@@ -15144,7 +15572,27 @@
       </p:sp>
       <p:sp>
         <p:nvSpPr>
-          <p:cNvPr id="30" name="Icono Eye"/>
+          <p:cNvPr id="30" name="Barra de color (base)"/>
+          <p:cNvSpPr/>
+          <p:nvPr/>
+        </p:nvSpPr>
+        <p:spPr>
+          <a:xfrm>
+            <a:off x="590550" y="3371850"/>
+            <a:ext cx="2400300" cy="38100"/>
+          </a:xfrm>
+          <a:prstGeom prst="rect">
+            <a:avLst/>
+          </a:prstGeom>
+          <a:solidFill>
+            <a:schemeClr val="accent1"/>
+          </a:solidFill>
+          <a:ln/>
+        </p:spPr>
+      </p:sp>
+      <p:sp>
+        <p:nvSpPr>
+          <p:cNvPr id="31" name="Icono Eye"/>
           <p:cNvSpPr/>
           <p:nvPr/>
         </p:nvSpPr>
@@ -15164,7 +15612,7 @@
       </p:sp>
       <p:pic>
         <p:nvPicPr>
-          <p:cNvPr id="31" name="Image 4" descr="Icono Eye">    </p:cNvPr>
+          <p:cNvPr id="32" name="Image 4" descr="Icono Eye">    </p:cNvPr>
           <p:cNvPicPr>
             <a:picLocks noChangeAspect="1"/>
           </p:cNvPicPr>
@@ -15188,7 +15636,7 @@
       </p:pic>
       <p:sp>
         <p:nvSpPr>
-          <p:cNvPr id="32" name="Text 25"/>
+          <p:cNvPr id="33" name="Text 26"/>
           <p:cNvSpPr txBox="1"/>
           <p:nvPr/>
         </p:nvSpPr>
@@ -15215,9 +15663,9 @@
                 <a:solidFill>
                   <a:schemeClr val="tx2"/>
                 </a:solidFill>
-                <a:latin typeface="+mj-lt" pitchFamily="34" charset="0"/>
-                <a:ea typeface="+mj-lt" pitchFamily="34" charset="-122"/>
-                <a:cs typeface="+mj-lt" pitchFamily="34" charset="-120"/>
+                <a:latin typeface="Arial" pitchFamily="34" charset="0"/>
+                <a:ea typeface="Arial" pitchFamily="34" charset="-122"/>
+                <a:cs typeface="Arial" pitchFamily="34" charset="-120"/>
               </a:rPr>
               <a:t>Visibilidad en tiempo real</a:t>
             </a:r>
@@ -15227,7 +15675,7 @@
       </p:sp>
       <p:sp>
         <p:nvSpPr>
-          <p:cNvPr id="33" name="Text 26"/>
+          <p:cNvPr id="34" name="Text 27"/>
           <p:cNvSpPr txBox="1"/>
           <p:nvPr/>
         </p:nvSpPr>
@@ -15254,6 +15702,9 @@
                 <a:solidFill>
                   <a:srgbClr val="475569"/>
                 </a:solidFill>
+                <a:latin typeface="Calibri" pitchFamily="34" charset="0"/>
+                <a:ea typeface="Calibri" pitchFamily="34" charset="-122"/>
+                <a:cs typeface="Calibri" pitchFamily="34" charset="-120"/>
               </a:rPr>
               <a:t>Cada movimiento se registra con EPCIS 2.0 y es consultable por los socios autorizados.</a:t>
             </a:r>
@@ -15263,7 +15714,7 @@
       </p:sp>
       <p:sp>
         <p:nvSpPr>
-          <p:cNvPr id="34" name="Tarjeta"/>
+          <p:cNvPr id="35" name="Tarjeta"/>
           <p:cNvSpPr/>
           <p:nvPr/>
         </p:nvSpPr>
@@ -15297,7 +15748,7 @@
       </p:sp>
       <p:sp>
         <p:nvSpPr>
-          <p:cNvPr id="35" name="Barra de color"/>
+          <p:cNvPr id="36" name="Barra de color"/>
           <p:cNvSpPr/>
           <p:nvPr/>
         </p:nvSpPr>
@@ -15306,9 +15757,9 @@
             <a:off x="3460718" y="3333750"/>
             <a:ext cx="2400300" cy="76200"/>
           </a:xfrm>
-          <a:prstGeom prst="round2SameRect">
+          <a:prstGeom prst="roundRect">
             <a:avLst>
-              <a:gd name="adj" fmla="val 600000"/>
+              <a:gd name="adj" fmla="val 50000"/>
             </a:avLst>
           </a:prstGeom>
           <a:solidFill>
@@ -15319,7 +15770,27 @@
       </p:sp>
       <p:sp>
         <p:nvSpPr>
-          <p:cNvPr id="36" name="Icono Hourglass"/>
+          <p:cNvPr id="37" name="Barra de color (base)"/>
+          <p:cNvSpPr/>
+          <p:nvPr/>
+        </p:nvSpPr>
+        <p:spPr>
+          <a:xfrm>
+            <a:off x="3460718" y="3371850"/>
+            <a:ext cx="2400300" cy="38100"/>
+          </a:xfrm>
+          <a:prstGeom prst="rect">
+            <a:avLst/>
+          </a:prstGeom>
+          <a:solidFill>
+            <a:schemeClr val="accent2"/>
+          </a:solidFill>
+          <a:ln/>
+        </p:spPr>
+      </p:sp>
+      <p:sp>
+        <p:nvSpPr>
+          <p:cNvPr id="38" name="Icono Hourglass"/>
           <p:cNvSpPr/>
           <p:nvPr/>
         </p:nvSpPr>
@@ -15339,7 +15810,7 @@
       </p:sp>
       <p:pic>
         <p:nvPicPr>
-          <p:cNvPr id="37" name="Image 5" descr="Icono Hourglass">    </p:cNvPr>
+          <p:cNvPr id="39" name="Image 5" descr="Icono Hourglass">    </p:cNvPr>
           <p:cNvPicPr>
             <a:picLocks noChangeAspect="1"/>
           </p:cNvPicPr>
@@ -15363,7 +15834,7 @@
       </p:pic>
       <p:sp>
         <p:nvSpPr>
-          <p:cNvPr id="38" name="Text 30"/>
+          <p:cNvPr id="40" name="Text 32"/>
           <p:cNvSpPr txBox="1"/>
           <p:nvPr/>
         </p:nvSpPr>
@@ -15390,9 +15861,9 @@
                 <a:solidFill>
                   <a:schemeClr val="tx2"/>
                 </a:solidFill>
-                <a:latin typeface="+mj-lt" pitchFamily="34" charset="0"/>
-                <a:ea typeface="+mj-lt" pitchFamily="34" charset="-122"/>
-                <a:cs typeface="+mj-lt" pitchFamily="34" charset="-120"/>
+                <a:latin typeface="Arial" pitchFamily="34" charset="0"/>
+                <a:ea typeface="Arial" pitchFamily="34" charset="-122"/>
+                <a:cs typeface="Arial" pitchFamily="34" charset="-120"/>
               </a:rPr>
               <a:t>Vencimientos FEFO</a:t>
             </a:r>
@@ -15402,7 +15873,7 @@
       </p:sp>
       <p:sp>
         <p:nvSpPr>
-          <p:cNvPr id="39" name="Text 31"/>
+          <p:cNvPr id="41" name="Text 33"/>
           <p:cNvSpPr txBox="1"/>
           <p:nvPr/>
         </p:nvSpPr>
@@ -15429,6 +15900,9 @@
                 <a:solidFill>
                   <a:srgbClr val="475569"/>
                 </a:solidFill>
+                <a:latin typeface="Calibri" pitchFamily="34" charset="0"/>
+                <a:ea typeface="Calibri" pitchFamily="34" charset="-122"/>
+                <a:cs typeface="Calibri" pitchFamily="34" charset="-120"/>
               </a:rPr>
               <a:t>Se despacha primero lo que vence primero, con lote y fecha leídos del código.</a:t>
             </a:r>
@@ -15438,7 +15912,7 @@
       </p:sp>
       <p:sp>
         <p:nvSpPr>
-          <p:cNvPr id="40" name="Tarjeta"/>
+          <p:cNvPr id="42" name="Tarjeta"/>
           <p:cNvSpPr/>
           <p:nvPr/>
         </p:nvSpPr>
@@ -15472,7 +15946,7 @@
       </p:sp>
       <p:sp>
         <p:nvSpPr>
-          <p:cNvPr id="41" name="Barra de color"/>
+          <p:cNvPr id="43" name="Barra de color"/>
           <p:cNvSpPr/>
           <p:nvPr/>
         </p:nvSpPr>
@@ -15481,9 +15955,9 @@
             <a:off x="6330886" y="3333750"/>
             <a:ext cx="2400300" cy="76200"/>
           </a:xfrm>
-          <a:prstGeom prst="round2SameRect">
+          <a:prstGeom prst="roundRect">
             <a:avLst>
-              <a:gd name="adj" fmla="val 600000"/>
+              <a:gd name="adj" fmla="val 50000"/>
             </a:avLst>
           </a:prstGeom>
           <a:solidFill>
@@ -15494,7 +15968,27 @@
       </p:sp>
       <p:sp>
         <p:nvSpPr>
-          <p:cNvPr id="42" name="Icono Undo2"/>
+          <p:cNvPr id="44" name="Barra de color (base)"/>
+          <p:cNvSpPr/>
+          <p:nvPr/>
+        </p:nvSpPr>
+        <p:spPr>
+          <a:xfrm>
+            <a:off x="6330886" y="3371850"/>
+            <a:ext cx="2400300" cy="38100"/>
+          </a:xfrm>
+          <a:prstGeom prst="rect">
+            <a:avLst/>
+          </a:prstGeom>
+          <a:solidFill>
+            <a:schemeClr val="accent3"/>
+          </a:solidFill>
+          <a:ln/>
+        </p:spPr>
+      </p:sp>
+      <p:sp>
+        <p:nvSpPr>
+          <p:cNvPr id="45" name="Icono Undo2"/>
           <p:cNvSpPr/>
           <p:nvPr/>
         </p:nvSpPr>
@@ -15514,7 +16008,7 @@
       </p:sp>
       <p:pic>
         <p:nvPicPr>
-          <p:cNvPr id="43" name="Image 6" descr="Icono Undo2">    </p:cNvPr>
+          <p:cNvPr id="46" name="Image 6" descr="Icono Undo2">    </p:cNvPr>
           <p:cNvPicPr>
             <a:picLocks noChangeAspect="1"/>
           </p:cNvPicPr>
@@ -15538,7 +16032,7 @@
       </p:pic>
       <p:sp>
         <p:nvSpPr>
-          <p:cNvPr id="44" name="Text 35"/>
+          <p:cNvPr id="47" name="Text 38"/>
           <p:cNvSpPr txBox="1"/>
           <p:nvPr/>
         </p:nvSpPr>
@@ -15565,9 +16059,9 @@
                 <a:solidFill>
                   <a:schemeClr val="tx2"/>
                 </a:solidFill>
-                <a:latin typeface="+mj-lt" pitchFamily="34" charset="0"/>
-                <a:ea typeface="+mj-lt" pitchFamily="34" charset="-122"/>
-                <a:cs typeface="+mj-lt" pitchFamily="34" charset="-120"/>
+                <a:latin typeface="Arial" pitchFamily="34" charset="0"/>
+                <a:ea typeface="Arial" pitchFamily="34" charset="-122"/>
+                <a:cs typeface="Arial" pitchFamily="34" charset="-120"/>
               </a:rPr>
               <a:t>Retiro de lotes ágil</a:t>
             </a:r>
@@ -15577,7 +16071,7 @@
       </p:sp>
       <p:sp>
         <p:nvSpPr>
-          <p:cNvPr id="45" name="Text 36"/>
+          <p:cNvPr id="48" name="Text 39"/>
           <p:cNvSpPr txBox="1"/>
           <p:nvPr/>
         </p:nvSpPr>
@@ -15604,6 +16098,9 @@
                 <a:solidFill>
                   <a:srgbClr val="475569"/>
                 </a:solidFill>
+                <a:latin typeface="Calibri" pitchFamily="34" charset="0"/>
+                <a:ea typeface="Calibri" pitchFamily="34" charset="-122"/>
+                <a:cs typeface="Calibri" pitchFamily="34" charset="-120"/>
               </a:rPr>
               <a:t>Un recall se ubica por lote y GLN en minutos, sin revisar inventario caja por caja.</a:t>
             </a:r>
@@ -15613,7 +16110,7 @@
       </p:sp>
       <p:sp>
         <p:nvSpPr>
-          <p:cNvPr id="46" name="Tarjeta"/>
+          <p:cNvPr id="49" name="Tarjeta"/>
           <p:cNvSpPr/>
           <p:nvPr/>
         </p:nvSpPr>
@@ -15647,7 +16144,7 @@
       </p:sp>
       <p:sp>
         <p:nvSpPr>
-          <p:cNvPr id="47" name="Barra de color"/>
+          <p:cNvPr id="50" name="Barra de color"/>
           <p:cNvSpPr/>
           <p:nvPr/>
         </p:nvSpPr>
@@ -15656,9 +16153,9 @@
             <a:off x="9201055" y="3333750"/>
             <a:ext cx="2400300" cy="76200"/>
           </a:xfrm>
-          <a:prstGeom prst="round2SameRect">
+          <a:prstGeom prst="roundRect">
             <a:avLst>
-              <a:gd name="adj" fmla="val 600000"/>
+              <a:gd name="adj" fmla="val 50000"/>
             </a:avLst>
           </a:prstGeom>
           <a:solidFill>
@@ -15669,7 +16166,27 @@
       </p:sp>
       <p:sp>
         <p:nvSpPr>
-          <p:cNvPr id="48" name="Icono Snowflake"/>
+          <p:cNvPr id="51" name="Barra de color (base)"/>
+          <p:cNvSpPr/>
+          <p:nvPr/>
+        </p:nvSpPr>
+        <p:spPr>
+          <a:xfrm>
+            <a:off x="9201055" y="3371850"/>
+            <a:ext cx="2400300" cy="38100"/>
+          </a:xfrm>
+          <a:prstGeom prst="rect">
+            <a:avLst/>
+          </a:prstGeom>
+          <a:solidFill>
+            <a:schemeClr val="tx2"/>
+          </a:solidFill>
+          <a:ln/>
+        </p:spPr>
+      </p:sp>
+      <p:sp>
+        <p:nvSpPr>
+          <p:cNvPr id="52" name="Icono Snowflake"/>
           <p:cNvSpPr/>
           <p:nvPr/>
         </p:nvSpPr>
@@ -15689,7 +16206,7 @@
       </p:sp>
       <p:pic>
         <p:nvPicPr>
-          <p:cNvPr id="49" name="Image 7" descr="Icono Snowflake">    </p:cNvPr>
+          <p:cNvPr id="53" name="Image 7" descr="Icono Snowflake">    </p:cNvPr>
           <p:cNvPicPr>
             <a:picLocks noChangeAspect="1"/>
           </p:cNvPicPr>
@@ -15713,7 +16230,7 @@
       </p:pic>
       <p:sp>
         <p:nvSpPr>
-          <p:cNvPr id="50" name="Text 40"/>
+          <p:cNvPr id="54" name="Text 44"/>
           <p:cNvSpPr txBox="1"/>
           <p:nvPr/>
         </p:nvSpPr>
@@ -15740,9 +16257,9 @@
                 <a:solidFill>
                   <a:schemeClr val="tx2"/>
                 </a:solidFill>
-                <a:latin typeface="+mj-lt" pitchFamily="34" charset="0"/>
-                <a:ea typeface="+mj-lt" pitchFamily="34" charset="-122"/>
-                <a:cs typeface="+mj-lt" pitchFamily="34" charset="-120"/>
+                <a:latin typeface="Arial" pitchFamily="34" charset="0"/>
+                <a:ea typeface="Arial" pitchFamily="34" charset="-122"/>
+                <a:cs typeface="Arial" pitchFamily="34" charset="-120"/>
               </a:rPr>
               <a:t>Cadena de frío</a:t>
             </a:r>
@@ -15752,7 +16269,7 @@
       </p:sp>
       <p:sp>
         <p:nvSpPr>
-          <p:cNvPr id="51" name="Text 41"/>
+          <p:cNvPr id="55" name="Text 45"/>
           <p:cNvSpPr txBox="1"/>
           <p:nvPr/>
         </p:nvSpPr>
@@ -15779,6 +16296,9 @@
                 <a:solidFill>
                   <a:srgbClr val="475569"/>
                 </a:solidFill>
+                <a:latin typeface="Calibri" pitchFamily="34" charset="0"/>
+                <a:ea typeface="Calibri" pitchFamily="34" charset="-122"/>
+                <a:cs typeface="Calibri" pitchFamily="34" charset="-120"/>
               </a:rPr>
               <a:t>Alertas ante desvíos de temperatura en insulinas, vacunas y biológicos.</a:t>
             </a:r>
@@ -15885,6 +16405,9 @@
                 <a:solidFill>
                   <a:schemeClr val="accent2"/>
                 </a:solidFill>
+                <a:latin typeface="Calibri" pitchFamily="34" charset="0"/>
+                <a:ea typeface="Calibri" pitchFamily="34" charset="-122"/>
+                <a:cs typeface="Calibri" pitchFamily="34" charset="-120"/>
               </a:rPr>
               <a:t>AGENDA · PUNTO 2 · TRAZABILIDAD DE MEDICAMENTOS</a:t>
             </a:r>
@@ -15923,9 +16446,9 @@
                 <a:solidFill>
                   <a:schemeClr val="tx2"/>
                 </a:solidFill>
-                <a:latin typeface="+mj-lt" pitchFamily="34" charset="0"/>
-                <a:ea typeface="+mj-lt" pitchFamily="34" charset="-122"/>
-                <a:cs typeface="+mj-lt" pitchFamily="34" charset="-120"/>
+                <a:latin typeface="Arial" pitchFamily="34" charset="0"/>
+                <a:ea typeface="Arial" pitchFamily="34" charset="-122"/>
+                <a:cs typeface="Arial" pitchFamily="34" charset="-120"/>
               </a:rPr>
               <a:t>De la barra tradicional al </a:t>
             </a:r>
@@ -15937,9 +16460,9 @@
                 <a:solidFill>
                   <a:schemeClr val="accent1"/>
                 </a:solidFill>
-                <a:latin typeface="+mj-lt" pitchFamily="34" charset="0"/>
-                <a:ea typeface="+mj-lt" pitchFamily="34" charset="-122"/>
-                <a:cs typeface="+mj-lt" pitchFamily="34" charset="-120"/>
+                <a:latin typeface="Arial" pitchFamily="34" charset="0"/>
+                <a:ea typeface="Arial" pitchFamily="34" charset="-122"/>
+                <a:cs typeface="Arial" pitchFamily="34" charset="-120"/>
               </a:rPr>
               <a:t>estándar 2D en salud</a:t>
             </a:r>
@@ -15994,7 +16517,7 @@
           </a:xfrm>
           <a:prstGeom prst="roundRect">
             <a:avLst>
-              <a:gd name="adj" fmla="val 184615"/>
+              <a:gd name="adj" fmla="val 50000"/>
             </a:avLst>
           </a:prstGeom>
           <a:solidFill>
@@ -16032,6 +16555,9 @@
                 <a:solidFill>
                   <a:srgbClr val="475569"/>
                 </a:solidFill>
+                <a:latin typeface="Calibri" pitchFamily="34" charset="0"/>
+                <a:ea typeface="Calibri" pitchFamily="34" charset="-122"/>
+                <a:cs typeface="Calibri" pitchFamily="34" charset="-120"/>
               </a:rPr>
               <a:t>1973 – 2022 · Hasta ahora</a:t>
             </a:r>
@@ -16092,9 +16618,9 @@
                 <a:solidFill>
                   <a:schemeClr val="tx2"/>
                 </a:solidFill>
-                <a:latin typeface="+mj-lt" pitchFamily="34" charset="0"/>
-                <a:ea typeface="+mj-lt" pitchFamily="34" charset="-122"/>
-                <a:cs typeface="+mj-lt" pitchFamily="34" charset="-120"/>
+                <a:latin typeface="Arial" pitchFamily="34" charset="0"/>
+                <a:ea typeface="Arial" pitchFamily="34" charset="-122"/>
+                <a:cs typeface="Arial" pitchFamily="34" charset="-120"/>
               </a:rPr>
               <a:t>EAN-13 · código 1D</a:t>
             </a:r>
@@ -16131,6 +16657,9 @@
                 <a:solidFill>
                   <a:srgbClr val="475569"/>
                 </a:solidFill>
+                <a:latin typeface="Calibri" pitchFamily="34" charset="0"/>
+                <a:ea typeface="Calibri" pitchFamily="34" charset="-122"/>
+                <a:cs typeface="Calibri" pitchFamily="34" charset="-120"/>
               </a:rPr>
               <a:t>Solo identifica el GTIN, de forma estática.</a:t>
             </a:r>
@@ -16185,7 +16714,7 @@
           </a:xfrm>
           <a:prstGeom prst="roundRect">
             <a:avLst>
-              <a:gd name="adj" fmla="val 184615"/>
+              <a:gd name="adj" fmla="val 50000"/>
             </a:avLst>
           </a:prstGeom>
           <a:solidFill>
@@ -16223,6 +16752,9 @@
                 <a:solidFill>
                   <a:schemeClr val="accent2"/>
                 </a:solidFill>
+                <a:latin typeface="Calibri" pitchFamily="34" charset="0"/>
+                <a:ea typeface="Calibri" pitchFamily="34" charset="-122"/>
+                <a:cs typeface="Calibri" pitchFamily="34" charset="-120"/>
               </a:rPr>
               <a:t>2023 – 2026 · Transición dual</a:t>
             </a:r>
@@ -16307,9 +16839,9 @@
                 <a:solidFill>
                   <a:schemeClr val="tx2"/>
                 </a:solidFill>
-                <a:latin typeface="+mj-lt" pitchFamily="34" charset="0"/>
-                <a:ea typeface="+mj-lt" pitchFamily="34" charset="-122"/>
-                <a:cs typeface="+mj-lt" pitchFamily="34" charset="-120"/>
+                <a:latin typeface="Arial" pitchFamily="34" charset="0"/>
+                <a:ea typeface="Arial" pitchFamily="34" charset="-122"/>
+                <a:cs typeface="Arial" pitchFamily="34" charset="-120"/>
               </a:rPr>
               <a:t>Coexisten 1D + 2D</a:t>
             </a:r>
@@ -16346,6 +16878,9 @@
                 <a:solidFill>
                   <a:srgbClr val="475569"/>
                 </a:solidFill>
+                <a:latin typeface="Calibri" pitchFamily="34" charset="0"/>
+                <a:ea typeface="Calibri" pitchFamily="34" charset="-122"/>
+                <a:cs typeface="Calibri" pitchFamily="34" charset="-120"/>
               </a:rPr>
               <a:t>Se preparan lectores ópticos en farmacias y centros de salud.</a:t>
             </a:r>
@@ -16400,7 +16935,7 @@
           </a:xfrm>
           <a:prstGeom prst="roundRect">
             <a:avLst>
-              <a:gd name="adj" fmla="val 184615"/>
+              <a:gd name="adj" fmla="val 50000"/>
             </a:avLst>
           </a:prstGeom>
           <a:solidFill>
@@ -16438,6 +16973,9 @@
                 <a:solidFill>
                   <a:schemeClr val="bg1"/>
                 </a:solidFill>
+                <a:latin typeface="Calibri" pitchFamily="34" charset="0"/>
+                <a:ea typeface="Calibri" pitchFamily="34" charset="-122"/>
+                <a:cs typeface="Calibri" pitchFamily="34" charset="-120"/>
               </a:rPr>
               <a:t>2027+ · Ambición global y Healthcare</a:t>
             </a:r>
@@ -16522,9 +17060,9 @@
                 <a:solidFill>
                   <a:schemeClr val="tx2"/>
                 </a:solidFill>
-                <a:latin typeface="+mj-lt" pitchFamily="34" charset="0"/>
-                <a:ea typeface="+mj-lt" pitchFamily="34" charset="-122"/>
-                <a:cs typeface="+mj-lt" pitchFamily="34" charset="-120"/>
+                <a:latin typeface="Arial" pitchFamily="34" charset="0"/>
+                <a:ea typeface="Arial" pitchFamily="34" charset="-122"/>
+                <a:cs typeface="Arial" pitchFamily="34" charset="-120"/>
               </a:rPr>
               <a:t>GS1 DataMatrix + QR Digital Link</a:t>
             </a:r>
@@ -16561,6 +17099,9 @@
                 <a:solidFill>
                   <a:srgbClr val="475569"/>
                 </a:solidFill>
+                <a:latin typeface="Calibri" pitchFamily="34" charset="0"/>
+                <a:ea typeface="Calibri" pitchFamily="34" charset="-122"/>
+                <a:cs typeface="Calibri" pitchFamily="34" charset="-120"/>
               </a:rPr>
               <a:t>Trazabilidad clínica/regulatoria + interacción con el paciente.</a:t>
             </a:r>
@@ -16724,6 +17265,9 @@
                 <a:solidFill>
                   <a:schemeClr val="tx2"/>
                 </a:solidFill>
+                <a:latin typeface="Calibri" pitchFamily="34" charset="0"/>
+                <a:ea typeface="Calibri" pitchFamily="34" charset="-122"/>
+                <a:cs typeface="Calibri" pitchFamily="34" charset="-120"/>
               </a:rPr>
               <a:t>GTIN · </a:t>
             </a:r>
@@ -16735,6 +17279,9 @@
                 <a:solidFill>
                   <a:srgbClr val="475569"/>
                 </a:solidFill>
+                <a:latin typeface="Calibri" pitchFamily="34" charset="0"/>
+                <a:ea typeface="Calibri" pitchFamily="34" charset="-122"/>
+                <a:cs typeface="Calibri" pitchFamily="34" charset="-120"/>
               </a:rPr>
               <a:t>ID único del medicamento (prefijo 759 GS1 Venezuela)</a:t>
             </a:r>
@@ -16858,6 +17405,9 @@
                 <a:solidFill>
                   <a:schemeClr val="tx2"/>
                 </a:solidFill>
+                <a:latin typeface="Calibri" pitchFamily="34" charset="0"/>
+                <a:ea typeface="Calibri" pitchFamily="34" charset="-122"/>
+                <a:cs typeface="Calibri" pitchFamily="34" charset="-120"/>
               </a:rPr>
               <a:t>Vencimiento · </a:t>
             </a:r>
@@ -16869,6 +17419,9 @@
                 <a:solidFill>
                   <a:srgbClr val="475569"/>
                 </a:solidFill>
+                <a:latin typeface="Calibri" pitchFamily="34" charset="0"/>
+                <a:ea typeface="Calibri" pitchFamily="34" charset="-122"/>
+                <a:cs typeface="Calibri" pitchFamily="34" charset="-120"/>
               </a:rPr>
               <a:t>31 Dic 2028</a:t>
             </a:r>
@@ -16992,6 +17545,9 @@
                 <a:solidFill>
                   <a:schemeClr val="tx2"/>
                 </a:solidFill>
+                <a:latin typeface="Calibri" pitchFamily="34" charset="0"/>
+                <a:ea typeface="Calibri" pitchFamily="34" charset="-122"/>
+                <a:cs typeface="Calibri" pitchFamily="34" charset="-120"/>
               </a:rPr>
               <a:t>Lote · </a:t>
             </a:r>
@@ -17003,6 +17559,9 @@
                 <a:solidFill>
                   <a:srgbClr val="475569"/>
                 </a:solidFill>
+                <a:latin typeface="Calibri" pitchFamily="34" charset="0"/>
+                <a:ea typeface="Calibri" pitchFamily="34" charset="-122"/>
+                <a:cs typeface="Calibri" pitchFamily="34" charset="-120"/>
               </a:rPr>
               <a:t>trazabilidad de producción</a:t>
             </a:r>
@@ -17126,6 +17685,9 @@
                 <a:solidFill>
                   <a:schemeClr val="tx2"/>
                 </a:solidFill>
+                <a:latin typeface="Calibri" pitchFamily="34" charset="0"/>
+                <a:ea typeface="Calibri" pitchFamily="34" charset="-122"/>
+                <a:cs typeface="Calibri" pitchFamily="34" charset="-120"/>
               </a:rPr>
               <a:t>Serie · </a:t>
             </a:r>
@@ -17137,6 +17699,9 @@
                 <a:solidFill>
                   <a:srgbClr val="475569"/>
                 </a:solidFill>
+                <a:latin typeface="Calibri" pitchFamily="34" charset="0"/>
+                <a:ea typeface="Calibri" pitchFamily="34" charset="-122"/>
+                <a:cs typeface="Calibri" pitchFamily="34" charset="-120"/>
               </a:rPr>
               <a:t>autenticación unitaria anti-falsificación</a:t>
             </a:r>
@@ -17173,6 +17738,9 @@
                 <a:solidFill>
                   <a:srgbClr val="64748B"/>
                 </a:solidFill>
+                <a:latin typeface="Calibri" pitchFamily="34" charset="0"/>
+                <a:ea typeface="Calibri" pitchFamily="34" charset="-122"/>
+                <a:cs typeface="Calibri" pitchFamily="34" charset="-120"/>
               </a:rPr>
               <a:t>ESTRUCTURA GS1 DIGITAL LINK</a:t>
             </a:r>
@@ -17380,6 +17948,9 @@
                 <a:solidFill>
                   <a:schemeClr val="accent3"/>
                 </a:solidFill>
+                <a:latin typeface="Calibri" pitchFamily="34" charset="0"/>
+                <a:ea typeface="Calibri" pitchFamily="34" charset="-122"/>
+                <a:cs typeface="Calibri" pitchFamily="34" charset="-120"/>
               </a:rPr>
               <a:t>● Dominio web     </a:t>
             </a:r>
@@ -17391,6 +17962,9 @@
                 <a:solidFill>
                   <a:schemeClr val="accent2"/>
                 </a:solidFill>
+                <a:latin typeface="Calibri" pitchFamily="34" charset="0"/>
+                <a:ea typeface="Calibri" pitchFamily="34" charset="-122"/>
+                <a:cs typeface="Calibri" pitchFamily="34" charset="-120"/>
               </a:rPr>
               <a:t>● Identificador de aplicación (AI)     </a:t>
             </a:r>
@@ -17402,6 +17976,9 @@
                 <a:solidFill>
                   <a:schemeClr val="tx2"/>
                 </a:solidFill>
+                <a:latin typeface="Calibri" pitchFamily="34" charset="0"/>
+                <a:ea typeface="Calibri" pitchFamily="34" charset="-122"/>
+                <a:cs typeface="Calibri" pitchFamily="34" charset="-120"/>
               </a:rPr>
               <a:t>● GTIN / Lote / Vencimiento</a:t>
             </a:r>
@@ -17508,6 +18085,9 @@
                 <a:solidFill>
                   <a:schemeClr val="accent2"/>
                 </a:solidFill>
+                <a:latin typeface="Calibri" pitchFamily="34" charset="0"/>
+                <a:ea typeface="Calibri" pitchFamily="34" charset="-122"/>
+                <a:cs typeface="Calibri" pitchFamily="34" charset="-120"/>
               </a:rPr>
               <a:t>EVIDENCIA INTERNACIONAL · GS1 HEALTHCARE</a:t>
             </a:r>
@@ -17546,9 +18126,9 @@
                 <a:solidFill>
                   <a:schemeClr val="tx2"/>
                 </a:solidFill>
-                <a:latin typeface="+mj-lt" pitchFamily="34" charset="0"/>
-                <a:ea typeface="+mj-lt" pitchFamily="34" charset="-122"/>
-                <a:cs typeface="+mj-lt" pitchFamily="34" charset="-120"/>
+                <a:latin typeface="Arial" pitchFamily="34" charset="0"/>
+                <a:ea typeface="Arial" pitchFamily="34" charset="-122"/>
+                <a:cs typeface="Arial" pitchFamily="34" charset="-120"/>
               </a:rPr>
               <a:t>Casos de éxito: </a:t>
             </a:r>
@@ -17560,9 +18140,9 @@
                 <a:solidFill>
                   <a:schemeClr val="accent1"/>
                 </a:solidFill>
-                <a:latin typeface="+mj-lt" pitchFamily="34" charset="0"/>
-                <a:ea typeface="+mj-lt" pitchFamily="34" charset="-122"/>
-                <a:cs typeface="+mj-lt" pitchFamily="34" charset="-120"/>
+                <a:latin typeface="Arial" pitchFamily="34" charset="0"/>
+                <a:ea typeface="Arial" pitchFamily="34" charset="-122"/>
+                <a:cs typeface="Arial" pitchFamily="34" charset="-120"/>
               </a:rPr>
               <a:t>impacto real en hospitales y regulación</a:t>
             </a:r>
@@ -17615,7 +18195,7 @@
             <a:off x="457200" y="1190625"/>
             <a:ext cx="3600450" cy="1238250"/>
           </a:xfrm>
-          <a:prstGeom prst="round2SameRect">
+          <a:prstGeom prst="roundRect">
             <a:avLst>
               <a:gd name="adj" fmla="val 13292"/>
             </a:avLst>
@@ -17626,9 +18206,29 @@
           <a:ln/>
         </p:spPr>
       </p:sp>
+      <p:sp>
+        <p:nvSpPr>
+          <p:cNvPr id="6" name="FOTO (reemplazar): Reino Unido · NHS (base)"/>
+          <p:cNvSpPr/>
+          <p:nvPr/>
+        </p:nvSpPr>
+        <p:spPr>
+          <a:xfrm>
+            <a:off x="457200" y="1809750"/>
+            <a:ext cx="3600450" cy="619125"/>
+          </a:xfrm>
+          <a:prstGeom prst="rect">
+            <a:avLst/>
+          </a:prstGeom>
+          <a:solidFill>
+            <a:srgbClr val="002C6C"/>
+          </a:solidFill>
+          <a:ln/>
+        </p:spPr>
+      </p:sp>
       <p:pic>
         <p:nvPicPr>
-          <p:cNvPr id="6" name="Image 0" descr="Icono Hospital">    </p:cNvPr>
+          <p:cNvPr id="7" name="Image 0" descr="Icono Hospital">    </p:cNvPr>
           <p:cNvPicPr>
             <a:picLocks noChangeAspect="1"/>
           </p:cNvPicPr>
@@ -17652,7 +18252,7 @@
       </p:pic>
       <p:sp>
         <p:nvSpPr>
-          <p:cNvPr id="7" name="Text 4"/>
+          <p:cNvPr id="8" name="Text 5"/>
           <p:cNvSpPr txBox="1"/>
           <p:nvPr/>
         </p:nvSpPr>
@@ -17679,6 +18279,9 @@
                 <a:solidFill>
                   <a:schemeClr val="bg1"/>
                 </a:solidFill>
+                <a:latin typeface="Calibri" pitchFamily="34" charset="0"/>
+                <a:ea typeface="Calibri" pitchFamily="34" charset="-122"/>
+                <a:cs typeface="Calibri" pitchFamily="34" charset="-120"/>
               </a:rPr>
               <a:t>Insertar foto</a:t>
             </a:r>
@@ -17688,7 +18291,7 @@
       </p:sp>
       <p:sp>
         <p:nvSpPr>
-          <p:cNvPr id="8" name="Text 5"/>
+          <p:cNvPr id="9" name="Text 6"/>
           <p:cNvSpPr txBox="1"/>
           <p:nvPr/>
         </p:nvSpPr>
@@ -17715,9 +18318,9 @@
                 <a:solidFill>
                   <a:schemeClr val="tx2"/>
                 </a:solidFill>
-                <a:latin typeface="+mj-lt" pitchFamily="34" charset="0"/>
-                <a:ea typeface="+mj-lt" pitchFamily="34" charset="-122"/>
-                <a:cs typeface="+mj-lt" pitchFamily="34" charset="-120"/>
+                <a:latin typeface="Arial" pitchFamily="34" charset="0"/>
+                <a:ea typeface="Arial" pitchFamily="34" charset="-122"/>
+                <a:cs typeface="Arial" pitchFamily="34" charset="-120"/>
               </a:rPr>
               <a:t>Reino Unido · NHS</a:t>
             </a:r>
@@ -17727,7 +18330,7 @@
       </p:sp>
       <p:sp>
         <p:nvSpPr>
-          <p:cNvPr id="9" name="Text 6"/>
+          <p:cNvPr id="10" name="Text 7"/>
           <p:cNvSpPr txBox="1"/>
           <p:nvPr/>
         </p:nvSpPr>
@@ -17754,6 +18357,9 @@
                 <a:solidFill>
                   <a:schemeClr val="accent1"/>
                 </a:solidFill>
+                <a:latin typeface="Calibri" pitchFamily="34" charset="0"/>
+                <a:ea typeface="Calibri" pitchFamily="34" charset="-122"/>
+                <a:cs typeface="Calibri" pitchFamily="34" charset="-120"/>
               </a:rPr>
               <a:t>Proyecto Scan4Safety</a:t>
             </a:r>
@@ -17763,7 +18369,7 @@
       </p:sp>
       <p:sp>
         <p:nvSpPr>
-          <p:cNvPr id="10" name="Text 7"/>
+          <p:cNvPr id="11" name="Text 8"/>
           <p:cNvSpPr txBox="1"/>
           <p:nvPr/>
         </p:nvSpPr>
@@ -17802,7 +18408,7 @@
       </p:sp>
       <p:sp>
         <p:nvSpPr>
-          <p:cNvPr id="11" name="Text 8"/>
+          <p:cNvPr id="12" name="Text 9"/>
           <p:cNvSpPr txBox="1"/>
           <p:nvPr/>
         </p:nvSpPr>
@@ -17829,6 +18435,9 @@
                 <a:solidFill>
                   <a:srgbClr val="475569"/>
                 </a:solidFill>
+                <a:latin typeface="Calibri" pitchFamily="34" charset="0"/>
+                <a:ea typeface="Calibri" pitchFamily="34" charset="-122"/>
+                <a:cs typeface="Calibri" pitchFamily="34" charset="-120"/>
               </a:rPr>
               <a:t>Adopción en hospitales públicos británicos.</a:t>
             </a:r>
@@ -17838,7 +18447,7 @@
       </p:sp>
       <p:sp>
         <p:nvSpPr>
-          <p:cNvPr id="12" name="Tarjeta"/>
+          <p:cNvPr id="13" name="Tarjeta"/>
           <p:cNvSpPr/>
           <p:nvPr/>
         </p:nvSpPr>
@@ -17872,7 +18481,7 @@
       </p:sp>
       <p:sp>
         <p:nvSpPr>
-          <p:cNvPr id="13" name="FOTO (reemplazar): Argentina (ANMAT) y Brasil"/>
+          <p:cNvPr id="14" name="FOTO (reemplazar): Argentina (ANMAT) y Brasil"/>
           <p:cNvSpPr/>
           <p:nvPr/>
         </p:nvSpPr>
@@ -17881,7 +18490,7 @@
             <a:off x="4286250" y="1190625"/>
             <a:ext cx="3600450" cy="1238250"/>
           </a:xfrm>
-          <a:prstGeom prst="round2SameRect">
+          <a:prstGeom prst="roundRect">
             <a:avLst>
               <a:gd name="adj" fmla="val 13292"/>
             </a:avLst>
@@ -17892,9 +18501,29 @@
           <a:ln/>
         </p:spPr>
       </p:sp>
+      <p:sp>
+        <p:nvSpPr>
+          <p:cNvPr id="15" name="FOTO (reemplazar): Argentina (ANMAT) y Brasil (base)"/>
+          <p:cNvSpPr/>
+          <p:nvPr/>
+        </p:nvSpPr>
+        <p:spPr>
+          <a:xfrm>
+            <a:off x="4286250" y="1809750"/>
+            <a:ext cx="3600450" cy="619125"/>
+          </a:xfrm>
+          <a:prstGeom prst="rect">
+            <a:avLst/>
+          </a:prstGeom>
+          <a:solidFill>
+            <a:srgbClr val="0097B2"/>
+          </a:solidFill>
+          <a:ln/>
+        </p:spPr>
+      </p:sp>
       <p:pic>
         <p:nvPicPr>
-          <p:cNvPr id="14" name="Image 1" descr="Icono Pill">    </p:cNvPr>
+          <p:cNvPr id="16" name="Image 1" descr="Icono Pill">    </p:cNvPr>
           <p:cNvPicPr>
             <a:picLocks noChangeAspect="1"/>
           </p:cNvPicPr>
@@ -17918,7 +18547,7 @@
       </p:pic>
       <p:sp>
         <p:nvSpPr>
-          <p:cNvPr id="15" name="Text 11"/>
+          <p:cNvPr id="17" name="Text 13"/>
           <p:cNvSpPr txBox="1"/>
           <p:nvPr/>
         </p:nvSpPr>
@@ -17945,6 +18574,9 @@
                 <a:solidFill>
                   <a:schemeClr val="bg1"/>
                 </a:solidFill>
+                <a:latin typeface="Calibri" pitchFamily="34" charset="0"/>
+                <a:ea typeface="Calibri" pitchFamily="34" charset="-122"/>
+                <a:cs typeface="Calibri" pitchFamily="34" charset="-120"/>
               </a:rPr>
               <a:t>Insertar foto</a:t>
             </a:r>
@@ -17954,7 +18586,7 @@
       </p:sp>
       <p:sp>
         <p:nvSpPr>
-          <p:cNvPr id="16" name="Text 12"/>
+          <p:cNvPr id="18" name="Text 14"/>
           <p:cNvSpPr txBox="1"/>
           <p:nvPr/>
         </p:nvSpPr>
@@ -17981,9 +18613,9 @@
                 <a:solidFill>
                   <a:schemeClr val="tx2"/>
                 </a:solidFill>
-                <a:latin typeface="+mj-lt" pitchFamily="34" charset="0"/>
-                <a:ea typeface="+mj-lt" pitchFamily="34" charset="-122"/>
-                <a:cs typeface="+mj-lt" pitchFamily="34" charset="-120"/>
+                <a:latin typeface="Arial" pitchFamily="34" charset="0"/>
+                <a:ea typeface="Arial" pitchFamily="34" charset="-122"/>
+                <a:cs typeface="Arial" pitchFamily="34" charset="-120"/>
               </a:rPr>
               <a:t>Argentina (ANMAT) y Brasil</a:t>
             </a:r>
@@ -17993,7 +18625,7 @@
       </p:sp>
       <p:sp>
         <p:nvSpPr>
-          <p:cNvPr id="17" name="Text 13"/>
+          <p:cNvPr id="19" name="Text 15"/>
           <p:cNvSpPr txBox="1"/>
           <p:nvPr/>
         </p:nvSpPr>
@@ -18020,6 +18652,9 @@
                 <a:solidFill>
                   <a:schemeClr val="accent1"/>
                 </a:solidFill>
+                <a:latin typeface="Calibri" pitchFamily="34" charset="0"/>
+                <a:ea typeface="Calibri" pitchFamily="34" charset="-122"/>
+                <a:cs typeface="Calibri" pitchFamily="34" charset="-120"/>
               </a:rPr>
               <a:t>ANVISA · Sírio-Libanês · Einstein</a:t>
             </a:r>
@@ -18029,7 +18664,7 @@
       </p:sp>
       <p:sp>
         <p:nvSpPr>
-          <p:cNvPr id="18" name="Text 14"/>
+          <p:cNvPr id="20" name="Text 16"/>
           <p:cNvSpPr txBox="1"/>
           <p:nvPr/>
         </p:nvSpPr>
@@ -18068,7 +18703,7 @@
       </p:sp>
       <p:sp>
         <p:nvSpPr>
-          <p:cNvPr id="19" name="Text 15"/>
+          <p:cNvPr id="21" name="Text 17"/>
           <p:cNvSpPr txBox="1"/>
           <p:nvPr/>
         </p:nvSpPr>
@@ -18095,6 +18730,9 @@
                 <a:solidFill>
                   <a:srgbClr val="475569"/>
                 </a:solidFill>
+                <a:latin typeface="Calibri" pitchFamily="34" charset="0"/>
+                <a:ea typeface="Calibri" pitchFamily="34" charset="-122"/>
+                <a:cs typeface="Calibri" pitchFamily="34" charset="-120"/>
               </a:rPr>
               <a:t>Trazabilidad unitaria de medicamentos oncológicos y de alto costo.</a:t>
             </a:r>
@@ -18104,7 +18742,7 @@
       </p:sp>
       <p:sp>
         <p:nvSpPr>
-          <p:cNvPr id="20" name="Tarjeta"/>
+          <p:cNvPr id="22" name="Tarjeta"/>
           <p:cNvSpPr/>
           <p:nvPr/>
         </p:nvSpPr>
@@ -18138,7 +18776,7 @@
       </p:sp>
       <p:sp>
         <p:nvSpPr>
-          <p:cNvPr id="21" name="FOTO (reemplazar): Unión Europea (FMD) y Colombia"/>
+          <p:cNvPr id="23" name="FOTO (reemplazar): Unión Europea (FMD) y Colombia"/>
           <p:cNvSpPr/>
           <p:nvPr/>
         </p:nvSpPr>
@@ -18147,7 +18785,7 @@
             <a:off x="8115300" y="1190625"/>
             <a:ext cx="3600450" cy="1238250"/>
           </a:xfrm>
-          <a:prstGeom prst="round2SameRect">
+          <a:prstGeom prst="roundRect">
             <a:avLst>
               <a:gd name="adj" fmla="val 13292"/>
             </a:avLst>
@@ -18158,9 +18796,29 @@
           <a:ln/>
         </p:spPr>
       </p:sp>
+      <p:sp>
+        <p:nvSpPr>
+          <p:cNvPr id="24" name="FOTO (reemplazar): Unión Europea (FMD) y Colombia (base)"/>
+          <p:cNvSpPr/>
+          <p:nvPr/>
+        </p:nvSpPr>
+        <p:spPr>
+          <a:xfrm>
+            <a:off x="8115300" y="1809750"/>
+            <a:ext cx="3600450" cy="619125"/>
+          </a:xfrm>
+          <a:prstGeom prst="rect">
+            <a:avLst/>
+          </a:prstGeom>
+          <a:solidFill>
+            <a:srgbClr val="00A79D"/>
+          </a:solidFill>
+          <a:ln/>
+        </p:spPr>
+      </p:sp>
       <p:pic>
         <p:nvPicPr>
-          <p:cNvPr id="22" name="Image 2" descr="Icono ScanLine">    </p:cNvPr>
+          <p:cNvPr id="25" name="Image 2" descr="Icono ScanLine">    </p:cNvPr>
           <p:cNvPicPr>
             <a:picLocks noChangeAspect="1"/>
           </p:cNvPicPr>
@@ -18184,7 +18842,7 @@
       </p:pic>
       <p:sp>
         <p:nvSpPr>
-          <p:cNvPr id="23" name="Text 18"/>
+          <p:cNvPr id="26" name="Text 21"/>
           <p:cNvSpPr txBox="1"/>
           <p:nvPr/>
         </p:nvSpPr>
@@ -18211,6 +18869,9 @@
                 <a:solidFill>
                   <a:schemeClr val="bg1"/>
                 </a:solidFill>
+                <a:latin typeface="Calibri" pitchFamily="34" charset="0"/>
+                <a:ea typeface="Calibri" pitchFamily="34" charset="-122"/>
+                <a:cs typeface="Calibri" pitchFamily="34" charset="-120"/>
               </a:rPr>
               <a:t>Insertar foto</a:t>
             </a:r>
@@ -18220,7 +18881,7 @@
       </p:sp>
       <p:sp>
         <p:nvSpPr>
-          <p:cNvPr id="24" name="Text 19"/>
+          <p:cNvPr id="27" name="Text 22"/>
           <p:cNvSpPr txBox="1"/>
           <p:nvPr/>
         </p:nvSpPr>
@@ -18247,9 +18908,9 @@
                 <a:solidFill>
                   <a:schemeClr val="tx2"/>
                 </a:solidFill>
-                <a:latin typeface="+mj-lt" pitchFamily="34" charset="0"/>
-                <a:ea typeface="+mj-lt" pitchFamily="34" charset="-122"/>
-                <a:cs typeface="+mj-lt" pitchFamily="34" charset="-120"/>
+                <a:latin typeface="Arial" pitchFamily="34" charset="0"/>
+                <a:ea typeface="Arial" pitchFamily="34" charset="-122"/>
+                <a:cs typeface="Arial" pitchFamily="34" charset="-120"/>
               </a:rPr>
               <a:t>Unión Europea (FMD) y Colombia</a:t>
             </a:r>
@@ -18259,7 +18920,7 @@
       </p:sp>
       <p:sp>
         <p:nvSpPr>
-          <p:cNvPr id="25" name="Text 20"/>
+          <p:cNvPr id="28" name="Text 23"/>
           <p:cNvSpPr txBox="1"/>
           <p:nvPr/>
         </p:nvSpPr>
@@ -18286,6 +18947,9 @@
                 <a:solidFill>
                   <a:schemeClr val="accent1"/>
                 </a:solidFill>
+                <a:latin typeface="Calibri" pitchFamily="34" charset="0"/>
+                <a:ea typeface="Calibri" pitchFamily="34" charset="-122"/>
+                <a:cs typeface="Calibri" pitchFamily="34" charset="-120"/>
               </a:rPr>
               <a:t>Sincronización GDSN</a:t>
             </a:r>
@@ -18295,7 +18959,7 @@
       </p:sp>
       <p:sp>
         <p:nvSpPr>
-          <p:cNvPr id="26" name="Text 21"/>
+          <p:cNvPr id="29" name="Text 24"/>
           <p:cNvSpPr txBox="1"/>
           <p:nvPr/>
         </p:nvSpPr>
@@ -18334,7 +18998,7 @@
       </p:sp>
       <p:sp>
         <p:nvSpPr>
-          <p:cNvPr id="27" name="Text 22"/>
+          <p:cNvPr id="30" name="Text 25"/>
           <p:cNvSpPr txBox="1"/>
           <p:nvPr/>
         </p:nvSpPr>
@@ -18361,6 +19025,9 @@
                 <a:solidFill>
                   <a:srgbClr val="475569"/>
                 </a:solidFill>
+                <a:latin typeface="Calibri" pitchFamily="34" charset="0"/>
+                <a:ea typeface="Calibri" pitchFamily="34" charset="-122"/>
+                <a:cs typeface="Calibri" pitchFamily="34" charset="-120"/>
               </a:rPr>
               <a:t>Verificación serializada punto a punto y prospecto electrónico (e-PIL) mediante GS1 Digital Link.</a:t>
             </a:r>
@@ -18370,7 +19037,7 @@
       </p:sp>
       <p:sp>
         <p:nvSpPr>
-          <p:cNvPr id="28" name="Tarjeta"/>
+          <p:cNvPr id="31" name="Tarjeta"/>
           <p:cNvSpPr/>
           <p:nvPr/>
         </p:nvSpPr>
@@ -18397,7 +19064,7 @@
       </p:sp>
       <p:sp>
         <p:nvSpPr>
-          <p:cNvPr id="29" name="Text 24"/>
+          <p:cNvPr id="32" name="Text 27"/>
           <p:cNvSpPr txBox="1"/>
           <p:nvPr/>
         </p:nvSpPr>
@@ -18424,9 +19091,9 @@
                 <a:solidFill>
                   <a:schemeClr val="accent2"/>
                 </a:solidFill>
-                <a:latin typeface="+mj-lt" pitchFamily="34" charset="0"/>
-                <a:ea typeface="+mj-lt" pitchFamily="34" charset="-122"/>
-                <a:cs typeface="+mj-lt" pitchFamily="34" charset="-120"/>
+                <a:latin typeface="Arial" pitchFamily="34" charset="0"/>
+                <a:ea typeface="Arial" pitchFamily="34" charset="-122"/>
+                <a:cs typeface="Arial" pitchFamily="34" charset="-120"/>
               </a:rPr>
               <a:t>76%</a:t>
             </a:r>
@@ -18436,7 +19103,7 @@
       </p:sp>
       <p:sp>
         <p:nvSpPr>
-          <p:cNvPr id="30" name="Text 25"/>
+          <p:cNvPr id="33" name="Text 28"/>
           <p:cNvSpPr txBox="1"/>
           <p:nvPr/>
         </p:nvSpPr>
@@ -18463,6 +19130,9 @@
                 <a:solidFill>
                   <a:srgbClr val="475569"/>
                 </a:solidFill>
+                <a:latin typeface="Calibri" pitchFamily="34" charset="0"/>
+                <a:ea typeface="Calibri" pitchFamily="34" charset="-122"/>
+                <a:cs typeface="Calibri" pitchFamily="34" charset="-120"/>
               </a:rPr>
               <a:t>menos errores de medicación</a:t>
             </a:r>
@@ -18472,7 +19142,7 @@
       </p:sp>
       <p:sp>
         <p:nvSpPr>
-          <p:cNvPr id="31" name="Tarjeta"/>
+          <p:cNvPr id="34" name="Tarjeta"/>
           <p:cNvSpPr/>
           <p:nvPr/>
         </p:nvSpPr>
@@ -18499,7 +19169,7 @@
       </p:sp>
       <p:sp>
         <p:nvSpPr>
-          <p:cNvPr id="32" name="Text 27"/>
+          <p:cNvPr id="35" name="Text 30"/>
           <p:cNvSpPr txBox="1"/>
           <p:nvPr/>
         </p:nvSpPr>
@@ -18526,9 +19196,9 @@
                 <a:solidFill>
                   <a:schemeClr val="accent2"/>
                 </a:solidFill>
-                <a:latin typeface="+mj-lt" pitchFamily="34" charset="0"/>
-                <a:ea typeface="+mj-lt" pitchFamily="34" charset="-122"/>
-                <a:cs typeface="+mj-lt" pitchFamily="34" charset="-120"/>
+                <a:latin typeface="Arial" pitchFamily="34" charset="0"/>
+                <a:ea typeface="Arial" pitchFamily="34" charset="-122"/>
+                <a:cs typeface="Arial" pitchFamily="34" charset="-120"/>
               </a:rPr>
               <a:t>+140,000</a:t>
             </a:r>
@@ -18538,7 +19208,7 @@
       </p:sp>
       <p:sp>
         <p:nvSpPr>
-          <p:cNvPr id="33" name="Text 28"/>
+          <p:cNvPr id="36" name="Text 31"/>
           <p:cNvSpPr txBox="1"/>
           <p:nvPr/>
         </p:nvSpPr>
@@ -18565,6 +19235,9 @@
                 <a:solidFill>
                   <a:srgbClr val="475569"/>
                 </a:solidFill>
+                <a:latin typeface="Calibri" pitchFamily="34" charset="0"/>
+                <a:ea typeface="Calibri" pitchFamily="34" charset="-122"/>
+                <a:cs typeface="Calibri" pitchFamily="34" charset="-120"/>
               </a:rPr>
               <a:t>horas clínicas liberadas</a:t>
             </a:r>
@@ -18574,7 +19247,7 @@
       </p:sp>
       <p:sp>
         <p:nvSpPr>
-          <p:cNvPr id="34" name="Tarjeta"/>
+          <p:cNvPr id="37" name="Tarjeta"/>
           <p:cNvSpPr/>
           <p:nvPr/>
         </p:nvSpPr>
@@ -18601,7 +19274,7 @@
       </p:sp>
       <p:sp>
         <p:nvSpPr>
-          <p:cNvPr id="35" name="Text 30"/>
+          <p:cNvPr id="38" name="Text 33"/>
           <p:cNvSpPr txBox="1"/>
           <p:nvPr/>
         </p:nvSpPr>
@@ -18628,9 +19301,9 @@
                 <a:solidFill>
                   <a:schemeClr val="accent2"/>
                 </a:solidFill>
-                <a:latin typeface="+mj-lt" pitchFamily="34" charset="0"/>
-                <a:ea typeface="+mj-lt" pitchFamily="34" charset="-122"/>
-                <a:cs typeface="+mj-lt" pitchFamily="34" charset="-120"/>
+                <a:latin typeface="Arial" pitchFamily="34" charset="0"/>
+                <a:ea typeface="Arial" pitchFamily="34" charset="-122"/>
+                <a:cs typeface="Arial" pitchFamily="34" charset="-120"/>
               </a:rPr>
               <a:t>&lt;30 min</a:t>
             </a:r>
@@ -18640,7 +19313,7 @@
       </p:sp>
       <p:sp>
         <p:nvSpPr>
-          <p:cNvPr id="36" name="Text 31"/>
+          <p:cNvPr id="39" name="Text 34"/>
           <p:cNvSpPr txBox="1"/>
           <p:nvPr/>
         </p:nvSpPr>
@@ -18667,6 +19340,9 @@
                 <a:solidFill>
                   <a:srgbClr val="475569"/>
                 </a:solidFill>
+                <a:latin typeface="Calibri" pitchFamily="34" charset="0"/>
+                <a:ea typeface="Calibri" pitchFamily="34" charset="-122"/>
+                <a:cs typeface="Calibri" pitchFamily="34" charset="-120"/>
               </a:rPr>
               <a:t>para ubicar lotes (recall)</a:t>
             </a:r>
@@ -18676,7 +19352,7 @@
       </p:sp>
       <p:sp>
         <p:nvSpPr>
-          <p:cNvPr id="37" name="Text 32"/>
+          <p:cNvPr id="40" name="Text 35"/>
           <p:cNvSpPr txBox="1"/>
           <p:nvPr/>
         </p:nvSpPr>
@@ -18703,9 +19379,9 @@
                 <a:solidFill>
                   <a:schemeClr val="accent2"/>
                 </a:solidFill>
-                <a:latin typeface="+mj-lt" pitchFamily="34" charset="0"/>
-                <a:ea typeface="+mj-lt" pitchFamily="34" charset="-122"/>
-                <a:cs typeface="+mj-lt" pitchFamily="34" charset="-120"/>
+                <a:latin typeface="Arial" pitchFamily="34" charset="0"/>
+                <a:ea typeface="Arial" pitchFamily="34" charset="-122"/>
+                <a:cs typeface="Arial" pitchFamily="34" charset="-120"/>
               </a:rPr>
               <a:t>99.9%</a:t>
             </a:r>
@@ -18715,7 +19391,7 @@
       </p:sp>
       <p:sp>
         <p:nvSpPr>
-          <p:cNvPr id="38" name="Text 33"/>
+          <p:cNvPr id="41" name="Text 36"/>
           <p:cNvSpPr txBox="1"/>
           <p:nvPr/>
         </p:nvSpPr>
@@ -18742,6 +19418,9 @@
                 <a:solidFill>
                   <a:srgbClr val="475569"/>
                 </a:solidFill>
+                <a:latin typeface="Calibri" pitchFamily="34" charset="0"/>
+                <a:ea typeface="Calibri" pitchFamily="34" charset="-122"/>
+                <a:cs typeface="Calibri" pitchFamily="34" charset="-120"/>
               </a:rPr>
               <a:t>de precisión en dispensación intrahospitalaria</a:t>
             </a:r>
@@ -18751,7 +19430,7 @@
       </p:sp>
       <p:sp>
         <p:nvSpPr>
-          <p:cNvPr id="39" name="Tarjeta"/>
+          <p:cNvPr id="42" name="Tarjeta"/>
           <p:cNvSpPr/>
           <p:nvPr/>
         </p:nvSpPr>
@@ -18778,7 +19457,7 @@
       </p:sp>
       <p:pic>
         <p:nvPicPr>
-          <p:cNvPr id="40" name="Image 3" descr="Icono ShieldCheck">    </p:cNvPr>
+          <p:cNvPr id="43" name="Image 3" descr="Icono ShieldCheck">    </p:cNvPr>
           <p:cNvPicPr>
             <a:picLocks noChangeAspect="1"/>
           </p:cNvPicPr>
@@ -18802,7 +19481,7 @@
       </p:pic>
       <p:sp>
         <p:nvSpPr>
-          <p:cNvPr id="41" name="Text 35"/>
+          <p:cNvPr id="44" name="Text 38"/>
           <p:cNvSpPr txBox="1"/>
           <p:nvPr/>
         </p:nvSpPr>
@@ -18829,6 +19508,9 @@
                 <a:solidFill>
                   <a:srgbClr val="047857"/>
                 </a:solidFill>
+                <a:latin typeface="Calibri" pitchFamily="34" charset="0"/>
+                <a:ea typeface="Calibri" pitchFamily="34" charset="-122"/>
+                <a:cs typeface="Calibri" pitchFamily="34" charset="-120"/>
               </a:rPr>
               <a:t>Erradicación de fármacos falsificados en el canal formal.</a:t>
             </a:r>
@@ -18838,7 +19520,7 @@
       </p:sp>
       <p:sp>
         <p:nvSpPr>
-          <p:cNvPr id="42" name="Text 36"/>
+          <p:cNvPr id="45" name="Text 39"/>
           <p:cNvSpPr txBox="1"/>
           <p:nvPr/>
         </p:nvSpPr>
@@ -18865,9 +19547,9 @@
                 <a:solidFill>
                   <a:schemeClr val="accent2"/>
                 </a:solidFill>
-                <a:latin typeface="+mj-lt" pitchFamily="34" charset="0"/>
-                <a:ea typeface="+mj-lt" pitchFamily="34" charset="-122"/>
-                <a:cs typeface="+mj-lt" pitchFamily="34" charset="-120"/>
+                <a:latin typeface="Arial" pitchFamily="34" charset="0"/>
+                <a:ea typeface="Arial" pitchFamily="34" charset="-122"/>
+                <a:cs typeface="Arial" pitchFamily="34" charset="-120"/>
               </a:rPr>
               <a:t>−40%</a:t>
             </a:r>
@@ -18877,7 +19559,7 @@
       </p:sp>
       <p:sp>
         <p:nvSpPr>
-          <p:cNvPr id="43" name="Text 37"/>
+          <p:cNvPr id="46" name="Text 40"/>
           <p:cNvSpPr txBox="1"/>
           <p:nvPr/>
         </p:nvSpPr>
@@ -18904,6 +19586,9 @@
                 <a:solidFill>
                   <a:srgbClr val="475569"/>
                 </a:solidFill>
+                <a:latin typeface="Calibri" pitchFamily="34" charset="0"/>
+                <a:ea typeface="Calibri" pitchFamily="34" charset="-122"/>
+                <a:cs typeface="Calibri" pitchFamily="34" charset="-120"/>
               </a:rPr>
               <a:t>de errores de catalogación entre laboratorios y clínicas</a:t>
             </a:r>

</xml_diff>